<commit_message>
docs: resync figure numbering from Drive decks (2026-10-02)
Decks changed in Drive: Fig MyM, Fig R2.
- Fig MyM (16 slides): caption-only edits - dropped the stale
  "Fig. M15." prefix from slides 15 (coocurrencia_motivos) and 16
  (puffin_prediccion_esquema). No content moved; numbering unchanged.
- Fig R2 (6 slides): slide 3 image replaced by the current
  summary_endo.jpg (adds "Promotor unidireccional" row). Still part of
  summary_features_secuencia (Fig. R2.2); numbering unchanged.

Fig R1/R3 re-exported with byte-level differences only (media
re-encoding); slide text identical and no Drive edits since July, so
not committed. No mapping_figuras.csv changes, no folders renamed.

Co-Authored-By: Claude Opus 5.5 <noreply@anthropic.com>
</commit_message>
<xml_diff>
--- a/docs/Fig R2.pptx
+++ b/docs/Fig R2.pptx
@@ -993,7 +993,7 @@
   <p:cSld>
     <p:spTree>
       <p:nvGrpSpPr>
-        <p:cNvPr id="104" name="Shape 104"/>
+        <p:cNvPr id="105" name="Shape 105"/>
         <p:cNvGrpSpPr/>
         <p:nvPr/>
       </p:nvGrpSpPr>
@@ -1007,7 +1007,7 @@
       </p:grpSpPr>
       <p:sp>
         <p:nvSpPr>
-          <p:cNvPr id="105" name="Google Shape;105;g3f58eefa86d_0_96:notes"/>
+          <p:cNvPr id="106" name="Google Shape;106;g3f58eefa86d_0_96:notes"/>
           <p:cNvSpPr/>
           <p:nvPr>
             <p:ph idx="2" type="sldImg"/>
@@ -1042,7 +1042,7 @@
       </p:sp>
       <p:sp>
         <p:nvSpPr>
-          <p:cNvPr id="106" name="Google Shape;106;g3f58eefa86d_0_96:notes"/>
+          <p:cNvPr id="107" name="Google Shape;107;g3f58eefa86d_0_96:notes"/>
           <p:cNvSpPr txBox="1"/>
           <p:nvPr>
             <p:ph idx="1" type="body"/>
@@ -1092,7 +1092,7 @@
   <p:cSld>
     <p:spTree>
       <p:nvGrpSpPr>
-        <p:cNvPr id="111" name="Shape 111"/>
+        <p:cNvPr id="112" name="Shape 112"/>
         <p:cNvGrpSpPr/>
         <p:nvPr/>
       </p:nvGrpSpPr>
@@ -1106,7 +1106,7 @@
       </p:grpSpPr>
       <p:sp>
         <p:nvSpPr>
-          <p:cNvPr id="112" name="Google Shape;112;g3f58eefa86d_0_108:notes"/>
+          <p:cNvPr id="113" name="Google Shape;113;g3f58eefa86d_0_108:notes"/>
           <p:cNvSpPr/>
           <p:nvPr>
             <p:ph idx="2" type="sldImg"/>
@@ -1141,7 +1141,7 @@
       </p:sp>
       <p:sp>
         <p:nvSpPr>
-          <p:cNvPr id="113" name="Google Shape;113;g3f58eefa86d_0_108:notes"/>
+          <p:cNvPr id="114" name="Google Shape;114;g3f58eefa86d_0_108:notes"/>
           <p:cNvSpPr txBox="1"/>
           <p:nvPr>
             <p:ph idx="1" type="body"/>
@@ -1191,7 +1191,7 @@
   <p:cSld>
     <p:spTree>
       <p:nvGrpSpPr>
-        <p:cNvPr id="119" name="Shape 119"/>
+        <p:cNvPr id="120" name="Shape 120"/>
         <p:cNvGrpSpPr/>
         <p:nvPr/>
       </p:nvGrpSpPr>
@@ -1205,7 +1205,7 @@
       </p:grpSpPr>
       <p:sp>
         <p:nvSpPr>
-          <p:cNvPr id="120" name="Google Shape;120;g3f58eefa86d_0_117:notes"/>
+          <p:cNvPr id="121" name="Google Shape;121;g3f58eefa86d_0_117:notes"/>
           <p:cNvSpPr/>
           <p:nvPr>
             <p:ph idx="2" type="sldImg"/>
@@ -1240,7 +1240,7 @@
       </p:sp>
       <p:sp>
         <p:nvSpPr>
-          <p:cNvPr id="121" name="Google Shape;121;g3f58eefa86d_0_117:notes"/>
+          <p:cNvPr id="122" name="Google Shape;122;g3f58eefa86d_0_117:notes"/>
           <p:cNvSpPr txBox="1"/>
           <p:nvPr>
             <p:ph idx="1" type="body"/>
@@ -7131,13 +7131,13 @@
           <a:blip r:embed="rId3">
             <a:alphaModFix/>
           </a:blip>
-          <a:srcRect b="6350" l="0" r="0" t="8876"/>
+          <a:srcRect b="0" l="44240" r="0" t="0"/>
           <a:stretch/>
         </p:blipFill>
         <p:spPr>
           <a:xfrm>
-            <a:off x="554900" y="1387075"/>
-            <a:ext cx="7410450" cy="3116800"/>
+            <a:off x="4009000" y="1417575"/>
+            <a:ext cx="4022124" cy="3606625"/>
           </a:xfrm>
           <a:prstGeom prst="rect">
             <a:avLst/>
@@ -7256,7 +7256,7 @@
         </p:nvSpPr>
         <p:spPr>
           <a:xfrm>
-            <a:off x="4167455" y="1332088"/>
+            <a:off x="5390418" y="1417563"/>
             <a:ext cx="1005300" cy="361800"/>
           </a:xfrm>
           <a:prstGeom prst="rect">
@@ -7358,7 +7358,7 @@
         </p:nvSpPr>
         <p:spPr>
           <a:xfrm>
-            <a:off x="5376263" y="1329686"/>
+            <a:off x="6400457" y="1417586"/>
             <a:ext cx="1005300" cy="361800"/>
           </a:xfrm>
           <a:prstGeom prst="rect">
@@ -7462,7 +7462,7 @@
         </p:nvSpPr>
         <p:spPr>
           <a:xfrm>
-            <a:off x="4360229" y="4442778"/>
+            <a:off x="4675379" y="4814203"/>
             <a:ext cx="2601600" cy="276900"/>
           </a:xfrm>
           <a:prstGeom prst="rect">
@@ -7522,7 +7522,7 @@
         </p:blipFill>
         <p:spPr>
           <a:xfrm>
-            <a:off x="4042753" y="4313375"/>
+            <a:off x="4312857" y="4652550"/>
             <a:ext cx="3160425" cy="161650"/>
           </a:xfrm>
           <a:prstGeom prst="rect">
@@ -7698,7 +7698,7 @@
         </p:nvSpPr>
         <p:spPr>
           <a:xfrm>
-            <a:off x="742160" y="2839130"/>
+            <a:off x="730910" y="3079233"/>
             <a:ext cx="3219600" cy="215400"/>
           </a:xfrm>
           <a:prstGeom prst="rect">
@@ -7750,7 +7750,7 @@
         </p:nvSpPr>
         <p:spPr>
           <a:xfrm>
-            <a:off x="1142751" y="3087850"/>
+            <a:off x="1131501" y="3327953"/>
             <a:ext cx="2738700" cy="215400"/>
           </a:xfrm>
           <a:prstGeom prst="rect">
@@ -7802,7 +7802,7 @@
         </p:nvSpPr>
         <p:spPr>
           <a:xfrm>
-            <a:off x="1343729" y="3336575"/>
+            <a:off x="1332479" y="3576678"/>
             <a:ext cx="1876800" cy="215400"/>
           </a:xfrm>
           <a:prstGeom prst="rect">
@@ -7854,8 +7854,8 @@
         </p:nvSpPr>
         <p:spPr>
           <a:xfrm>
-            <a:off x="888994" y="3574588"/>
-            <a:ext cx="3219600" cy="215400"/>
+            <a:off x="877750" y="3814700"/>
+            <a:ext cx="2992500" cy="215400"/>
           </a:xfrm>
           <a:prstGeom prst="rect">
             <a:avLst/>
@@ -7906,8 +7906,8 @@
         </p:nvSpPr>
         <p:spPr>
           <a:xfrm>
-            <a:off x="1266142" y="3812606"/>
-            <a:ext cx="3219600" cy="215400"/>
+            <a:off x="1254898" y="4052700"/>
+            <a:ext cx="2314800" cy="215400"/>
           </a:xfrm>
           <a:prstGeom prst="rect">
             <a:avLst/>
@@ -7958,7 +7958,7 @@
         </p:nvSpPr>
         <p:spPr>
           <a:xfrm>
-            <a:off x="1065375" y="4039925"/>
+            <a:off x="1111750" y="4327128"/>
             <a:ext cx="2457900" cy="215400"/>
           </a:xfrm>
           <a:prstGeom prst="rect">
@@ -7997,6 +7997,58 @@
             <a:endParaRPr>
               <a:solidFill>
                 <a:srgbClr val="24A35F"/>
+              </a:solidFill>
+            </a:endParaRPr>
+          </a:p>
+        </p:txBody>
+      </p:sp>
+      <p:sp>
+        <p:nvSpPr>
+          <p:cNvPr id="104" name="Google Shape;104;p15"/>
+          <p:cNvSpPr txBox="1"/>
+          <p:nvPr/>
+        </p:nvSpPr>
+        <p:spPr>
+          <a:xfrm>
+            <a:off x="1118194" y="2826206"/>
+            <a:ext cx="2738700" cy="215400"/>
+          </a:xfrm>
+          <a:prstGeom prst="rect">
+            <a:avLst/>
+          </a:prstGeom>
+          <a:solidFill>
+            <a:schemeClr val="lt1"/>
+          </a:solidFill>
+          <a:ln>
+            <a:noFill/>
+          </a:ln>
+        </p:spPr>
+        <p:txBody>
+          <a:bodyPr anchorCtr="0" anchor="t" bIns="0" lIns="91425" spcFirstLastPara="1" rIns="91425" wrap="square" tIns="0">
+            <a:spAutoFit/>
+          </a:bodyPr>
+          <a:lstStyle/>
+          <a:p>
+            <a:pPr indent="0" lvl="0" marL="0" rtl="0" algn="l">
+              <a:spcBef>
+                <a:spcPts val="0"/>
+              </a:spcBef>
+              <a:spcAft>
+                <a:spcPts val="0"/>
+              </a:spcAft>
+              <a:buNone/>
+            </a:pPr>
+            <a:r>
+              <a:rPr lang="es-419">
+                <a:solidFill>
+                  <a:srgbClr val="F37336"/>
+                </a:solidFill>
+              </a:rPr>
+              <a:t>Promotor unidireccional</a:t>
+            </a:r>
+            <a:endParaRPr>
+              <a:solidFill>
+                <a:srgbClr val="F37336"/>
               </a:solidFill>
             </a:endParaRPr>
           </a:p>
@@ -8015,7 +8067,7 @@
   <p:cSld>
     <p:spTree>
       <p:nvGrpSpPr>
-        <p:cNvPr id="107" name="Shape 107"/>
+        <p:cNvPr id="108" name="Shape 108"/>
         <p:cNvGrpSpPr/>
         <p:nvPr/>
       </p:nvGrpSpPr>
@@ -8029,7 +8081,7 @@
       </p:grpSpPr>
       <p:pic>
         <p:nvPicPr>
-          <p:cNvPr id="108" name="Google Shape;108;p16" title="SP2_scatter.jpg"/>
+          <p:cNvPr id="109" name="Google Shape;109;p16" title="SP2_scatter.jpg"/>
           <p:cNvPicPr preferRelativeResize="0"/>
           <p:nvPr/>
         </p:nvPicPr>
@@ -8057,7 +8109,7 @@
       </p:pic>
       <p:pic>
         <p:nvPicPr>
-          <p:cNvPr id="109" name="Google Shape;109;p16" title="NFYA_scatter.jpg"/>
+          <p:cNvPr id="110" name="Google Shape;110;p16" title="NFYA_scatter.jpg"/>
           <p:cNvPicPr preferRelativeResize="0"/>
           <p:nvPr/>
         </p:nvPicPr>
@@ -8085,7 +8137,7 @@
       </p:pic>
       <p:pic>
         <p:nvPicPr>
-          <p:cNvPr id="110" name="Google Shape;110;p16" title="SP1_scatter.jpg"/>
+          <p:cNvPr id="111" name="Google Shape;111;p16" title="SP1_scatter.jpg"/>
           <p:cNvPicPr preferRelativeResize="0"/>
           <p:nvPr/>
         </p:nvPicPr>
@@ -8124,7 +8176,7 @@
   <p:cSld>
     <p:spTree>
       <p:nvGrpSpPr>
-        <p:cNvPr id="114" name="Shape 114"/>
+        <p:cNvPr id="115" name="Shape 115"/>
         <p:cNvGrpSpPr/>
         <p:nvPr/>
       </p:nvGrpSpPr>
@@ -8138,7 +8190,7 @@
       </p:grpSpPr>
       <p:pic>
         <p:nvPicPr>
-          <p:cNvPr id="115" name="Google Shape;115;p17" title="SP1_scatter_hek.jpg"/>
+          <p:cNvPr id="116" name="Google Shape;116;p17" title="SP1_scatter_hek.jpg"/>
           <p:cNvPicPr preferRelativeResize="0"/>
           <p:nvPr/>
         </p:nvPicPr>
@@ -8166,7 +8218,7 @@
       </p:pic>
       <p:pic>
         <p:nvPicPr>
-          <p:cNvPr id="116" name="Google Shape;116;p17" title="SP2_scatter_hek.jpg"/>
+          <p:cNvPr id="117" name="Google Shape;117;p17" title="SP2_scatter_hek.jpg"/>
           <p:cNvPicPr preferRelativeResize="0"/>
           <p:nvPr/>
         </p:nvPicPr>
@@ -8194,7 +8246,7 @@
       </p:pic>
       <p:pic>
         <p:nvPicPr>
-          <p:cNvPr id="117" name="Google Shape;117;p17" title="NFYA_scatter_intersect.jpg"/>
+          <p:cNvPr id="118" name="Google Shape;118;p17" title="NFYA_scatter_intersect.jpg"/>
           <p:cNvPicPr preferRelativeResize="0"/>
           <p:nvPr/>
         </p:nvPicPr>
@@ -8222,7 +8274,7 @@
       </p:pic>
       <p:pic>
         <p:nvPicPr>
-          <p:cNvPr id="118" name="Google Shape;118;p17" title="NFYA_venn.png"/>
+          <p:cNvPr id="119" name="Google Shape;119;p17" title="NFYA_venn.png"/>
           <p:cNvPicPr preferRelativeResize="0"/>
           <p:nvPr/>
         </p:nvPicPr>
@@ -8261,7 +8313,7 @@
   <p:cSld>
     <p:spTree>
       <p:nvGrpSpPr>
-        <p:cNvPr id="122" name="Shape 122"/>
+        <p:cNvPr id="123" name="Shape 123"/>
         <p:cNvGrpSpPr/>
         <p:nvPr/>
       </p:nvGrpSpPr>
@@ -8275,7 +8327,7 @@
       </p:grpSpPr>
       <p:pic>
         <p:nvPicPr>
-          <p:cNvPr id="123" name="Google Shape;123;p18" title="GSEA_top_pathway_rep1.jpg"/>
+          <p:cNvPr id="124" name="Google Shape;124;p18" title="GSEA_top_pathway_rep1.jpg"/>
           <p:cNvPicPr preferRelativeResize="0"/>
           <p:nvPr/>
         </p:nvPicPr>
@@ -8303,7 +8355,7 @@
       </p:pic>
       <p:pic>
         <p:nvPicPr>
-          <p:cNvPr id="124" name="Google Shape;124;p18" title="remap_act.jpg"/>
+          <p:cNvPr id="125" name="Google Shape;125;p18" title="remap_act.jpg"/>
           <p:cNvPicPr preferRelativeResize="0"/>
           <p:nvPr/>
         </p:nvPicPr>
@@ -8331,7 +8383,7 @@
       </p:pic>
       <p:pic>
         <p:nvPicPr>
-          <p:cNvPr id="125" name="Google Shape;125;p18" title="remap_act_low.jpg"/>
+          <p:cNvPr id="126" name="Google Shape;126;p18" title="remap_act_low.jpg"/>
           <p:cNvPicPr preferRelativeResize="0"/>
           <p:nvPr/>
         </p:nvPicPr>
@@ -8366,6 +8418,285 @@
 </file>
 
 <file path=ppt/theme/theme1.xml><?xml version="1.0" encoding="utf-8"?>
+<a:theme xmlns:a="http://schemas.openxmlformats.org/drawingml/2006/main" xmlns:r="http://schemas.openxmlformats.org/officeDocument/2006/relationships">
+  <a:themeElements>
+    <a:clrScheme name="Default">
+      <a:dk1>
+        <a:srgbClr val="000000"/>
+      </a:dk1>
+      <a:lt1>
+        <a:srgbClr val="FFFFFF"/>
+      </a:lt1>
+      <a:dk2>
+        <a:srgbClr val="158158"/>
+      </a:dk2>
+      <a:lt2>
+        <a:srgbClr val="F3F3F3"/>
+      </a:lt2>
+      <a:accent1>
+        <a:srgbClr val="058DC7"/>
+      </a:accent1>
+      <a:accent2>
+        <a:srgbClr val="50B432"/>
+      </a:accent2>
+      <a:accent3>
+        <a:srgbClr val="ED561B"/>
+      </a:accent3>
+      <a:accent4>
+        <a:srgbClr val="EDEF00"/>
+      </a:accent4>
+      <a:accent5>
+        <a:srgbClr val="24CBE5"/>
+      </a:accent5>
+      <a:accent6>
+        <a:srgbClr val="64E572"/>
+      </a:accent6>
+      <a:hlink>
+        <a:srgbClr val="2200CC"/>
+      </a:hlink>
+      <a:folHlink>
+        <a:srgbClr val="551A8B"/>
+      </a:folHlink>
+    </a:clrScheme>
+    <a:fontScheme name="Office">
+      <a:majorFont>
+        <a:latin typeface="Arial"/>
+        <a:ea typeface=""/>
+        <a:cs typeface=""/>
+        <a:font script="Jpan" typeface="ＭＳ Ｐゴシック"/>
+        <a:font script="Hang" typeface="맑은 고딕"/>
+        <a:font script="Hans" typeface="宋体"/>
+        <a:font script="Hant" typeface="新細明體"/>
+        <a:font script="Arab" typeface="Times New Roman"/>
+        <a:font script="Hebr" typeface="Times New Roman"/>
+        <a:font script="Thai" typeface="Angsana New"/>
+        <a:font script="Ethi" typeface="Nyala"/>
+        <a:font script="Beng" typeface="Vrinda"/>
+        <a:font script="Gujr" typeface="Shruti"/>
+        <a:font script="Khmr" typeface="MoolBoran"/>
+        <a:font script="Knda" typeface="Tunga"/>
+        <a:font script="Guru" typeface="Raavi"/>
+        <a:font script="Cans" typeface="Euphemia"/>
+        <a:font script="Cher" typeface="Plantagenet Cherokee"/>
+        <a:font script="Yiii" typeface="Microsoft Yi Baiti"/>
+        <a:font script="Tibt" typeface="Microsoft Himalaya"/>
+        <a:font script="Thaa" typeface="MV Boli"/>
+        <a:font script="Deva" typeface="Mangal"/>
+        <a:font script="Telu" typeface="Gautami"/>
+        <a:font script="Taml" typeface="Latha"/>
+        <a:font script="Syrc" typeface="Estrangelo Edessa"/>
+        <a:font script="Orya" typeface="Kalinga"/>
+        <a:font script="Mlym" typeface="Kartika"/>
+        <a:font script="Laoo" typeface="DokChampa"/>
+        <a:font script="Sinh" typeface="Iskoola Pota"/>
+        <a:font script="Mong" typeface="Mongolian Baiti"/>
+        <a:font script="Viet" typeface="Times New Roman"/>
+        <a:font script="Uigh" typeface="Microsoft Uighur"/>
+        <a:font script="Geor" typeface="Sylfaen"/>
+      </a:majorFont>
+      <a:minorFont>
+        <a:latin typeface="Arial"/>
+        <a:ea typeface=""/>
+        <a:cs typeface=""/>
+        <a:font script="Jpan" typeface="ＭＳ Ｐゴシック"/>
+        <a:font script="Hang" typeface="맑은 고딕"/>
+        <a:font script="Hans" typeface="宋体"/>
+        <a:font script="Hant" typeface="新細明體"/>
+        <a:font script="Arab" typeface="Arial"/>
+        <a:font script="Hebr" typeface="Arial"/>
+        <a:font script="Thai" typeface="Cordia New"/>
+        <a:font script="Ethi" typeface="Nyala"/>
+        <a:font script="Beng" typeface="Vrinda"/>
+        <a:font script="Gujr" typeface="Shruti"/>
+        <a:font script="Khmr" typeface="DaunPenh"/>
+        <a:font script="Knda" typeface="Tunga"/>
+        <a:font script="Guru" typeface="Raavi"/>
+        <a:font script="Cans" typeface="Euphemia"/>
+        <a:font script="Cher" typeface="Plantagenet Cherokee"/>
+        <a:font script="Yiii" typeface="Microsoft Yi Baiti"/>
+        <a:font script="Tibt" typeface="Microsoft Himalaya"/>
+        <a:font script="Thaa" typeface="MV Boli"/>
+        <a:font script="Deva" typeface="Mangal"/>
+        <a:font script="Telu" typeface="Gautami"/>
+        <a:font script="Taml" typeface="Latha"/>
+        <a:font script="Syrc" typeface="Estrangelo Edessa"/>
+        <a:font script="Orya" typeface="Kalinga"/>
+        <a:font script="Mlym" typeface="Kartika"/>
+        <a:font script="Laoo" typeface="DokChampa"/>
+        <a:font script="Sinh" typeface="Iskoola Pota"/>
+        <a:font script="Mong" typeface="Mongolian Baiti"/>
+        <a:font script="Viet" typeface="Arial"/>
+        <a:font script="Uigh" typeface="Microsoft Uighur"/>
+        <a:font script="Geor" typeface="Sylfaen"/>
+      </a:minorFont>
+    </a:fontScheme>
+    <a:fmtScheme name="Office">
+      <a:fillStyleLst>
+        <a:solidFill>
+          <a:schemeClr val="phClr"/>
+        </a:solidFill>
+        <a:gradFill rotWithShape="1">
+          <a:gsLst>
+            <a:gs pos="0">
+              <a:schemeClr val="phClr">
+                <a:tint val="50000"/>
+                <a:satMod val="300000"/>
+              </a:schemeClr>
+            </a:gs>
+            <a:gs pos="35000">
+              <a:schemeClr val="phClr">
+                <a:tint val="37000"/>
+                <a:satMod val="300000"/>
+              </a:schemeClr>
+            </a:gs>
+            <a:gs pos="100000">
+              <a:schemeClr val="phClr">
+                <a:tint val="15000"/>
+                <a:satMod val="350000"/>
+              </a:schemeClr>
+            </a:gs>
+          </a:gsLst>
+          <a:lin ang="16200000" scaled="1"/>
+        </a:gradFill>
+        <a:gradFill rotWithShape="1">
+          <a:gsLst>
+            <a:gs pos="0">
+              <a:schemeClr val="phClr">
+                <a:tint val="100000"/>
+                <a:shade val="100000"/>
+                <a:satMod val="130000"/>
+              </a:schemeClr>
+            </a:gs>
+            <a:gs pos="100000">
+              <a:schemeClr val="phClr">
+                <a:tint val="50000"/>
+                <a:shade val="100000"/>
+                <a:satMod val="350000"/>
+              </a:schemeClr>
+            </a:gs>
+          </a:gsLst>
+          <a:lin ang="16200000" scaled="0"/>
+        </a:gradFill>
+      </a:fillStyleLst>
+      <a:lnStyleLst>
+        <a:ln w="9525" cap="flat" cmpd="sng" algn="ctr">
+          <a:solidFill>
+            <a:schemeClr val="phClr">
+              <a:shade val="95000"/>
+              <a:satMod val="105000"/>
+            </a:schemeClr>
+          </a:solidFill>
+          <a:prstDash val="solid"/>
+        </a:ln>
+        <a:ln w="25400" cap="flat" cmpd="sng" algn="ctr">
+          <a:solidFill>
+            <a:schemeClr val="phClr"/>
+          </a:solidFill>
+          <a:prstDash val="solid"/>
+        </a:ln>
+        <a:ln w="38100" cap="flat" cmpd="sng" algn="ctr">
+          <a:solidFill>
+            <a:schemeClr val="phClr"/>
+          </a:solidFill>
+          <a:prstDash val="solid"/>
+        </a:ln>
+      </a:lnStyleLst>
+      <a:effectStyleLst>
+        <a:effectStyle>
+          <a:effectLst>
+            <a:outerShdw blurRad="40000" dist="20000" dir="5400000" rotWithShape="0">
+              <a:srgbClr val="000000">
+                <a:alpha val="38000"/>
+              </a:srgbClr>
+            </a:outerShdw>
+          </a:effectLst>
+        </a:effectStyle>
+        <a:effectStyle>
+          <a:effectLst>
+            <a:outerShdw blurRad="40000" dist="23000" dir="5400000" rotWithShape="0">
+              <a:srgbClr val="000000">
+                <a:alpha val="35000"/>
+              </a:srgbClr>
+            </a:outerShdw>
+          </a:effectLst>
+        </a:effectStyle>
+        <a:effectStyle>
+          <a:effectLst>
+            <a:outerShdw blurRad="40000" dist="23000" dir="5400000" rotWithShape="0">
+              <a:srgbClr val="000000">
+                <a:alpha val="35000"/>
+              </a:srgbClr>
+            </a:outerShdw>
+          </a:effectLst>
+          <a:scene3d>
+            <a:camera prst="orthographicFront">
+              <a:rot lat="0" lon="0" rev="0"/>
+            </a:camera>
+            <a:lightRig rig="threePt" dir="t">
+              <a:rot lat="0" lon="0" rev="1200000"/>
+            </a:lightRig>
+          </a:scene3d>
+          <a:sp3d>
+            <a:bevelT w="63500" h="25400"/>
+          </a:sp3d>
+        </a:effectStyle>
+      </a:effectStyleLst>
+      <a:bgFillStyleLst>
+        <a:solidFill>
+          <a:schemeClr val="phClr"/>
+        </a:solidFill>
+        <a:gradFill rotWithShape="1">
+          <a:gsLst>
+            <a:gs pos="0">
+              <a:schemeClr val="phClr">
+                <a:tint val="40000"/>
+                <a:satMod val="350000"/>
+              </a:schemeClr>
+            </a:gs>
+            <a:gs pos="40000">
+              <a:schemeClr val="phClr">
+                <a:tint val="45000"/>
+                <a:shade val="99000"/>
+                <a:satMod val="350000"/>
+              </a:schemeClr>
+            </a:gs>
+            <a:gs pos="100000">
+              <a:schemeClr val="phClr">
+                <a:shade val="20000"/>
+                <a:satMod val="255000"/>
+              </a:schemeClr>
+            </a:gs>
+          </a:gsLst>
+          <a:path path="circle">
+            <a:fillToRect l="50000" t="-80000" r="50000" b="180000"/>
+          </a:path>
+        </a:gradFill>
+        <a:gradFill rotWithShape="1">
+          <a:gsLst>
+            <a:gs pos="0">
+              <a:schemeClr val="phClr">
+                <a:tint val="80000"/>
+                <a:satMod val="300000"/>
+              </a:schemeClr>
+            </a:gs>
+            <a:gs pos="100000">
+              <a:schemeClr val="phClr">
+                <a:shade val="30000"/>
+                <a:satMod val="200000"/>
+              </a:schemeClr>
+            </a:gs>
+          </a:gsLst>
+          <a:path path="circle">
+            <a:fillToRect l="50000" t="50000" r="50000" b="50000"/>
+          </a:path>
+        </a:gradFill>
+      </a:bgFillStyleLst>
+    </a:fmtScheme>
+  </a:themeElements>
+</a:theme>
+</file>
+
+<file path=ppt/theme/theme2.xml><?xml version="1.0" encoding="utf-8"?>
 <a:theme xmlns:a="http://schemas.openxmlformats.org/drawingml/2006/main" xmlns:r="http://schemas.openxmlformats.org/officeDocument/2006/relationships" name="Simple Light">
   <a:themeElements>
     <a:clrScheme name="Simple Light">
@@ -8642,283 +8973,4 @@
     </a:fmtScheme>
   </a:themeElements>
 </a:theme>
-</file>
-
-<file path=ppt/theme/theme2.xml><?xml version="1.0" encoding="utf-8"?>
-<a:theme xmlns:a="http://schemas.openxmlformats.org/drawingml/2006/main" xmlns:r="http://schemas.openxmlformats.org/officeDocument/2006/relationships">
-  <a:themeElements>
-    <a:clrScheme name="Default">
-      <a:dk1>
-        <a:srgbClr val="000000"/>
-      </a:dk1>
-      <a:lt1>
-        <a:srgbClr val="FFFFFF"/>
-      </a:lt1>
-      <a:dk2>
-        <a:srgbClr val="158158"/>
-      </a:dk2>
-      <a:lt2>
-        <a:srgbClr val="F3F3F3"/>
-      </a:lt2>
-      <a:accent1>
-        <a:srgbClr val="058DC7"/>
-      </a:accent1>
-      <a:accent2>
-        <a:srgbClr val="50B432"/>
-      </a:accent2>
-      <a:accent3>
-        <a:srgbClr val="ED561B"/>
-      </a:accent3>
-      <a:accent4>
-        <a:srgbClr val="EDEF00"/>
-      </a:accent4>
-      <a:accent5>
-        <a:srgbClr val="24CBE5"/>
-      </a:accent5>
-      <a:accent6>
-        <a:srgbClr val="64E572"/>
-      </a:accent6>
-      <a:hlink>
-        <a:srgbClr val="2200CC"/>
-      </a:hlink>
-      <a:folHlink>
-        <a:srgbClr val="551A8B"/>
-      </a:folHlink>
-    </a:clrScheme>
-    <a:fontScheme name="Office">
-      <a:majorFont>
-        <a:latin typeface="Arial"/>
-        <a:ea typeface=""/>
-        <a:cs typeface=""/>
-        <a:font script="Jpan" typeface="ＭＳ Ｐゴシック"/>
-        <a:font script="Hang" typeface="맑은 고딕"/>
-        <a:font script="Hans" typeface="宋体"/>
-        <a:font script="Hant" typeface="新細明體"/>
-        <a:font script="Arab" typeface="Times New Roman"/>
-        <a:font script="Hebr" typeface="Times New Roman"/>
-        <a:font script="Thai" typeface="Angsana New"/>
-        <a:font script="Ethi" typeface="Nyala"/>
-        <a:font script="Beng" typeface="Vrinda"/>
-        <a:font script="Gujr" typeface="Shruti"/>
-        <a:font script="Khmr" typeface="MoolBoran"/>
-        <a:font script="Knda" typeface="Tunga"/>
-        <a:font script="Guru" typeface="Raavi"/>
-        <a:font script="Cans" typeface="Euphemia"/>
-        <a:font script="Cher" typeface="Plantagenet Cherokee"/>
-        <a:font script="Yiii" typeface="Microsoft Yi Baiti"/>
-        <a:font script="Tibt" typeface="Microsoft Himalaya"/>
-        <a:font script="Thaa" typeface="MV Boli"/>
-        <a:font script="Deva" typeface="Mangal"/>
-        <a:font script="Telu" typeface="Gautami"/>
-        <a:font script="Taml" typeface="Latha"/>
-        <a:font script="Syrc" typeface="Estrangelo Edessa"/>
-        <a:font script="Orya" typeface="Kalinga"/>
-        <a:font script="Mlym" typeface="Kartika"/>
-        <a:font script="Laoo" typeface="DokChampa"/>
-        <a:font script="Sinh" typeface="Iskoola Pota"/>
-        <a:font script="Mong" typeface="Mongolian Baiti"/>
-        <a:font script="Viet" typeface="Times New Roman"/>
-        <a:font script="Uigh" typeface="Microsoft Uighur"/>
-        <a:font script="Geor" typeface="Sylfaen"/>
-      </a:majorFont>
-      <a:minorFont>
-        <a:latin typeface="Arial"/>
-        <a:ea typeface=""/>
-        <a:cs typeface=""/>
-        <a:font script="Jpan" typeface="ＭＳ Ｐゴシック"/>
-        <a:font script="Hang" typeface="맑은 고딕"/>
-        <a:font script="Hans" typeface="宋体"/>
-        <a:font script="Hant" typeface="新細明體"/>
-        <a:font script="Arab" typeface="Arial"/>
-        <a:font script="Hebr" typeface="Arial"/>
-        <a:font script="Thai" typeface="Cordia New"/>
-        <a:font script="Ethi" typeface="Nyala"/>
-        <a:font script="Beng" typeface="Vrinda"/>
-        <a:font script="Gujr" typeface="Shruti"/>
-        <a:font script="Khmr" typeface="DaunPenh"/>
-        <a:font script="Knda" typeface="Tunga"/>
-        <a:font script="Guru" typeface="Raavi"/>
-        <a:font script="Cans" typeface="Euphemia"/>
-        <a:font script="Cher" typeface="Plantagenet Cherokee"/>
-        <a:font script="Yiii" typeface="Microsoft Yi Baiti"/>
-        <a:font script="Tibt" typeface="Microsoft Himalaya"/>
-        <a:font script="Thaa" typeface="MV Boli"/>
-        <a:font script="Deva" typeface="Mangal"/>
-        <a:font script="Telu" typeface="Gautami"/>
-        <a:font script="Taml" typeface="Latha"/>
-        <a:font script="Syrc" typeface="Estrangelo Edessa"/>
-        <a:font script="Orya" typeface="Kalinga"/>
-        <a:font script="Mlym" typeface="Kartika"/>
-        <a:font script="Laoo" typeface="DokChampa"/>
-        <a:font script="Sinh" typeface="Iskoola Pota"/>
-        <a:font script="Mong" typeface="Mongolian Baiti"/>
-        <a:font script="Viet" typeface="Arial"/>
-        <a:font script="Uigh" typeface="Microsoft Uighur"/>
-        <a:font script="Geor" typeface="Sylfaen"/>
-      </a:minorFont>
-    </a:fontScheme>
-    <a:fmtScheme name="Office">
-      <a:fillStyleLst>
-        <a:solidFill>
-          <a:schemeClr val="phClr"/>
-        </a:solidFill>
-        <a:gradFill rotWithShape="1">
-          <a:gsLst>
-            <a:gs pos="0">
-              <a:schemeClr val="phClr">
-                <a:tint val="50000"/>
-                <a:satMod val="300000"/>
-              </a:schemeClr>
-            </a:gs>
-            <a:gs pos="35000">
-              <a:schemeClr val="phClr">
-                <a:tint val="37000"/>
-                <a:satMod val="300000"/>
-              </a:schemeClr>
-            </a:gs>
-            <a:gs pos="100000">
-              <a:schemeClr val="phClr">
-                <a:tint val="15000"/>
-                <a:satMod val="350000"/>
-              </a:schemeClr>
-            </a:gs>
-          </a:gsLst>
-          <a:lin ang="16200000" scaled="1"/>
-        </a:gradFill>
-        <a:gradFill rotWithShape="1">
-          <a:gsLst>
-            <a:gs pos="0">
-              <a:schemeClr val="phClr">
-                <a:tint val="100000"/>
-                <a:shade val="100000"/>
-                <a:satMod val="130000"/>
-              </a:schemeClr>
-            </a:gs>
-            <a:gs pos="100000">
-              <a:schemeClr val="phClr">
-                <a:tint val="50000"/>
-                <a:shade val="100000"/>
-                <a:satMod val="350000"/>
-              </a:schemeClr>
-            </a:gs>
-          </a:gsLst>
-          <a:lin ang="16200000" scaled="0"/>
-        </a:gradFill>
-      </a:fillStyleLst>
-      <a:lnStyleLst>
-        <a:ln w="9525" cap="flat" cmpd="sng" algn="ctr">
-          <a:solidFill>
-            <a:schemeClr val="phClr">
-              <a:shade val="95000"/>
-              <a:satMod val="105000"/>
-            </a:schemeClr>
-          </a:solidFill>
-          <a:prstDash val="solid"/>
-        </a:ln>
-        <a:ln w="25400" cap="flat" cmpd="sng" algn="ctr">
-          <a:solidFill>
-            <a:schemeClr val="phClr"/>
-          </a:solidFill>
-          <a:prstDash val="solid"/>
-        </a:ln>
-        <a:ln w="38100" cap="flat" cmpd="sng" algn="ctr">
-          <a:solidFill>
-            <a:schemeClr val="phClr"/>
-          </a:solidFill>
-          <a:prstDash val="solid"/>
-        </a:ln>
-      </a:lnStyleLst>
-      <a:effectStyleLst>
-        <a:effectStyle>
-          <a:effectLst>
-            <a:outerShdw blurRad="40000" dist="20000" dir="5400000" rotWithShape="0">
-              <a:srgbClr val="000000">
-                <a:alpha val="38000"/>
-              </a:srgbClr>
-            </a:outerShdw>
-          </a:effectLst>
-        </a:effectStyle>
-        <a:effectStyle>
-          <a:effectLst>
-            <a:outerShdw blurRad="40000" dist="23000" dir="5400000" rotWithShape="0">
-              <a:srgbClr val="000000">
-                <a:alpha val="35000"/>
-              </a:srgbClr>
-            </a:outerShdw>
-          </a:effectLst>
-        </a:effectStyle>
-        <a:effectStyle>
-          <a:effectLst>
-            <a:outerShdw blurRad="40000" dist="23000" dir="5400000" rotWithShape="0">
-              <a:srgbClr val="000000">
-                <a:alpha val="35000"/>
-              </a:srgbClr>
-            </a:outerShdw>
-          </a:effectLst>
-          <a:scene3d>
-            <a:camera prst="orthographicFront">
-              <a:rot lat="0" lon="0" rev="0"/>
-            </a:camera>
-            <a:lightRig rig="threePt" dir="t">
-              <a:rot lat="0" lon="0" rev="1200000"/>
-            </a:lightRig>
-          </a:scene3d>
-          <a:sp3d>
-            <a:bevelT w="63500" h="25400"/>
-          </a:sp3d>
-        </a:effectStyle>
-      </a:effectStyleLst>
-      <a:bgFillStyleLst>
-        <a:solidFill>
-          <a:schemeClr val="phClr"/>
-        </a:solidFill>
-        <a:gradFill rotWithShape="1">
-          <a:gsLst>
-            <a:gs pos="0">
-              <a:schemeClr val="phClr">
-                <a:tint val="40000"/>
-                <a:satMod val="350000"/>
-              </a:schemeClr>
-            </a:gs>
-            <a:gs pos="40000">
-              <a:schemeClr val="phClr">
-                <a:tint val="45000"/>
-                <a:shade val="99000"/>
-                <a:satMod val="350000"/>
-              </a:schemeClr>
-            </a:gs>
-            <a:gs pos="100000">
-              <a:schemeClr val="phClr">
-                <a:shade val="20000"/>
-                <a:satMod val="255000"/>
-              </a:schemeClr>
-            </a:gs>
-          </a:gsLst>
-          <a:path path="circle">
-            <a:fillToRect l="50000" t="-80000" r="50000" b="180000"/>
-          </a:path>
-        </a:gradFill>
-        <a:gradFill rotWithShape="1">
-          <a:gsLst>
-            <a:gs pos="0">
-              <a:schemeClr val="phClr">
-                <a:tint val="80000"/>
-                <a:satMod val="300000"/>
-              </a:schemeClr>
-            </a:gs>
-            <a:gs pos="100000">
-              <a:schemeClr val="phClr">
-                <a:shade val="30000"/>
-                <a:satMod val="200000"/>
-              </a:schemeClr>
-            </a:gs>
-          </a:gsLst>
-          <a:path path="circle">
-            <a:fillToRect l="50000" t="50000" r="50000" b="50000"/>
-          </a:path>
-        </a:gradFill>
-      </a:bgFillStyleLst>
-    </a:fmtScheme>
-  </a:themeElements>
-</a:theme>
 </file>
</xml_diff>

<commit_message>
docs: resync figure numbering from Drive decks (2026-10-16)
Decks changed in Drive: Fig R2 (11 -> 15 slides).
Fig MyM, Fig R1 and Fig R3 re-exported with different bytes but
identical text and pixel-identical images, so they were left as committed.

R2 renumbering (matched by slide images; the CSV number changes went in
with 6a482c4, committed concurrently):
- remap_tf_activity_gsea: R2.13 -> R2.14 (folder renamed)
- tf_nfya_sp_contexto_endogeno: R2.12 -> R2.15 (folder renamed, from the
  committed R2.10_ path)

Flagged for manual review: summary_features_secuencia appears on slides
11 (old hand-made table) and 13 (current summary_seq.jpg); kept at R2.11.

Co-Authored-By: Claude Opus 5.5 <noreply@anthropic.com>
</commit_message>
<xml_diff>
--- a/docs/Fig R2.pptx
+++ b/docs/Fig R2.pptx
@@ -2,23 +2,27 @@
 <file path=ppt/presentation.xml><?xml version="1.0" encoding="utf-8"?>
 <p:presentation xmlns:a="http://schemas.openxmlformats.org/drawingml/2006/main" xmlns:r="http://schemas.openxmlformats.org/officeDocument/2006/relationships" xmlns:mc="http://schemas.openxmlformats.org/markup-compatibility/2006" xmlns:mv="urn:schemas-microsoft-com:mac:vml" xmlns:p="http://schemas.openxmlformats.org/presentationml/2006/main" xmlns:c="http://schemas.openxmlformats.org/drawingml/2006/chart" xmlns:dgm="http://schemas.openxmlformats.org/drawingml/2006/diagram" xmlns:o="urn:schemas-microsoft-com:office:office" xmlns:v="urn:schemas-microsoft-com:vml" xmlns:pvml="urn:schemas-microsoft-com:office:powerpoint" xmlns:com="http://schemas.openxmlformats.org/drawingml/2006/compatibility" xmlns:p14="http://schemas.microsoft.com/office/powerpoint/2010/main" xmlns:p15="http://schemas.microsoft.com/office/powerpoint/2012/main" xmlns:ahyp="http://schemas.microsoft.com/office/drawing/2018/hyperlinkcolor" autoCompressPictures="0" strictFirstAndLastChars="0" saveSubsetFonts="1">
   <p:sldMasterIdLst>
-    <p:sldMasterId id="2147483659" r:id="rId4"/>
+    <p:sldMasterId id="2147483659" r:id="rId5"/>
   </p:sldMasterIdLst>
   <p:notesMasterIdLst>
-    <p:notesMasterId r:id="rId5"/>
+    <p:notesMasterId r:id="rId6"/>
   </p:notesMasterIdLst>
   <p:sldIdLst>
-    <p:sldId id="256" r:id="rId6"/>
-    <p:sldId id="257" r:id="rId7"/>
-    <p:sldId id="258" r:id="rId8"/>
-    <p:sldId id="259" r:id="rId9"/>
-    <p:sldId id="260" r:id="rId10"/>
-    <p:sldId id="261" r:id="rId11"/>
-    <p:sldId id="262" r:id="rId12"/>
-    <p:sldId id="263" r:id="rId13"/>
-    <p:sldId id="264" r:id="rId14"/>
-    <p:sldId id="265" r:id="rId15"/>
-    <p:sldId id="266" r:id="rId16"/>
+    <p:sldId id="256" r:id="rId7"/>
+    <p:sldId id="257" r:id="rId8"/>
+    <p:sldId id="258" r:id="rId9"/>
+    <p:sldId id="259" r:id="rId10"/>
+    <p:sldId id="260" r:id="rId11"/>
+    <p:sldId id="261" r:id="rId12"/>
+    <p:sldId id="262" r:id="rId13"/>
+    <p:sldId id="263" r:id="rId14"/>
+    <p:sldId id="264" r:id="rId15"/>
+    <p:sldId id="265" r:id="rId16"/>
+    <p:sldId id="266" r:id="rId17"/>
+    <p:sldId id="267" r:id="rId18"/>
+    <p:sldId id="268" r:id="rId19"/>
+    <p:sldId id="269" r:id="rId20"/>
+    <p:sldId id="270" r:id="rId21"/>
   </p:sldIdLst>
   <p:sldSz cy="5143500" cx="9144000"/>
   <p:notesSz cx="6858000" cy="9144000"/>
@@ -268,6 +272,30 @@
     </p:ext>
   </p:extLst>
 </p:presentation>
+</file>
+
+<file path=ppt/commentAuthors.xml><?xml version="1.0" encoding="utf-8"?>
+<p:cmAuthorLst xmlns:a="http://schemas.openxmlformats.org/drawingml/2006/main" xmlns:r="http://schemas.openxmlformats.org/officeDocument/2006/relationships" xmlns:mc="http://schemas.openxmlformats.org/markup-compatibility/2006" xmlns:mv="urn:schemas-microsoft-com:mac:vml" xmlns:p="http://schemas.openxmlformats.org/presentationml/2006/main" xmlns:c="http://schemas.openxmlformats.org/drawingml/2006/chart" xmlns:dgm="http://schemas.openxmlformats.org/drawingml/2006/diagram" xmlns:o="urn:schemas-microsoft-com:office:office" xmlns:v="urn:schemas-microsoft-com:vml" xmlns:pvml="urn:schemas-microsoft-com:office:powerpoint" xmlns:com="http://schemas.openxmlformats.org/drawingml/2006/compatibility" xmlns:p14="http://schemas.microsoft.com/office/powerpoint/2010/main" xmlns:p15="http://schemas.microsoft.com/office/powerpoint/2012/main" xmlns:ahyp="http://schemas.microsoft.com/office/drawing/2018/hyperlinkcolor">
+  <p:cmAuthor clrIdx="0" id="0" initials="" lastIdx="2" name="Martin Iungman"/>
+</p:cmAuthorLst>
+</file>
+
+<file path=ppt/comments/comment1.xml><?xml version="1.0" encoding="utf-8"?>
+<p:cmLst xmlns:a="http://schemas.openxmlformats.org/drawingml/2006/main" xmlns:r="http://schemas.openxmlformats.org/officeDocument/2006/relationships" xmlns:mc="http://schemas.openxmlformats.org/markup-compatibility/2006" xmlns:mv="urn:schemas-microsoft-com:mac:vml" xmlns:p="http://schemas.openxmlformats.org/presentationml/2006/main" xmlns:c="http://schemas.openxmlformats.org/drawingml/2006/chart" xmlns:dgm="http://schemas.openxmlformats.org/drawingml/2006/diagram" xmlns:o="urn:schemas-microsoft-com:office:office" xmlns:v="urn:schemas-microsoft-com:vml" xmlns:pvml="urn:schemas-microsoft-com:office:powerpoint" xmlns:com="http://schemas.openxmlformats.org/drawingml/2006/compatibility" xmlns:p14="http://schemas.microsoft.com/office/powerpoint/2010/main" xmlns:p15="http://schemas.microsoft.com/office/powerpoint/2012/main" xmlns:ahyp="http://schemas.microsoft.com/office/drawing/2018/hyperlinkcolor">
+  <p:cm authorId="0" idx="1" dt="2026-10-15T18:20:48.941">
+    <p:pos x="96" y="1590"/>
+    <p:text>tengo un tema aca y en otros con este mismo esquema de plot.  parece que el efecto es bajo, cuando en realidad esta cayendo a la mitad. al mantener la escala fija, cuando hay poca prevalencia del feture, pasa esto. pero cambiar la escala y que no llegue a 1 me resulta raro.</p:text>
+  </p:cm>
+</p:cmLst>
+</file>
+
+<file path=ppt/comments/comment2.xml><?xml version="1.0" encoding="utf-8"?>
+<p:cmLst xmlns:a="http://schemas.openxmlformats.org/drawingml/2006/main" xmlns:r="http://schemas.openxmlformats.org/officeDocument/2006/relationships" xmlns:mc="http://schemas.openxmlformats.org/markup-compatibility/2006" xmlns:mv="urn:schemas-microsoft-com:mac:vml" xmlns:p="http://schemas.openxmlformats.org/presentationml/2006/main" xmlns:c="http://schemas.openxmlformats.org/drawingml/2006/chart" xmlns:dgm="http://schemas.openxmlformats.org/drawingml/2006/diagram" xmlns:o="urn:schemas-microsoft-com:office:office" xmlns:v="urn:schemas-microsoft-com:vml" xmlns:pvml="urn:schemas-microsoft-com:office:powerpoint" xmlns:com="http://schemas.openxmlformats.org/drawingml/2006/compatibility" xmlns:p14="http://schemas.microsoft.com/office/powerpoint/2010/main" xmlns:p15="http://schemas.microsoft.com/office/powerpoint/2012/main" xmlns:ahyp="http://schemas.microsoft.com/office/drawing/2018/hyperlinkcolor">
+  <p:cm authorId="0" idx="2" dt="2026-10-16T13:14:00.794">
+    <p:pos x="2064" y="1412"/>
+    <p:text>tal vez hacer una escala de colores para cada replica es mas correcto</p:text>
+  </p:cm>
+</p:cmLst>
 </file>
 
 <file path=ppt/notesMasters/notesMaster1.xml><?xml version="1.0" encoding="utf-8"?>
@@ -800,7 +828,7 @@
   <p:cSld>
     <p:spTree>
       <p:nvGrpSpPr>
-        <p:cNvPr id="148" name="Shape 148"/>
+        <p:cNvPr id="114" name="Shape 114"/>
         <p:cNvGrpSpPr/>
         <p:nvPr/>
       </p:nvGrpSpPr>
@@ -814,7 +842,7 @@
       </p:grpSpPr>
       <p:sp>
         <p:nvSpPr>
-          <p:cNvPr id="149" name="Google Shape;149;g3f58eefa86d_0_117:notes"/>
+          <p:cNvPr id="115" name="Google Shape;115;h1c371980c4f29fb2_0_0:notes"/>
           <p:cNvSpPr/>
           <p:nvPr>
             <p:ph idx="2" type="sldImg"/>
@@ -849,7 +877,7 @@
       </p:sp>
       <p:sp>
         <p:nvSpPr>
-          <p:cNvPr id="150" name="Google Shape;150;g3f58eefa86d_0_117:notes"/>
+          <p:cNvPr id="116" name="Google Shape;116;h1c371980c4f29fb2_0_0:notes"/>
           <p:cNvSpPr txBox="1"/>
           <p:nvPr>
             <p:ph idx="1" type="body"/>
@@ -899,7 +927,7 @@
   <p:cSld>
     <p:spTree>
       <p:nvGrpSpPr>
-        <p:cNvPr id="155" name="Shape 155"/>
+        <p:cNvPr id="121" name="Shape 121"/>
         <p:cNvGrpSpPr/>
         <p:nvPr/>
       </p:nvGrpSpPr>
@@ -913,7 +941,7 @@
       </p:grpSpPr>
       <p:sp>
         <p:nvSpPr>
-          <p:cNvPr id="156" name="Google Shape;156;g3f58eefa86d_0_108:notes"/>
+          <p:cNvPr id="122" name="Google Shape;122;g3f58eefa86d_0_9:notes"/>
           <p:cNvSpPr/>
           <p:nvPr>
             <p:ph idx="2" type="sldImg"/>
@@ -948,7 +976,403 @@
       </p:sp>
       <p:sp>
         <p:nvSpPr>
-          <p:cNvPr id="157" name="Google Shape;157;g3f58eefa86d_0_108:notes"/>
+          <p:cNvPr id="123" name="Google Shape;123;g3f58eefa86d_0_9:notes"/>
+          <p:cNvSpPr txBox="1"/>
+          <p:nvPr>
+            <p:ph idx="1" type="body"/>
+          </p:nvPr>
+        </p:nvSpPr>
+        <p:spPr>
+          <a:xfrm>
+            <a:off x="685800" y="4343400"/>
+            <a:ext cx="5486400" cy="4114800"/>
+          </a:xfrm>
+          <a:prstGeom prst="rect">
+            <a:avLst/>
+          </a:prstGeom>
+        </p:spPr>
+        <p:txBody>
+          <a:bodyPr anchorCtr="0" anchor="t" bIns="91425" lIns="91425" spcFirstLastPara="1" rIns="91425" wrap="square" tIns="91425">
+            <a:noAutofit/>
+          </a:bodyPr>
+          <a:lstStyle/>
+          <a:p>
+            <a:pPr indent="0" lvl="0" marL="0" rtl="0" algn="l">
+              <a:spcBef>
+                <a:spcPts val="0"/>
+              </a:spcBef>
+              <a:spcAft>
+                <a:spcPts val="0"/>
+              </a:spcAft>
+              <a:buNone/>
+            </a:pPr>
+            <a:r>
+              <a:t/>
+            </a:r>
+            <a:endParaRPr/>
+          </a:p>
+        </p:txBody>
+      </p:sp>
+    </p:spTree>
+  </p:cSld>
+  <p:clrMapOvr>
+    <a:masterClrMapping/>
+  </p:clrMapOvr>
+</p:notes>
+</file>
+
+<file path=ppt/notesSlides/notesSlide12.xml><?xml version="1.0" encoding="utf-8"?>
+<p:notes xmlns:a="http://schemas.openxmlformats.org/drawingml/2006/main" xmlns:r="http://schemas.openxmlformats.org/officeDocument/2006/relationships" xmlns:mc="http://schemas.openxmlformats.org/markup-compatibility/2006" xmlns:mv="urn:schemas-microsoft-com:mac:vml" xmlns:p="http://schemas.openxmlformats.org/presentationml/2006/main" xmlns:c="http://schemas.openxmlformats.org/drawingml/2006/chart" xmlns:dgm="http://schemas.openxmlformats.org/drawingml/2006/diagram" xmlns:o="urn:schemas-microsoft-com:office:office" xmlns:v="urn:schemas-microsoft-com:vml" xmlns:pvml="urn:schemas-microsoft-com:office:powerpoint" xmlns:com="http://schemas.openxmlformats.org/drawingml/2006/compatibility" xmlns:p14="http://schemas.microsoft.com/office/powerpoint/2010/main" xmlns:p15="http://schemas.microsoft.com/office/powerpoint/2012/main" xmlns:ahyp="http://schemas.microsoft.com/office/drawing/2018/hyperlinkcolor" showMasterPhAnim="0" showMasterSp="0">
+  <p:cSld>
+    <p:spTree>
+      <p:nvGrpSpPr>
+        <p:cNvPr id="144" name="Shape 144"/>
+        <p:cNvGrpSpPr/>
+        <p:nvPr/>
+      </p:nvGrpSpPr>
+      <p:grpSpPr>
+        <a:xfrm>
+          <a:off x="0" y="0"/>
+          <a:ext cx="0" cy="0"/>
+          <a:chOff x="0" y="0"/>
+          <a:chExt cx="0" cy="0"/>
+        </a:xfrm>
+      </p:grpSpPr>
+      <p:sp>
+        <p:nvSpPr>
+          <p:cNvPr id="145" name="Google Shape;145;h1c371980c4f29fb2_0_10:notes"/>
+          <p:cNvSpPr/>
+          <p:nvPr>
+            <p:ph idx="2" type="sldImg"/>
+          </p:nvPr>
+        </p:nvSpPr>
+        <p:spPr>
+          <a:xfrm>
+            <a:off x="381300" y="685800"/>
+            <a:ext cx="6096000" cy="3429000"/>
+          </a:xfrm>
+          <a:custGeom>
+            <a:rect b="b" l="l" r="r" t="t"/>
+            <a:pathLst>
+              <a:path extrusionOk="0" h="120000" w="120000">
+                <a:moveTo>
+                  <a:pt x="0" y="0"/>
+                </a:moveTo>
+                <a:lnTo>
+                  <a:pt x="120000" y="0"/>
+                </a:lnTo>
+                <a:lnTo>
+                  <a:pt x="120000" y="120000"/>
+                </a:lnTo>
+                <a:lnTo>
+                  <a:pt x="0" y="120000"/>
+                </a:lnTo>
+                <a:close/>
+              </a:path>
+            </a:pathLst>
+          </a:custGeom>
+        </p:spPr>
+      </p:sp>
+      <p:sp>
+        <p:nvSpPr>
+          <p:cNvPr id="146" name="Google Shape;146;h1c371980c4f29fb2_0_10:notes"/>
+          <p:cNvSpPr txBox="1"/>
+          <p:nvPr>
+            <p:ph idx="1" type="body"/>
+          </p:nvPr>
+        </p:nvSpPr>
+        <p:spPr>
+          <a:xfrm>
+            <a:off x="685800" y="4343400"/>
+            <a:ext cx="5486400" cy="4114800"/>
+          </a:xfrm>
+          <a:prstGeom prst="rect">
+            <a:avLst/>
+          </a:prstGeom>
+        </p:spPr>
+        <p:txBody>
+          <a:bodyPr anchorCtr="0" anchor="t" bIns="91425" lIns="91425" spcFirstLastPara="1" rIns="91425" wrap="square" tIns="91425">
+            <a:noAutofit/>
+          </a:bodyPr>
+          <a:lstStyle/>
+          <a:p>
+            <a:pPr indent="0" lvl="0" marL="0" rtl="0" algn="l">
+              <a:spcBef>
+                <a:spcPts val="0"/>
+              </a:spcBef>
+              <a:spcAft>
+                <a:spcPts val="0"/>
+              </a:spcAft>
+              <a:buNone/>
+            </a:pPr>
+            <a:r>
+              <a:t/>
+            </a:r>
+            <a:endParaRPr/>
+          </a:p>
+        </p:txBody>
+      </p:sp>
+    </p:spTree>
+  </p:cSld>
+  <p:clrMapOvr>
+    <a:masterClrMapping/>
+  </p:clrMapOvr>
+</p:notes>
+</file>
+
+<file path=ppt/notesSlides/notesSlide13.xml><?xml version="1.0" encoding="utf-8"?>
+<p:notes xmlns:a="http://schemas.openxmlformats.org/drawingml/2006/main" xmlns:r="http://schemas.openxmlformats.org/officeDocument/2006/relationships" xmlns:mc="http://schemas.openxmlformats.org/markup-compatibility/2006" xmlns:mv="urn:schemas-microsoft-com:mac:vml" xmlns:p="http://schemas.openxmlformats.org/presentationml/2006/main" xmlns:c="http://schemas.openxmlformats.org/drawingml/2006/chart" xmlns:dgm="http://schemas.openxmlformats.org/drawingml/2006/diagram" xmlns:o="urn:schemas-microsoft-com:office:office" xmlns:v="urn:schemas-microsoft-com:vml" xmlns:pvml="urn:schemas-microsoft-com:office:powerpoint" xmlns:com="http://schemas.openxmlformats.org/drawingml/2006/compatibility" xmlns:p14="http://schemas.microsoft.com/office/powerpoint/2010/main" xmlns:p15="http://schemas.microsoft.com/office/powerpoint/2012/main" xmlns:ahyp="http://schemas.microsoft.com/office/drawing/2018/hyperlinkcolor" showMasterPhAnim="0" showMasterSp="0">
+  <p:cSld>
+    <p:spTree>
+      <p:nvGrpSpPr>
+        <p:cNvPr id="151" name="Shape 151"/>
+        <p:cNvGrpSpPr/>
+        <p:nvPr/>
+      </p:nvGrpSpPr>
+      <p:grpSpPr>
+        <a:xfrm>
+          <a:off x="0" y="0"/>
+          <a:ext cx="0" cy="0"/>
+          <a:chOff x="0" y="0"/>
+          <a:chExt cx="0" cy="0"/>
+        </a:xfrm>
+      </p:grpSpPr>
+      <p:sp>
+        <p:nvSpPr>
+          <p:cNvPr id="152" name="Google Shape;152;g3f58eefa86d_0_31:notes"/>
+          <p:cNvSpPr/>
+          <p:nvPr>
+            <p:ph idx="2" type="sldImg"/>
+          </p:nvPr>
+        </p:nvSpPr>
+        <p:spPr>
+          <a:xfrm>
+            <a:off x="381300" y="685800"/>
+            <a:ext cx="6096000" cy="3429000"/>
+          </a:xfrm>
+          <a:custGeom>
+            <a:rect b="b" l="l" r="r" t="t"/>
+            <a:pathLst>
+              <a:path extrusionOk="0" h="120000" w="120000">
+                <a:moveTo>
+                  <a:pt x="0" y="0"/>
+                </a:moveTo>
+                <a:lnTo>
+                  <a:pt x="120000" y="0"/>
+                </a:lnTo>
+                <a:lnTo>
+                  <a:pt x="120000" y="120000"/>
+                </a:lnTo>
+                <a:lnTo>
+                  <a:pt x="0" y="120000"/>
+                </a:lnTo>
+                <a:close/>
+              </a:path>
+            </a:pathLst>
+          </a:custGeom>
+        </p:spPr>
+      </p:sp>
+      <p:sp>
+        <p:nvSpPr>
+          <p:cNvPr id="153" name="Google Shape;153;g3f58eefa86d_0_31:notes"/>
+          <p:cNvSpPr txBox="1"/>
+          <p:nvPr>
+            <p:ph idx="1" type="body"/>
+          </p:nvPr>
+        </p:nvSpPr>
+        <p:spPr>
+          <a:xfrm>
+            <a:off x="685800" y="4343400"/>
+            <a:ext cx="5486400" cy="4114800"/>
+          </a:xfrm>
+          <a:prstGeom prst="rect">
+            <a:avLst/>
+          </a:prstGeom>
+        </p:spPr>
+        <p:txBody>
+          <a:bodyPr anchorCtr="0" anchor="t" bIns="91425" lIns="91425" spcFirstLastPara="1" rIns="91425" wrap="square" tIns="91425">
+            <a:noAutofit/>
+          </a:bodyPr>
+          <a:lstStyle/>
+          <a:p>
+            <a:pPr indent="0" lvl="0" marL="0" rtl="0" algn="l">
+              <a:spcBef>
+                <a:spcPts val="0"/>
+              </a:spcBef>
+              <a:spcAft>
+                <a:spcPts val="0"/>
+              </a:spcAft>
+              <a:buNone/>
+            </a:pPr>
+            <a:r>
+              <a:t/>
+            </a:r>
+            <a:endParaRPr/>
+          </a:p>
+        </p:txBody>
+      </p:sp>
+    </p:spTree>
+  </p:cSld>
+  <p:clrMapOvr>
+    <a:masterClrMapping/>
+  </p:clrMapOvr>
+</p:notes>
+</file>
+
+<file path=ppt/notesSlides/notesSlide14.xml><?xml version="1.0" encoding="utf-8"?>
+<p:notes xmlns:a="http://schemas.openxmlformats.org/drawingml/2006/main" xmlns:r="http://schemas.openxmlformats.org/officeDocument/2006/relationships" xmlns:mc="http://schemas.openxmlformats.org/markup-compatibility/2006" xmlns:mv="urn:schemas-microsoft-com:mac:vml" xmlns:p="http://schemas.openxmlformats.org/presentationml/2006/main" xmlns:c="http://schemas.openxmlformats.org/drawingml/2006/chart" xmlns:dgm="http://schemas.openxmlformats.org/drawingml/2006/diagram" xmlns:o="urn:schemas-microsoft-com:office:office" xmlns:v="urn:schemas-microsoft-com:vml" xmlns:pvml="urn:schemas-microsoft-com:office:powerpoint" xmlns:com="http://schemas.openxmlformats.org/drawingml/2006/compatibility" xmlns:p14="http://schemas.microsoft.com/office/powerpoint/2010/main" xmlns:p15="http://schemas.microsoft.com/office/powerpoint/2012/main" xmlns:ahyp="http://schemas.microsoft.com/office/drawing/2018/hyperlinkcolor" showMasterPhAnim="0" showMasterSp="0">
+  <p:cSld>
+    <p:spTree>
+      <p:nvGrpSpPr>
+        <p:cNvPr id="156" name="Shape 156"/>
+        <p:cNvGrpSpPr/>
+        <p:nvPr/>
+      </p:nvGrpSpPr>
+      <p:grpSpPr>
+        <a:xfrm>
+          <a:off x="0" y="0"/>
+          <a:ext cx="0" cy="0"/>
+          <a:chOff x="0" y="0"/>
+          <a:chExt cx="0" cy="0"/>
+        </a:xfrm>
+      </p:grpSpPr>
+      <p:sp>
+        <p:nvSpPr>
+          <p:cNvPr id="157" name="Google Shape;157;g3f58eefa86d_0_117:notes"/>
+          <p:cNvSpPr/>
+          <p:nvPr>
+            <p:ph idx="2" type="sldImg"/>
+          </p:nvPr>
+        </p:nvSpPr>
+        <p:spPr>
+          <a:xfrm>
+            <a:off x="381300" y="685800"/>
+            <a:ext cx="6096000" cy="3429000"/>
+          </a:xfrm>
+          <a:custGeom>
+            <a:rect b="b" l="l" r="r" t="t"/>
+            <a:pathLst>
+              <a:path extrusionOk="0" h="120000" w="120000">
+                <a:moveTo>
+                  <a:pt x="0" y="0"/>
+                </a:moveTo>
+                <a:lnTo>
+                  <a:pt x="120000" y="0"/>
+                </a:lnTo>
+                <a:lnTo>
+                  <a:pt x="120000" y="120000"/>
+                </a:lnTo>
+                <a:lnTo>
+                  <a:pt x="0" y="120000"/>
+                </a:lnTo>
+                <a:close/>
+              </a:path>
+            </a:pathLst>
+          </a:custGeom>
+        </p:spPr>
+      </p:sp>
+      <p:sp>
+        <p:nvSpPr>
+          <p:cNvPr id="158" name="Google Shape;158;g3f58eefa86d_0_117:notes"/>
+          <p:cNvSpPr txBox="1"/>
+          <p:nvPr>
+            <p:ph idx="1" type="body"/>
+          </p:nvPr>
+        </p:nvSpPr>
+        <p:spPr>
+          <a:xfrm>
+            <a:off x="685800" y="4343400"/>
+            <a:ext cx="5486400" cy="4114800"/>
+          </a:xfrm>
+          <a:prstGeom prst="rect">
+            <a:avLst/>
+          </a:prstGeom>
+        </p:spPr>
+        <p:txBody>
+          <a:bodyPr anchorCtr="0" anchor="t" bIns="91425" lIns="91425" spcFirstLastPara="1" rIns="91425" wrap="square" tIns="91425">
+            <a:noAutofit/>
+          </a:bodyPr>
+          <a:lstStyle/>
+          <a:p>
+            <a:pPr indent="0" lvl="0" marL="0" rtl="0" algn="l">
+              <a:spcBef>
+                <a:spcPts val="0"/>
+              </a:spcBef>
+              <a:spcAft>
+                <a:spcPts val="0"/>
+              </a:spcAft>
+              <a:buNone/>
+            </a:pPr>
+            <a:r>
+              <a:t/>
+            </a:r>
+            <a:endParaRPr/>
+          </a:p>
+        </p:txBody>
+      </p:sp>
+    </p:spTree>
+  </p:cSld>
+  <p:clrMapOvr>
+    <a:masterClrMapping/>
+  </p:clrMapOvr>
+</p:notes>
+</file>
+
+<file path=ppt/notesSlides/notesSlide15.xml><?xml version="1.0" encoding="utf-8"?>
+<p:notes xmlns:a="http://schemas.openxmlformats.org/drawingml/2006/main" xmlns:r="http://schemas.openxmlformats.org/officeDocument/2006/relationships" xmlns:mc="http://schemas.openxmlformats.org/markup-compatibility/2006" xmlns:mv="urn:schemas-microsoft-com:mac:vml" xmlns:p="http://schemas.openxmlformats.org/presentationml/2006/main" xmlns:c="http://schemas.openxmlformats.org/drawingml/2006/chart" xmlns:dgm="http://schemas.openxmlformats.org/drawingml/2006/diagram" xmlns:o="urn:schemas-microsoft-com:office:office" xmlns:v="urn:schemas-microsoft-com:vml" xmlns:pvml="urn:schemas-microsoft-com:office:powerpoint" xmlns:com="http://schemas.openxmlformats.org/drawingml/2006/compatibility" xmlns:p14="http://schemas.microsoft.com/office/powerpoint/2010/main" xmlns:p15="http://schemas.microsoft.com/office/powerpoint/2012/main" xmlns:ahyp="http://schemas.microsoft.com/office/drawing/2018/hyperlinkcolor" showMasterPhAnim="0" showMasterSp="0">
+  <p:cSld>
+    <p:spTree>
+      <p:nvGrpSpPr>
+        <p:cNvPr id="163" name="Shape 163"/>
+        <p:cNvGrpSpPr/>
+        <p:nvPr/>
+      </p:nvGrpSpPr>
+      <p:grpSpPr>
+        <a:xfrm>
+          <a:off x="0" y="0"/>
+          <a:ext cx="0" cy="0"/>
+          <a:chOff x="0" y="0"/>
+          <a:chExt cx="0" cy="0"/>
+        </a:xfrm>
+      </p:grpSpPr>
+      <p:sp>
+        <p:nvSpPr>
+          <p:cNvPr id="164" name="Google Shape;164;g3f58eefa86d_0_108:notes"/>
+          <p:cNvSpPr/>
+          <p:nvPr>
+            <p:ph idx="2" type="sldImg"/>
+          </p:nvPr>
+        </p:nvSpPr>
+        <p:spPr>
+          <a:xfrm>
+            <a:off x="381300" y="685800"/>
+            <a:ext cx="6096000" cy="3429000"/>
+          </a:xfrm>
+          <a:custGeom>
+            <a:rect b="b" l="l" r="r" t="t"/>
+            <a:pathLst>
+              <a:path extrusionOk="0" h="120000" w="120000">
+                <a:moveTo>
+                  <a:pt x="0" y="0"/>
+                </a:moveTo>
+                <a:lnTo>
+                  <a:pt x="120000" y="0"/>
+                </a:lnTo>
+                <a:lnTo>
+                  <a:pt x="120000" y="120000"/>
+                </a:lnTo>
+                <a:lnTo>
+                  <a:pt x="0" y="120000"/>
+                </a:lnTo>
+                <a:close/>
+              </a:path>
+            </a:pathLst>
+          </a:custGeom>
+        </p:spPr>
+      </p:sp>
+      <p:sp>
+        <p:nvSpPr>
+          <p:cNvPr id="165" name="Google Shape;165;g3f58eefa86d_0_108:notes"/>
           <p:cNvSpPr txBox="1"/>
           <p:nvPr>
             <p:ph idx="1" type="body"/>
@@ -1606,7 +2030,7 @@
       </p:grpSpPr>
       <p:sp>
         <p:nvSpPr>
-          <p:cNvPr id="104" name="Google Shape;104;g3f58eefa86d_0_9:notes"/>
+          <p:cNvPr id="104" name="Google Shape;104;h4ebe40c7f8899e75_0_8:notes"/>
           <p:cNvSpPr/>
           <p:nvPr>
             <p:ph idx="2" type="sldImg"/>
@@ -1641,7 +2065,7 @@
       </p:sp>
       <p:sp>
         <p:nvSpPr>
-          <p:cNvPr id="105" name="Google Shape;105;g3f58eefa86d_0_9:notes"/>
+          <p:cNvPr id="105" name="Google Shape;105;h4ebe40c7f8899e75_0_8:notes"/>
           <p:cNvSpPr txBox="1"/>
           <p:nvPr>
             <p:ph idx="1" type="body"/>
@@ -1691,7 +2115,7 @@
   <p:cSld>
     <p:spTree>
       <p:nvGrpSpPr>
-        <p:cNvPr id="126" name="Shape 126"/>
+        <p:cNvPr id="108" name="Shape 108"/>
         <p:cNvGrpSpPr/>
         <p:nvPr/>
       </p:nvGrpSpPr>
@@ -1705,7 +2129,7 @@
       </p:grpSpPr>
       <p:sp>
         <p:nvSpPr>
-          <p:cNvPr id="127" name="Google Shape;127;g3f58eefa86d_0_31:notes"/>
+          <p:cNvPr id="109" name="Google Shape;109;h4ebe40c7f8899e75_0_0:notes"/>
           <p:cNvSpPr/>
           <p:nvPr>
             <p:ph idx="2" type="sldImg"/>
@@ -1740,7 +2164,7 @@
       </p:sp>
       <p:sp>
         <p:nvSpPr>
-          <p:cNvPr id="128" name="Google Shape;128;g3f58eefa86d_0_31:notes"/>
+          <p:cNvPr id="110" name="Google Shape;110;h4ebe40c7f8899e75_0_0:notes"/>
           <p:cNvSpPr txBox="1"/>
           <p:nvPr>
             <p:ph idx="1" type="body"/>
@@ -6765,7 +7189,7 @@
   <p:cSld>
     <p:spTree>
       <p:nvGrpSpPr>
-        <p:cNvPr id="151" name="Shape 151"/>
+        <p:cNvPr id="117" name="Shape 117"/>
         <p:cNvGrpSpPr/>
         <p:nvPr/>
       </p:nvGrpSpPr>
@@ -6779,35 +7203,7 @@
       </p:grpSpPr>
       <p:pic>
         <p:nvPicPr>
-          <p:cNvPr id="152" name="Google Shape;152;p22" title="GSEA_top_pathway_rep1.jpg"/>
-          <p:cNvPicPr preferRelativeResize="0"/>
-          <p:nvPr/>
-        </p:nvPicPr>
-        <p:blipFill>
-          <a:blip r:embed="rId3">
-            <a:alphaModFix/>
-          </a:blip>
-          <a:stretch>
-            <a:fillRect/>
-          </a:stretch>
-        </p:blipFill>
-        <p:spPr>
-          <a:xfrm>
-            <a:off x="4091150" y="2046550"/>
-            <a:ext cx="3154673" cy="2366001"/>
-          </a:xfrm>
-          <a:prstGeom prst="rect">
-            <a:avLst/>
-          </a:prstGeom>
-          <a:noFill/>
-          <a:ln>
-            <a:noFill/>
-          </a:ln>
-        </p:spPr>
-      </p:pic>
-      <p:pic>
-        <p:nvPicPr>
-          <p:cNvPr id="153" name="Google Shape;153;p22" title="remap_act.jpg"/>
+          <p:cNvPr id="118" name="Google Shape;118;p22" title="kmeros_efecto_vs_cpg.jpg"/>
           <p:cNvPicPr preferRelativeResize="0"/>
           <p:nvPr/>
         </p:nvPicPr>
@@ -6821,8 +7217,8 @@
         </p:blipFill>
         <p:spPr>
           <a:xfrm>
-            <a:off x="0" y="0"/>
-            <a:ext cx="3946076" cy="2959549"/>
+            <a:off x="0" y="-1"/>
+            <a:ext cx="5610598" cy="2372450"/>
           </a:xfrm>
           <a:prstGeom prst="rect">
             <a:avLst/>
@@ -6835,7 +7231,7 @@
       </p:pic>
       <p:pic>
         <p:nvPicPr>
-          <p:cNvPr id="154" name="Google Shape;154;p22" title="remap_act_low.jpg"/>
+          <p:cNvPr id="119" name="Google Shape;119;p22" title="ebox_zeb_scatter_cgi.jpg"/>
           <p:cNvPicPr preferRelativeResize="0"/>
           <p:nvPr/>
         </p:nvPicPr>
@@ -6849,8 +7245,36 @@
         </p:blipFill>
         <p:spPr>
           <a:xfrm>
-            <a:off x="3946074" y="2"/>
-            <a:ext cx="2235203" cy="1986362"/>
+            <a:off x="152400" y="2524849"/>
+            <a:ext cx="4384445" cy="2466251"/>
+          </a:xfrm>
+          <a:prstGeom prst="rect">
+            <a:avLst/>
+          </a:prstGeom>
+          <a:noFill/>
+          <a:ln>
+            <a:noFill/>
+          </a:ln>
+        </p:spPr>
+      </p:pic>
+      <p:pic>
+        <p:nvPicPr>
+          <p:cNvPr id="120" name="Google Shape;120;p22" title="kmeros_volcano_motivos.jpg"/>
+          <p:cNvPicPr preferRelativeResize="0"/>
+          <p:nvPr/>
+        </p:nvPicPr>
+        <p:blipFill>
+          <a:blip r:embed="rId6">
+            <a:alphaModFix/>
+          </a:blip>
+          <a:stretch>
+            <a:fillRect/>
+          </a:stretch>
+        </p:blipFill>
+        <p:spPr>
+          <a:xfrm>
+            <a:off x="5762998" y="152400"/>
+            <a:ext cx="3228600" cy="2536532"/>
           </a:xfrm>
           <a:prstGeom prst="rect">
             <a:avLst/>
@@ -6874,7 +7298,7 @@
   <p:cSld>
     <p:spTree>
       <p:nvGrpSpPr>
-        <p:cNvPr id="158" name="Shape 158"/>
+        <p:cNvPr id="124" name="Shape 124"/>
         <p:cNvGrpSpPr/>
         <p:nvPr/>
       </p:nvGrpSpPr>
@@ -6888,7 +7312,1129 @@
       </p:grpSpPr>
       <p:pic>
         <p:nvPicPr>
-          <p:cNvPr id="159" name="Google Shape;159;p23" title="nfya_scatter_intersect.jpg"/>
+          <p:cNvPr id="125" name="Google Shape;125;p23"/>
+          <p:cNvPicPr preferRelativeResize="0"/>
+          <p:nvPr/>
+        </p:nvPicPr>
+        <p:blipFill rotWithShape="1">
+          <a:blip r:embed="rId3">
+            <a:alphaModFix/>
+          </a:blip>
+          <a:srcRect b="0" l="0" r="0" t="9000"/>
+          <a:stretch/>
+        </p:blipFill>
+        <p:spPr>
+          <a:xfrm>
+            <a:off x="152400" y="546500"/>
+            <a:ext cx="7048201" cy="3982901"/>
+          </a:xfrm>
+          <a:prstGeom prst="rect">
+            <a:avLst/>
+          </a:prstGeom>
+          <a:noFill/>
+          <a:ln>
+            <a:noFill/>
+          </a:ln>
+        </p:spPr>
+      </p:pic>
+      <p:sp>
+        <p:nvSpPr>
+          <p:cNvPr id="126" name="Google Shape;126;p23"/>
+          <p:cNvSpPr txBox="1"/>
+          <p:nvPr/>
+        </p:nvSpPr>
+        <p:spPr>
+          <a:xfrm>
+            <a:off x="3835025" y="4343400"/>
+            <a:ext cx="2601600" cy="276900"/>
+          </a:xfrm>
+          <a:prstGeom prst="rect">
+            <a:avLst/>
+          </a:prstGeom>
+          <a:solidFill>
+            <a:schemeClr val="lt1"/>
+          </a:solidFill>
+          <a:ln>
+            <a:noFill/>
+          </a:ln>
+        </p:spPr>
+        <p:txBody>
+          <a:bodyPr anchorCtr="0" anchor="t" bIns="91425" lIns="91425" spcFirstLastPara="1" rIns="91425" wrap="square" tIns="0">
+            <a:spAutoFit/>
+          </a:bodyPr>
+          <a:lstStyle/>
+          <a:p>
+            <a:pPr indent="0" lvl="0" marL="0" rtl="0" algn="l">
+              <a:spcBef>
+                <a:spcPts val="0"/>
+              </a:spcBef>
+              <a:spcAft>
+                <a:spcPts val="0"/>
+              </a:spcAft>
+              <a:buNone/>
+            </a:pPr>
+            <a:r>
+              <a:rPr b="1" lang="es-419" sz="1200">
+                <a:solidFill>
+                  <a:schemeClr val="dk2"/>
+                </a:solidFill>
+              </a:rPr>
+              <a:t>Efecto sobre la actividad media</a:t>
+            </a:r>
+            <a:endParaRPr b="1" sz="1200">
+              <a:solidFill>
+                <a:schemeClr val="dk2"/>
+              </a:solidFill>
+            </a:endParaRPr>
+          </a:p>
+        </p:txBody>
+      </p:sp>
+      <p:sp>
+        <p:nvSpPr>
+          <p:cNvPr id="127" name="Google Shape;127;p23"/>
+          <p:cNvSpPr txBox="1"/>
+          <p:nvPr/>
+        </p:nvSpPr>
+        <p:spPr>
+          <a:xfrm>
+            <a:off x="3465653" y="454825"/>
+            <a:ext cx="1005300" cy="361800"/>
+          </a:xfrm>
+          <a:prstGeom prst="rect">
+            <a:avLst/>
+          </a:prstGeom>
+          <a:solidFill>
+            <a:schemeClr val="lt1"/>
+          </a:solidFill>
+          <a:ln>
+            <a:noFill/>
+          </a:ln>
+        </p:spPr>
+        <p:txBody>
+          <a:bodyPr anchorCtr="0" anchor="t" bIns="91425" lIns="0" spcFirstLastPara="1" rIns="0" wrap="square" tIns="91425">
+            <a:spAutoFit/>
+          </a:bodyPr>
+          <a:lstStyle/>
+          <a:p>
+            <a:pPr indent="0" lvl="0" marL="0" rtl="0" algn="l">
+              <a:spcBef>
+                <a:spcPts val="0"/>
+              </a:spcBef>
+              <a:spcAft>
+                <a:spcPts val="0"/>
+              </a:spcAft>
+              <a:buNone/>
+            </a:pPr>
+            <a:r>
+              <a:rPr b="1" lang="es-419" sz="1150">
+                <a:solidFill>
+                  <a:schemeClr val="dk2"/>
+                </a:solidFill>
+              </a:rPr>
+              <a:t>Alta actividad</a:t>
+            </a:r>
+            <a:endParaRPr b="1" sz="1150">
+              <a:solidFill>
+                <a:schemeClr val="dk2"/>
+              </a:solidFill>
+            </a:endParaRPr>
+          </a:p>
+        </p:txBody>
+      </p:sp>
+      <p:sp>
+        <p:nvSpPr>
+          <p:cNvPr id="128" name="Google Shape;128;p23"/>
+          <p:cNvSpPr txBox="1"/>
+          <p:nvPr/>
+        </p:nvSpPr>
+        <p:spPr>
+          <a:xfrm>
+            <a:off x="3142325" y="248494"/>
+            <a:ext cx="692700" cy="369300"/>
+          </a:xfrm>
+          <a:prstGeom prst="rect">
+            <a:avLst/>
+          </a:prstGeom>
+          <a:noFill/>
+          <a:ln>
+            <a:noFill/>
+          </a:ln>
+        </p:spPr>
+        <p:txBody>
+          <a:bodyPr anchorCtr="0" anchor="t" bIns="91425" lIns="91425" spcFirstLastPara="1" rIns="91425" wrap="square" tIns="91425">
+            <a:spAutoFit/>
+          </a:bodyPr>
+          <a:lstStyle/>
+          <a:p>
+            <a:pPr indent="0" lvl="0" marL="0" rtl="0" algn="l">
+              <a:spcBef>
+                <a:spcPts val="0"/>
+              </a:spcBef>
+              <a:spcAft>
+                <a:spcPts val="0"/>
+              </a:spcAft>
+              <a:buNone/>
+            </a:pPr>
+            <a:r>
+              <a:rPr b="1" lang="es-419" sz="1200">
+                <a:solidFill>
+                  <a:schemeClr val="dk2"/>
+                </a:solidFill>
+              </a:rPr>
+              <a:t>Efecto</a:t>
+            </a:r>
+            <a:endParaRPr b="1" sz="1200">
+              <a:solidFill>
+                <a:schemeClr val="dk2"/>
+              </a:solidFill>
+            </a:endParaRPr>
+          </a:p>
+        </p:txBody>
+      </p:sp>
+      <p:sp>
+        <p:nvSpPr>
+          <p:cNvPr id="129" name="Google Shape;129;p23"/>
+          <p:cNvSpPr txBox="1"/>
+          <p:nvPr/>
+        </p:nvSpPr>
+        <p:spPr>
+          <a:xfrm>
+            <a:off x="4674460" y="452422"/>
+            <a:ext cx="1005300" cy="361800"/>
+          </a:xfrm>
+          <a:prstGeom prst="rect">
+            <a:avLst/>
+          </a:prstGeom>
+          <a:solidFill>
+            <a:schemeClr val="lt1"/>
+          </a:solidFill>
+          <a:ln>
+            <a:noFill/>
+          </a:ln>
+        </p:spPr>
+        <p:txBody>
+          <a:bodyPr anchorCtr="0" anchor="t" bIns="91425" lIns="0" spcFirstLastPara="1" rIns="0" wrap="square" tIns="91425">
+            <a:spAutoFit/>
+          </a:bodyPr>
+          <a:lstStyle/>
+          <a:p>
+            <a:pPr indent="0" lvl="0" marL="0" rtl="0" algn="l">
+              <a:spcBef>
+                <a:spcPts val="0"/>
+              </a:spcBef>
+              <a:spcAft>
+                <a:spcPts val="0"/>
+              </a:spcAft>
+              <a:buNone/>
+            </a:pPr>
+            <a:r>
+              <a:rPr b="1" lang="es-419" sz="1150">
+                <a:solidFill>
+                  <a:schemeClr val="dk2"/>
+                </a:solidFill>
+              </a:rPr>
+              <a:t>Baja actividad</a:t>
+            </a:r>
+            <a:endParaRPr b="1" sz="1150">
+              <a:solidFill>
+                <a:schemeClr val="dk2"/>
+              </a:solidFill>
+            </a:endParaRPr>
+          </a:p>
+        </p:txBody>
+      </p:sp>
+      <p:sp>
+        <p:nvSpPr>
+          <p:cNvPr id="130" name="Google Shape;130;p23"/>
+          <p:cNvSpPr txBox="1"/>
+          <p:nvPr/>
+        </p:nvSpPr>
+        <p:spPr>
+          <a:xfrm>
+            <a:off x="781900" y="233289"/>
+            <a:ext cx="1237200" cy="715800"/>
+          </a:xfrm>
+          <a:prstGeom prst="rect">
+            <a:avLst/>
+          </a:prstGeom>
+          <a:solidFill>
+            <a:schemeClr val="lt1"/>
+          </a:solidFill>
+          <a:ln>
+            <a:noFill/>
+          </a:ln>
+        </p:spPr>
+        <p:txBody>
+          <a:bodyPr anchorCtr="0" anchor="t" bIns="91425" lIns="0" spcFirstLastPara="1" rIns="0" wrap="square" tIns="91425">
+            <a:spAutoFit/>
+          </a:bodyPr>
+          <a:lstStyle/>
+          <a:p>
+            <a:pPr indent="0" lvl="0" marL="0" rtl="0" algn="ctr">
+              <a:spcBef>
+                <a:spcPts val="0"/>
+              </a:spcBef>
+              <a:spcAft>
+                <a:spcPts val="0"/>
+              </a:spcAft>
+              <a:buNone/>
+            </a:pPr>
+            <a:r>
+              <a:rPr b="1" lang="es-419" sz="1150">
+                <a:solidFill>
+                  <a:schemeClr val="dk2"/>
+                </a:solidFill>
+              </a:rPr>
+              <a:t>Características basadas en la secuencia</a:t>
+            </a:r>
+            <a:endParaRPr b="1" sz="1150">
+              <a:solidFill>
+                <a:schemeClr val="dk2"/>
+              </a:solidFill>
+            </a:endParaRPr>
+          </a:p>
+        </p:txBody>
+      </p:sp>
+      <p:sp>
+        <p:nvSpPr>
+          <p:cNvPr id="131" name="Google Shape;131;p23"/>
+          <p:cNvSpPr txBox="1"/>
+          <p:nvPr/>
+        </p:nvSpPr>
+        <p:spPr>
+          <a:xfrm>
+            <a:off x="920600" y="1229375"/>
+            <a:ext cx="1351800" cy="215400"/>
+          </a:xfrm>
+          <a:prstGeom prst="rect">
+            <a:avLst/>
+          </a:prstGeom>
+          <a:solidFill>
+            <a:schemeClr val="lt1"/>
+          </a:solidFill>
+          <a:ln>
+            <a:noFill/>
+          </a:ln>
+        </p:spPr>
+        <p:txBody>
+          <a:bodyPr anchorCtr="0" anchor="t" bIns="0" lIns="91425" spcFirstLastPara="1" rIns="91425" wrap="square" tIns="0">
+            <a:spAutoFit/>
+          </a:bodyPr>
+          <a:lstStyle/>
+          <a:p>
+            <a:pPr indent="0" lvl="0" marL="0" rtl="0" algn="l">
+              <a:spcBef>
+                <a:spcPts val="0"/>
+              </a:spcBef>
+              <a:spcAft>
+                <a:spcPts val="0"/>
+              </a:spcAft>
+              <a:buNone/>
+            </a:pPr>
+            <a:r>
+              <a:rPr lang="es-419">
+                <a:solidFill>
+                  <a:srgbClr val="F37336"/>
+                </a:solidFill>
+              </a:rPr>
+              <a:t>Isla CpG</a:t>
+            </a:r>
+            <a:endParaRPr>
+              <a:solidFill>
+                <a:srgbClr val="F37336"/>
+              </a:solidFill>
+            </a:endParaRPr>
+          </a:p>
+        </p:txBody>
+      </p:sp>
+      <p:sp>
+        <p:nvSpPr>
+          <p:cNvPr id="132" name="Google Shape;132;p23"/>
+          <p:cNvSpPr txBox="1"/>
+          <p:nvPr/>
+        </p:nvSpPr>
+        <p:spPr>
+          <a:xfrm>
+            <a:off x="2344825" y="1810225"/>
+            <a:ext cx="5944500" cy="461700"/>
+          </a:xfrm>
+          <a:prstGeom prst="rect">
+            <a:avLst/>
+          </a:prstGeom>
+          <a:noFill/>
+          <a:ln>
+            <a:noFill/>
+          </a:ln>
+        </p:spPr>
+        <p:txBody>
+          <a:bodyPr anchorCtr="0" anchor="t" bIns="91425" lIns="91425" spcFirstLastPara="1" rIns="91425" wrap="square" tIns="91425">
+            <a:spAutoFit/>
+          </a:bodyPr>
+          <a:lstStyle/>
+          <a:p>
+            <a:pPr indent="0" lvl="0" marL="0" rtl="0" algn="l">
+              <a:spcBef>
+                <a:spcPts val="0"/>
+              </a:spcBef>
+              <a:spcAft>
+                <a:spcPts val="0"/>
+              </a:spcAft>
+              <a:buNone/>
+            </a:pPr>
+            <a:r>
+              <a:t/>
+            </a:r>
+            <a:endParaRPr sz="1800">
+              <a:solidFill>
+                <a:schemeClr val="dk2"/>
+              </a:solidFill>
+            </a:endParaRPr>
+          </a:p>
+        </p:txBody>
+      </p:sp>
+      <p:sp>
+        <p:nvSpPr>
+          <p:cNvPr id="133" name="Google Shape;133;p23"/>
+          <p:cNvSpPr txBox="1"/>
+          <p:nvPr/>
+        </p:nvSpPr>
+        <p:spPr>
+          <a:xfrm>
+            <a:off x="813075" y="991850"/>
+            <a:ext cx="1351800" cy="215400"/>
+          </a:xfrm>
+          <a:prstGeom prst="rect">
+            <a:avLst/>
+          </a:prstGeom>
+          <a:solidFill>
+            <a:schemeClr val="lt1"/>
+          </a:solidFill>
+          <a:ln>
+            <a:noFill/>
+          </a:ln>
+        </p:spPr>
+        <p:txBody>
+          <a:bodyPr anchorCtr="0" anchor="t" bIns="0" lIns="91425" spcFirstLastPara="1" rIns="91425" wrap="square" tIns="0">
+            <a:spAutoFit/>
+          </a:bodyPr>
+          <a:lstStyle/>
+          <a:p>
+            <a:pPr indent="0" lvl="0" marL="0" rtl="0" algn="l">
+              <a:spcBef>
+                <a:spcPts val="0"/>
+              </a:spcBef>
+              <a:spcAft>
+                <a:spcPts val="0"/>
+              </a:spcAft>
+              <a:buNone/>
+            </a:pPr>
+            <a:r>
+              <a:rPr lang="es-419">
+                <a:solidFill>
+                  <a:srgbClr val="F37336"/>
+                </a:solidFill>
+              </a:rPr>
+              <a:t>   CCAAT</a:t>
+            </a:r>
+            <a:endParaRPr>
+              <a:solidFill>
+                <a:srgbClr val="F37336"/>
+              </a:solidFill>
+            </a:endParaRPr>
+          </a:p>
+        </p:txBody>
+      </p:sp>
+      <p:sp>
+        <p:nvSpPr>
+          <p:cNvPr id="134" name="Google Shape;134;p23"/>
+          <p:cNvSpPr txBox="1"/>
+          <p:nvPr/>
+        </p:nvSpPr>
+        <p:spPr>
+          <a:xfrm>
+            <a:off x="884822" y="1503213"/>
+            <a:ext cx="1351800" cy="215400"/>
+          </a:xfrm>
+          <a:prstGeom prst="rect">
+            <a:avLst/>
+          </a:prstGeom>
+          <a:solidFill>
+            <a:schemeClr val="lt1"/>
+          </a:solidFill>
+          <a:ln>
+            <a:noFill/>
+          </a:ln>
+        </p:spPr>
+        <p:txBody>
+          <a:bodyPr anchorCtr="0" anchor="t" bIns="0" lIns="91425" spcFirstLastPara="1" rIns="91425" wrap="square" tIns="0">
+            <a:spAutoFit/>
+          </a:bodyPr>
+          <a:lstStyle/>
+          <a:p>
+            <a:pPr indent="0" lvl="0" marL="0" rtl="0" algn="l">
+              <a:spcBef>
+                <a:spcPts val="0"/>
+              </a:spcBef>
+              <a:spcAft>
+                <a:spcPts val="0"/>
+              </a:spcAft>
+              <a:buNone/>
+            </a:pPr>
+            <a:r>
+              <a:rPr lang="es-419">
+                <a:solidFill>
+                  <a:srgbClr val="F37336"/>
+                </a:solidFill>
+              </a:rPr>
+              <a:t>TATA-box</a:t>
+            </a:r>
+            <a:endParaRPr>
+              <a:solidFill>
+                <a:srgbClr val="F37336"/>
+              </a:solidFill>
+            </a:endParaRPr>
+          </a:p>
+        </p:txBody>
+      </p:sp>
+      <p:sp>
+        <p:nvSpPr>
+          <p:cNvPr id="135" name="Google Shape;135;p23"/>
+          <p:cNvSpPr txBox="1"/>
+          <p:nvPr/>
+        </p:nvSpPr>
+        <p:spPr>
+          <a:xfrm>
+            <a:off x="942002" y="1766743"/>
+            <a:ext cx="1351800" cy="215400"/>
+          </a:xfrm>
+          <a:prstGeom prst="rect">
+            <a:avLst/>
+          </a:prstGeom>
+          <a:solidFill>
+            <a:schemeClr val="lt1"/>
+          </a:solidFill>
+          <a:ln>
+            <a:noFill/>
+          </a:ln>
+        </p:spPr>
+        <p:txBody>
+          <a:bodyPr anchorCtr="0" anchor="t" bIns="0" lIns="91425" spcFirstLastPara="1" rIns="91425" wrap="square" tIns="0">
+            <a:spAutoFit/>
+          </a:bodyPr>
+          <a:lstStyle/>
+          <a:p>
+            <a:pPr indent="0" lvl="0" marL="0" rtl="0" algn="l">
+              <a:spcBef>
+                <a:spcPts val="0"/>
+              </a:spcBef>
+              <a:spcAft>
+                <a:spcPts val="0"/>
+              </a:spcAft>
+              <a:buNone/>
+            </a:pPr>
+            <a:r>
+              <a:rPr lang="es-419">
+                <a:solidFill>
+                  <a:srgbClr val="F37336"/>
+                </a:solidFill>
+              </a:rPr>
+              <a:t>GC-box</a:t>
+            </a:r>
+            <a:endParaRPr>
+              <a:solidFill>
+                <a:srgbClr val="F37336"/>
+              </a:solidFill>
+            </a:endParaRPr>
+          </a:p>
+        </p:txBody>
+      </p:sp>
+      <p:sp>
+        <p:nvSpPr>
+          <p:cNvPr id="136" name="Google Shape;136;p23"/>
+          <p:cNvSpPr txBox="1"/>
+          <p:nvPr/>
+        </p:nvSpPr>
+        <p:spPr>
+          <a:xfrm>
+            <a:off x="373593" y="2030275"/>
+            <a:ext cx="2053800" cy="215400"/>
+          </a:xfrm>
+          <a:prstGeom prst="rect">
+            <a:avLst/>
+          </a:prstGeom>
+          <a:solidFill>
+            <a:schemeClr val="lt1"/>
+          </a:solidFill>
+          <a:ln>
+            <a:noFill/>
+          </a:ln>
+        </p:spPr>
+        <p:txBody>
+          <a:bodyPr anchorCtr="0" anchor="t" bIns="0" lIns="91425" spcFirstLastPara="1" rIns="91425" wrap="square" tIns="0">
+            <a:spAutoFit/>
+          </a:bodyPr>
+          <a:lstStyle/>
+          <a:p>
+            <a:pPr indent="0" lvl="0" marL="0" rtl="0" algn="l">
+              <a:spcBef>
+                <a:spcPts val="0"/>
+              </a:spcBef>
+              <a:spcAft>
+                <a:spcPts val="0"/>
+              </a:spcAft>
+              <a:buNone/>
+            </a:pPr>
+            <a:r>
+              <a:rPr lang="es-419">
+                <a:solidFill>
+                  <a:srgbClr val="F37336"/>
+                </a:solidFill>
+              </a:rPr>
+              <a:t>Alto contenido en G+C</a:t>
+            </a:r>
+            <a:endParaRPr>
+              <a:solidFill>
+                <a:srgbClr val="F37336"/>
+              </a:solidFill>
+            </a:endParaRPr>
+          </a:p>
+        </p:txBody>
+      </p:sp>
+      <p:sp>
+        <p:nvSpPr>
+          <p:cNvPr id="137" name="Google Shape;137;p23"/>
+          <p:cNvSpPr txBox="1"/>
+          <p:nvPr/>
+        </p:nvSpPr>
+        <p:spPr>
+          <a:xfrm>
+            <a:off x="801991" y="2269278"/>
+            <a:ext cx="1351800" cy="215400"/>
+          </a:xfrm>
+          <a:prstGeom prst="rect">
+            <a:avLst/>
+          </a:prstGeom>
+          <a:solidFill>
+            <a:schemeClr val="lt1"/>
+          </a:solidFill>
+          <a:ln>
+            <a:noFill/>
+          </a:ln>
+        </p:spPr>
+        <p:txBody>
+          <a:bodyPr anchorCtr="0" anchor="t" bIns="0" lIns="91425" spcFirstLastPara="1" rIns="91425" wrap="square" tIns="0">
+            <a:spAutoFit/>
+          </a:bodyPr>
+          <a:lstStyle/>
+          <a:p>
+            <a:pPr indent="0" lvl="0" marL="0" rtl="0" algn="l">
+              <a:spcBef>
+                <a:spcPts val="0"/>
+              </a:spcBef>
+              <a:spcAft>
+                <a:spcPts val="0"/>
+              </a:spcAft>
+              <a:buNone/>
+            </a:pPr>
+            <a:r>
+              <a:rPr lang="es-419">
+                <a:solidFill>
+                  <a:srgbClr val="F37336"/>
+                </a:solidFill>
+              </a:rPr>
+              <a:t>CG en TSS</a:t>
+            </a:r>
+            <a:endParaRPr>
+              <a:solidFill>
+                <a:srgbClr val="F37336"/>
+              </a:solidFill>
+            </a:endParaRPr>
+          </a:p>
+        </p:txBody>
+      </p:sp>
+      <p:sp>
+        <p:nvSpPr>
+          <p:cNvPr id="138" name="Google Shape;138;p23"/>
+          <p:cNvSpPr txBox="1"/>
+          <p:nvPr/>
+        </p:nvSpPr>
+        <p:spPr>
+          <a:xfrm>
+            <a:off x="1095665" y="2508259"/>
+            <a:ext cx="1351800" cy="215400"/>
+          </a:xfrm>
+          <a:prstGeom prst="rect">
+            <a:avLst/>
+          </a:prstGeom>
+          <a:solidFill>
+            <a:schemeClr val="lt1"/>
+          </a:solidFill>
+          <a:ln>
+            <a:noFill/>
+          </a:ln>
+        </p:spPr>
+        <p:txBody>
+          <a:bodyPr anchorCtr="0" anchor="t" bIns="0" lIns="91425" spcFirstLastPara="1" rIns="91425" wrap="square" tIns="0">
+            <a:spAutoFit/>
+          </a:bodyPr>
+          <a:lstStyle/>
+          <a:p>
+            <a:pPr indent="0" lvl="0" marL="0" rtl="0" algn="l">
+              <a:spcBef>
+                <a:spcPts val="0"/>
+              </a:spcBef>
+              <a:spcAft>
+                <a:spcPts val="0"/>
+              </a:spcAft>
+              <a:buNone/>
+            </a:pPr>
+            <a:r>
+              <a:rPr lang="es-419">
+                <a:solidFill>
+                  <a:srgbClr val="F37336"/>
+                </a:solidFill>
+              </a:rPr>
+              <a:t>TCT</a:t>
+            </a:r>
+            <a:endParaRPr>
+              <a:solidFill>
+                <a:srgbClr val="F37336"/>
+              </a:solidFill>
+            </a:endParaRPr>
+          </a:p>
+        </p:txBody>
+      </p:sp>
+      <p:sp>
+        <p:nvSpPr>
+          <p:cNvPr id="139" name="Google Shape;139;p23"/>
+          <p:cNvSpPr txBox="1"/>
+          <p:nvPr/>
+        </p:nvSpPr>
+        <p:spPr>
+          <a:xfrm>
+            <a:off x="386175" y="2773823"/>
+            <a:ext cx="2205600" cy="288300"/>
+          </a:xfrm>
+          <a:prstGeom prst="rect">
+            <a:avLst/>
+          </a:prstGeom>
+          <a:solidFill>
+            <a:schemeClr val="lt1"/>
+          </a:solidFill>
+          <a:ln>
+            <a:noFill/>
+          </a:ln>
+        </p:spPr>
+        <p:txBody>
+          <a:bodyPr anchorCtr="0" anchor="t" bIns="72000" lIns="91425" spcFirstLastPara="1" rIns="91425" wrap="square" tIns="0">
+            <a:spAutoFit/>
+          </a:bodyPr>
+          <a:lstStyle/>
+          <a:p>
+            <a:pPr indent="0" lvl="0" marL="0" rtl="0" algn="l">
+              <a:spcBef>
+                <a:spcPts val="0"/>
+              </a:spcBef>
+              <a:spcAft>
+                <a:spcPts val="0"/>
+              </a:spcAft>
+              <a:buNone/>
+            </a:pPr>
+            <a:r>
+              <a:rPr lang="es-419">
+                <a:solidFill>
+                  <a:srgbClr val="24A35F"/>
+                </a:solidFill>
+              </a:rPr>
+              <a:t>Elementos transponibles</a:t>
+            </a:r>
+            <a:endParaRPr>
+              <a:solidFill>
+                <a:srgbClr val="24A35F"/>
+              </a:solidFill>
+            </a:endParaRPr>
+          </a:p>
+        </p:txBody>
+      </p:sp>
+      <p:sp>
+        <p:nvSpPr>
+          <p:cNvPr id="140" name="Google Shape;140;p23"/>
+          <p:cNvSpPr txBox="1"/>
+          <p:nvPr/>
+        </p:nvSpPr>
+        <p:spPr>
+          <a:xfrm>
+            <a:off x="572050" y="3052022"/>
+            <a:ext cx="1656900" cy="215400"/>
+          </a:xfrm>
+          <a:prstGeom prst="rect">
+            <a:avLst/>
+          </a:prstGeom>
+          <a:solidFill>
+            <a:schemeClr val="lt1"/>
+          </a:solidFill>
+          <a:ln>
+            <a:noFill/>
+          </a:ln>
+        </p:spPr>
+        <p:txBody>
+          <a:bodyPr anchorCtr="0" anchor="t" bIns="0" lIns="91425" spcFirstLastPara="1" rIns="91425" wrap="square" tIns="0">
+            <a:spAutoFit/>
+          </a:bodyPr>
+          <a:lstStyle/>
+          <a:p>
+            <a:pPr indent="0" lvl="0" marL="0" rtl="0" algn="l">
+              <a:spcBef>
+                <a:spcPts val="0"/>
+              </a:spcBef>
+              <a:spcAft>
+                <a:spcPts val="0"/>
+              </a:spcAft>
+              <a:buNone/>
+            </a:pPr>
+            <a:r>
+              <a:rPr lang="es-419">
+                <a:solidFill>
+                  <a:srgbClr val="24A35F"/>
+                </a:solidFill>
+              </a:rPr>
+              <a:t>TSS no canónico</a:t>
+            </a:r>
+            <a:endParaRPr>
+              <a:solidFill>
+                <a:srgbClr val="24A35F"/>
+              </a:solidFill>
+            </a:endParaRPr>
+          </a:p>
+        </p:txBody>
+      </p:sp>
+      <p:sp>
+        <p:nvSpPr>
+          <p:cNvPr id="141" name="Google Shape;141;p23"/>
+          <p:cNvSpPr txBox="1"/>
+          <p:nvPr/>
+        </p:nvSpPr>
+        <p:spPr>
+          <a:xfrm>
+            <a:off x="1076130" y="3333063"/>
+            <a:ext cx="660600" cy="215400"/>
+          </a:xfrm>
+          <a:prstGeom prst="rect">
+            <a:avLst/>
+          </a:prstGeom>
+          <a:solidFill>
+            <a:schemeClr val="lt1"/>
+          </a:solidFill>
+          <a:ln>
+            <a:noFill/>
+          </a:ln>
+        </p:spPr>
+        <p:txBody>
+          <a:bodyPr anchorCtr="0" anchor="t" bIns="0" lIns="91425" spcFirstLastPara="1" rIns="91425" wrap="square" tIns="0">
+            <a:spAutoFit/>
+          </a:bodyPr>
+          <a:lstStyle/>
+          <a:p>
+            <a:pPr indent="0" lvl="0" marL="0" rtl="0" algn="l">
+              <a:spcBef>
+                <a:spcPts val="0"/>
+              </a:spcBef>
+              <a:spcAft>
+                <a:spcPts val="0"/>
+              </a:spcAft>
+              <a:buNone/>
+            </a:pPr>
+            <a:r>
+              <a:rPr lang="es-419">
+                <a:solidFill>
+                  <a:srgbClr val="24A35F"/>
+                </a:solidFill>
+              </a:rPr>
+              <a:t>SINE</a:t>
+            </a:r>
+            <a:endParaRPr>
+              <a:solidFill>
+                <a:srgbClr val="24A35F"/>
+              </a:solidFill>
+            </a:endParaRPr>
+          </a:p>
+        </p:txBody>
+      </p:sp>
+      <p:sp>
+        <p:nvSpPr>
+          <p:cNvPr id="142" name="Google Shape;142;p23"/>
+          <p:cNvSpPr txBox="1"/>
+          <p:nvPr/>
+        </p:nvSpPr>
+        <p:spPr>
+          <a:xfrm>
+            <a:off x="1094362" y="3588669"/>
+            <a:ext cx="660600" cy="215400"/>
+          </a:xfrm>
+          <a:prstGeom prst="rect">
+            <a:avLst/>
+          </a:prstGeom>
+          <a:solidFill>
+            <a:schemeClr val="lt1"/>
+          </a:solidFill>
+          <a:ln>
+            <a:noFill/>
+          </a:ln>
+        </p:spPr>
+        <p:txBody>
+          <a:bodyPr anchorCtr="0" anchor="t" bIns="0" lIns="91425" spcFirstLastPara="1" rIns="91425" wrap="square" tIns="0">
+            <a:spAutoFit/>
+          </a:bodyPr>
+          <a:lstStyle/>
+          <a:p>
+            <a:pPr indent="0" lvl="0" marL="0" rtl="0" algn="l">
+              <a:spcBef>
+                <a:spcPts val="0"/>
+              </a:spcBef>
+              <a:spcAft>
+                <a:spcPts val="0"/>
+              </a:spcAft>
+              <a:buNone/>
+            </a:pPr>
+            <a:r>
+              <a:rPr lang="es-419">
+                <a:solidFill>
+                  <a:srgbClr val="24A35F"/>
+                </a:solidFill>
+              </a:rPr>
+              <a:t>LINE</a:t>
+            </a:r>
+            <a:endParaRPr>
+              <a:solidFill>
+                <a:srgbClr val="24A35F"/>
+              </a:solidFill>
+            </a:endParaRPr>
+          </a:p>
+        </p:txBody>
+      </p:sp>
+      <p:sp>
+        <p:nvSpPr>
+          <p:cNvPr id="143" name="Google Shape;143;p23"/>
+          <p:cNvSpPr txBox="1"/>
+          <p:nvPr/>
+        </p:nvSpPr>
+        <p:spPr>
+          <a:xfrm>
+            <a:off x="624425" y="3887950"/>
+            <a:ext cx="1885200" cy="215400"/>
+          </a:xfrm>
+          <a:prstGeom prst="rect">
+            <a:avLst/>
+          </a:prstGeom>
+          <a:solidFill>
+            <a:schemeClr val="lt1"/>
+          </a:solidFill>
+          <a:ln>
+            <a:noFill/>
+          </a:ln>
+        </p:spPr>
+        <p:txBody>
+          <a:bodyPr anchorCtr="0" anchor="t" bIns="0" lIns="91425" spcFirstLastPara="1" rIns="91425" wrap="square" tIns="0">
+            <a:spAutoFit/>
+          </a:bodyPr>
+          <a:lstStyle/>
+          <a:p>
+            <a:pPr indent="0" lvl="0" marL="0" rtl="0" algn="l">
+              <a:spcBef>
+                <a:spcPts val="0"/>
+              </a:spcBef>
+              <a:spcAft>
+                <a:spcPts val="0"/>
+              </a:spcAft>
+              <a:buNone/>
+            </a:pPr>
+            <a:r>
+              <a:rPr lang="es-419">
+                <a:solidFill>
+                  <a:srgbClr val="24A35F"/>
+                </a:solidFill>
+              </a:rPr>
+              <a:t>Transposon de ADN</a:t>
+            </a:r>
+            <a:endParaRPr>
+              <a:solidFill>
+                <a:srgbClr val="24A35F"/>
+              </a:solidFill>
+            </a:endParaRPr>
+          </a:p>
+        </p:txBody>
+      </p:sp>
+    </p:spTree>
+  </p:cSld>
+  <p:clrMapOvr>
+    <a:masterClrMapping/>
+  </p:clrMapOvr>
+</p:sld>
+</file>
+
+<file path=ppt/slides/slide12.xml><?xml version="1.0" encoding="utf-8"?>
+<p:sld xmlns:a="http://schemas.openxmlformats.org/drawingml/2006/main" xmlns:r="http://schemas.openxmlformats.org/officeDocument/2006/relationships" xmlns:mc="http://schemas.openxmlformats.org/markup-compatibility/2006" xmlns:mv="urn:schemas-microsoft-com:mac:vml" xmlns:p="http://schemas.openxmlformats.org/presentationml/2006/main" xmlns:c="http://schemas.openxmlformats.org/drawingml/2006/chart" xmlns:dgm="http://schemas.openxmlformats.org/drawingml/2006/diagram" xmlns:o="urn:schemas-microsoft-com:office:office" xmlns:v="urn:schemas-microsoft-com:vml" xmlns:pvml="urn:schemas-microsoft-com:office:powerpoint" xmlns:com="http://schemas.openxmlformats.org/drawingml/2006/compatibility" xmlns:p14="http://schemas.microsoft.com/office/powerpoint/2010/main" xmlns:p15="http://schemas.microsoft.com/office/powerpoint/2012/main" xmlns:ahyp="http://schemas.microsoft.com/office/drawing/2018/hyperlinkcolor">
+  <p:cSld>
+    <p:spTree>
+      <p:nvGrpSpPr>
+        <p:cNvPr id="147" name="Shape 147"/>
+        <p:cNvGrpSpPr/>
+        <p:nvPr/>
+      </p:nvGrpSpPr>
+      <p:grpSpPr>
+        <a:xfrm>
+          <a:off x="0" y="0"/>
+          <a:ext cx="0" cy="0"/>
+          <a:chOff x="0" y="0"/>
+          <a:chExt cx="0" cy="0"/>
+        </a:xfrm>
+      </p:grpSpPr>
+      <p:sp>
+        <p:nvSpPr>
+          <p:cNvPr id="148" name="Google Shape;148;p24"/>
+          <p:cNvSpPr txBox="1"/>
+          <p:nvPr/>
+        </p:nvSpPr>
+        <p:spPr>
+          <a:xfrm>
+            <a:off x="0" y="0"/>
+            <a:ext cx="3000000" cy="2647500"/>
+          </a:xfrm>
+          <a:prstGeom prst="rect">
+            <a:avLst/>
+          </a:prstGeom>
+          <a:noFill/>
+          <a:ln>
+            <a:noFill/>
+          </a:ln>
+        </p:spPr>
+        <p:txBody>
+          <a:bodyPr anchorCtr="0" anchor="t" bIns="91425" lIns="91425" spcFirstLastPara="1" rIns="91425" wrap="square" tIns="91425">
+            <a:spAutoFit/>
+          </a:bodyPr>
+          <a:lstStyle/>
+          <a:p>
+            <a:pPr indent="0" lvl="0" marL="0" rtl="0" algn="l">
+              <a:spcBef>
+                <a:spcPts val="0"/>
+              </a:spcBef>
+              <a:spcAft>
+                <a:spcPts val="0"/>
+              </a:spcAft>
+              <a:buNone/>
+            </a:pPr>
+            <a:r>
+              <a:rPr b="1" lang="es-419" sz="1000">
+                <a:solidFill>
+                  <a:schemeClr val="dk1"/>
+                </a:solidFill>
+              </a:rPr>
+              <a:t>F</a:t>
+            </a:r>
+            <a:r>
+              <a:rPr b="1" lang="es-419" sz="1000">
+                <a:solidFill>
+                  <a:schemeClr val="dk1"/>
+                </a:solidFill>
+              </a:rPr>
+              <a:t>igura R2.12. Los elementos del promotor basal combinan sus efectos de forma aproximadamente aditiva.</a:t>
+            </a:r>
+            <a:r>
+              <a:rPr lang="es-419" sz="1000">
+                <a:solidFill>
+                  <a:schemeClr val="dk1"/>
+                </a:solidFill>
+              </a:rPr>
+              <a:t> (A) Distribución de la actividad media de los promotores según el número de elementos asociados a mayor actividad que contienen (isla CpG, TATA-box, CCAAT-box, sitio de YY1 y CRE), para cada réplica. Sobre cada violín se indica el número de promotores. (B) Mediana de la actividad media según el número de elementos positivos (columnas) y de características asociadas a menor actividad (TSS no canónico, E-box CAGGTR y tramo poli(dA:dT) proximal; filas), para cada réplica. En cada celda se indican la mediana y el número de promotores; se omiten las celdas con menos de 50 promotores. </a:t>
+            </a:r>
+            <a:endParaRPr sz="1000"/>
+          </a:p>
+        </p:txBody>
+      </p:sp>
+      <p:pic>
+        <p:nvPicPr>
+          <p:cNvPr id="149" name="Google Shape;149;p24" title="p1_violines_n_elementos.jpg"/>
+          <p:cNvPicPr preferRelativeResize="0"/>
+          <p:nvPr/>
+        </p:nvPicPr>
+        <p:blipFill>
+          <a:blip r:embed="rId4">
+            <a:alphaModFix/>
+          </a:blip>
+          <a:stretch>
+            <a:fillRect/>
+          </a:stretch>
+        </p:blipFill>
+        <p:spPr>
+          <a:xfrm>
+            <a:off x="3559375" y="0"/>
+            <a:ext cx="4419599" cy="2209800"/>
+          </a:xfrm>
+          <a:prstGeom prst="rect">
+            <a:avLst/>
+          </a:prstGeom>
+          <a:noFill/>
+          <a:ln>
+            <a:noFill/>
+          </a:ln>
+        </p:spPr>
+      </p:pic>
+      <p:pic>
+        <p:nvPicPr>
+          <p:cNvPr id="150" name="Google Shape;150;p24" title="p4_grilla_pos_x_neg.jpg"/>
+          <p:cNvPicPr preferRelativeResize="0"/>
+          <p:nvPr/>
+        </p:nvPicPr>
+        <p:blipFill>
+          <a:blip r:embed="rId5">
+            <a:alphaModFix/>
+          </a:blip>
+          <a:stretch>
+            <a:fillRect/>
+          </a:stretch>
+        </p:blipFill>
+        <p:spPr>
+          <a:xfrm>
+            <a:off x="3278100" y="2241950"/>
+            <a:ext cx="5347702" cy="2467575"/>
+          </a:xfrm>
+          <a:prstGeom prst="rect">
+            <a:avLst/>
+          </a:prstGeom>
+          <a:noFill/>
+          <a:ln>
+            <a:noFill/>
+          </a:ln>
+        </p:spPr>
+      </p:pic>
+    </p:spTree>
+  </p:cSld>
+  <p:clrMapOvr>
+    <a:masterClrMapping/>
+  </p:clrMapOvr>
+</p:sld>
+</file>
+
+<file path=ppt/slides/slide13.xml><?xml version="1.0" encoding="utf-8"?>
+<p:sld xmlns:a="http://schemas.openxmlformats.org/drawingml/2006/main" xmlns:r="http://schemas.openxmlformats.org/officeDocument/2006/relationships" xmlns:mc="http://schemas.openxmlformats.org/markup-compatibility/2006" xmlns:mv="urn:schemas-microsoft-com:mac:vml" xmlns:p="http://schemas.openxmlformats.org/presentationml/2006/main" xmlns:c="http://schemas.openxmlformats.org/drawingml/2006/chart" xmlns:dgm="http://schemas.openxmlformats.org/drawingml/2006/diagram" xmlns:o="urn:schemas-microsoft-com:office:office" xmlns:v="urn:schemas-microsoft-com:vml" xmlns:pvml="urn:schemas-microsoft-com:office:powerpoint" xmlns:com="http://schemas.openxmlformats.org/drawingml/2006/compatibility" xmlns:p14="http://schemas.microsoft.com/office/powerpoint/2010/main" xmlns:p15="http://schemas.microsoft.com/office/powerpoint/2012/main" xmlns:ahyp="http://schemas.microsoft.com/office/drawing/2018/hyperlinkcolor">
+  <p:cSld>
+    <p:spTree>
+      <p:nvGrpSpPr>
+        <p:cNvPr id="154" name="Shape 154"/>
+        <p:cNvGrpSpPr/>
+        <p:nvPr/>
+      </p:nvGrpSpPr>
+      <p:grpSpPr>
+        <a:xfrm>
+          <a:off x="0" y="0"/>
+          <a:ext cx="0" cy="0"/>
+          <a:chOff x="0" y="0"/>
+          <a:chExt cx="0" cy="0"/>
+        </a:xfrm>
+      </p:grpSpPr>
+      <p:pic>
+        <p:nvPicPr>
+          <p:cNvPr id="155" name="Google Shape;155;p25" title="summary_seq.jpg"/>
           <p:cNvPicPr preferRelativeResize="0"/>
           <p:nvPr/>
         </p:nvPicPr>
@@ -6902,8 +8448,8 @@
         </p:blipFill>
         <p:spPr>
           <a:xfrm>
-            <a:off x="0" y="0"/>
-            <a:ext cx="3225800" cy="2419350"/>
+            <a:off x="152400" y="152400"/>
+            <a:ext cx="8839204" cy="4419602"/>
           </a:xfrm>
           <a:prstGeom prst="rect">
             <a:avLst/>
@@ -6914,9 +8460,62 @@
           </a:ln>
         </p:spPr>
       </p:pic>
+    </p:spTree>
+  </p:cSld>
+  <p:clrMapOvr>
+    <a:masterClrMapping/>
+  </p:clrMapOvr>
+</p:sld>
+</file>
+
+<file path=ppt/slides/slide14.xml><?xml version="1.0" encoding="utf-8"?>
+<p:sld xmlns:a="http://schemas.openxmlformats.org/drawingml/2006/main" xmlns:r="http://schemas.openxmlformats.org/officeDocument/2006/relationships" xmlns:mc="http://schemas.openxmlformats.org/markup-compatibility/2006" xmlns:mv="urn:schemas-microsoft-com:mac:vml" xmlns:p="http://schemas.openxmlformats.org/presentationml/2006/main" xmlns:c="http://schemas.openxmlformats.org/drawingml/2006/chart" xmlns:dgm="http://schemas.openxmlformats.org/drawingml/2006/diagram" xmlns:o="urn:schemas-microsoft-com:office:office" xmlns:v="urn:schemas-microsoft-com:vml" xmlns:pvml="urn:schemas-microsoft-com:office:powerpoint" xmlns:com="http://schemas.openxmlformats.org/drawingml/2006/compatibility" xmlns:p14="http://schemas.microsoft.com/office/powerpoint/2010/main" xmlns:p15="http://schemas.microsoft.com/office/powerpoint/2012/main" xmlns:ahyp="http://schemas.microsoft.com/office/drawing/2018/hyperlinkcolor">
+  <p:cSld>
+    <p:spTree>
+      <p:nvGrpSpPr>
+        <p:cNvPr id="159" name="Shape 159"/>
+        <p:cNvGrpSpPr/>
+        <p:nvPr/>
+      </p:nvGrpSpPr>
+      <p:grpSpPr>
+        <a:xfrm>
+          <a:off x="0" y="0"/>
+          <a:ext cx="0" cy="0"/>
+          <a:chOff x="0" y="0"/>
+          <a:chExt cx="0" cy="0"/>
+        </a:xfrm>
+      </p:grpSpPr>
       <p:pic>
         <p:nvPicPr>
-          <p:cNvPr id="160" name="Google Shape;160;p23" title="tf_efecto_vs_cobertura.jpg"/>
+          <p:cNvPr id="160" name="Google Shape;160;p26" title="GSEA_top_pathway_rep1.jpg"/>
+          <p:cNvPicPr preferRelativeResize="0"/>
+          <p:nvPr/>
+        </p:nvPicPr>
+        <p:blipFill>
+          <a:blip r:embed="rId3">
+            <a:alphaModFix/>
+          </a:blip>
+          <a:stretch>
+            <a:fillRect/>
+          </a:stretch>
+        </p:blipFill>
+        <p:spPr>
+          <a:xfrm>
+            <a:off x="4091150" y="2046550"/>
+            <a:ext cx="3154673" cy="2366001"/>
+          </a:xfrm>
+          <a:prstGeom prst="rect">
+            <a:avLst/>
+          </a:prstGeom>
+          <a:noFill/>
+          <a:ln>
+            <a:noFill/>
+          </a:ln>
+        </p:spPr>
+      </p:pic>
+      <p:pic>
+        <p:nvPicPr>
+          <p:cNvPr id="161" name="Google Shape;161;p26" title="remap_act.jpg"/>
           <p:cNvPicPr preferRelativeResize="0"/>
           <p:nvPr/>
         </p:nvPicPr>
@@ -6930,8 +8529,8 @@
         </p:blipFill>
         <p:spPr>
           <a:xfrm>
-            <a:off x="3485400" y="0"/>
-            <a:ext cx="5613404" cy="3039680"/>
+            <a:off x="0" y="0"/>
+            <a:ext cx="3946076" cy="2959549"/>
           </a:xfrm>
           <a:prstGeom prst="rect">
             <a:avLst/>
@@ -6944,7 +8543,7 @@
       </p:pic>
       <p:pic>
         <p:nvPicPr>
-          <p:cNvPr id="161" name="Google Shape;161;p23" title="tf_especificidad_ccaat.jpg"/>
+          <p:cNvPr id="162" name="Google Shape;162;p26" title="remap_act_low.jpg"/>
           <p:cNvPicPr preferRelativeResize="0"/>
           <p:nvPr/>
         </p:nvPicPr>
@@ -6958,8 +8557,117 @@
         </p:blipFill>
         <p:spPr>
           <a:xfrm>
-            <a:off x="0" y="1406742"/>
-            <a:ext cx="5571451" cy="3797724"/>
+            <a:off x="3946074" y="2"/>
+            <a:ext cx="2235203" cy="1986362"/>
+          </a:xfrm>
+          <a:prstGeom prst="rect">
+            <a:avLst/>
+          </a:prstGeom>
+          <a:noFill/>
+          <a:ln>
+            <a:noFill/>
+          </a:ln>
+        </p:spPr>
+      </p:pic>
+    </p:spTree>
+  </p:cSld>
+  <p:clrMapOvr>
+    <a:masterClrMapping/>
+  </p:clrMapOvr>
+</p:sld>
+</file>
+
+<file path=ppt/slides/slide15.xml><?xml version="1.0" encoding="utf-8"?>
+<p:sld xmlns:a="http://schemas.openxmlformats.org/drawingml/2006/main" xmlns:r="http://schemas.openxmlformats.org/officeDocument/2006/relationships" xmlns:mc="http://schemas.openxmlformats.org/markup-compatibility/2006" xmlns:mv="urn:schemas-microsoft-com:mac:vml" xmlns:p="http://schemas.openxmlformats.org/presentationml/2006/main" xmlns:c="http://schemas.openxmlformats.org/drawingml/2006/chart" xmlns:dgm="http://schemas.openxmlformats.org/drawingml/2006/diagram" xmlns:o="urn:schemas-microsoft-com:office:office" xmlns:v="urn:schemas-microsoft-com:vml" xmlns:pvml="urn:schemas-microsoft-com:office:powerpoint" xmlns:com="http://schemas.openxmlformats.org/drawingml/2006/compatibility" xmlns:p14="http://schemas.microsoft.com/office/powerpoint/2010/main" xmlns:p15="http://schemas.microsoft.com/office/powerpoint/2012/main" xmlns:ahyp="http://schemas.microsoft.com/office/drawing/2018/hyperlinkcolor">
+  <p:cSld>
+    <p:spTree>
+      <p:nvGrpSpPr>
+        <p:cNvPr id="166" name="Shape 166"/>
+        <p:cNvGrpSpPr/>
+        <p:nvPr/>
+      </p:nvGrpSpPr>
+      <p:grpSpPr>
+        <a:xfrm>
+          <a:off x="0" y="0"/>
+          <a:ext cx="0" cy="0"/>
+          <a:chOff x="0" y="0"/>
+          <a:chExt cx="0" cy="0"/>
+        </a:xfrm>
+      </p:grpSpPr>
+      <p:pic>
+        <p:nvPicPr>
+          <p:cNvPr id="167" name="Google Shape;167;p27" title="nfya_scatter_intersect.jpg"/>
+          <p:cNvPicPr preferRelativeResize="0"/>
+          <p:nvPr/>
+        </p:nvPicPr>
+        <p:blipFill>
+          <a:blip r:embed="rId3">
+            <a:alphaModFix/>
+          </a:blip>
+          <a:stretch>
+            <a:fillRect/>
+          </a:stretch>
+        </p:blipFill>
+        <p:spPr>
+          <a:xfrm>
+            <a:off x="0" y="0"/>
+            <a:ext cx="3225800" cy="2419350"/>
+          </a:xfrm>
+          <a:prstGeom prst="rect">
+            <a:avLst/>
+          </a:prstGeom>
+          <a:noFill/>
+          <a:ln>
+            <a:noFill/>
+          </a:ln>
+        </p:spPr>
+      </p:pic>
+      <p:pic>
+        <p:nvPicPr>
+          <p:cNvPr id="168" name="Google Shape;168;p27" title="tf_efecto_vs_cobertura.jpg"/>
+          <p:cNvPicPr preferRelativeResize="0"/>
+          <p:nvPr/>
+        </p:nvPicPr>
+        <p:blipFill>
+          <a:blip r:embed="rId4">
+            <a:alphaModFix/>
+          </a:blip>
+          <a:stretch>
+            <a:fillRect/>
+          </a:stretch>
+        </p:blipFill>
+        <p:spPr>
+          <a:xfrm>
+            <a:off x="3485400" y="0"/>
+            <a:ext cx="5613404" cy="3039680"/>
+          </a:xfrm>
+          <a:prstGeom prst="rect">
+            <a:avLst/>
+          </a:prstGeom>
+          <a:noFill/>
+          <a:ln>
+            <a:noFill/>
+          </a:ln>
+        </p:spPr>
+      </p:pic>
+      <p:pic>
+        <p:nvPicPr>
+          <p:cNvPr id="169" name="Google Shape;169;p27" title="tf_especificidad_ccaat.jpg"/>
+          <p:cNvPicPr preferRelativeResize="0"/>
+          <p:nvPr/>
+        </p:nvPicPr>
+        <p:blipFill>
+          <a:blip r:embed="rId5">
+            <a:alphaModFix/>
+          </a:blip>
+          <a:stretch>
+            <a:fillRect/>
+          </a:stretch>
+        </p:blipFill>
+        <p:spPr>
+          <a:xfrm>
+            <a:off x="52350" y="2497122"/>
+            <a:ext cx="3730524" cy="2542873"/>
           </a:xfrm>
           <a:prstGeom prst="rect">
             <a:avLst/>
@@ -8037,21 +9745,22 @@
       </p:grpSpPr>
       <p:pic>
         <p:nvPicPr>
-          <p:cNvPr id="107" name="Google Shape;107;p20"/>
+          <p:cNvPr id="107" name="Google Shape;107;p20" title="tss_perfil_efectos_promotor_hl.jpg"/>
           <p:cNvPicPr preferRelativeResize="0"/>
           <p:nvPr/>
         </p:nvPicPr>
-        <p:blipFill rotWithShape="1">
+        <p:blipFill>
           <a:blip r:embed="rId3">
             <a:alphaModFix/>
           </a:blip>
-          <a:srcRect b="0" l="0" r="0" t="9000"/>
-          <a:stretch/>
+          <a:stretch>
+            <a:fillRect/>
+          </a:stretch>
         </p:blipFill>
         <p:spPr>
           <a:xfrm>
-            <a:off x="152400" y="546500"/>
-            <a:ext cx="7048201" cy="3982901"/>
+            <a:off x="152400" y="152400"/>
+            <a:ext cx="8469796" cy="4838702"/>
           </a:xfrm>
           <a:prstGeom prst="rect">
             <a:avLst/>
@@ -8062,933 +9771,6 @@
           </a:ln>
         </p:spPr>
       </p:pic>
-      <p:sp>
-        <p:nvSpPr>
-          <p:cNvPr id="108" name="Google Shape;108;p20"/>
-          <p:cNvSpPr txBox="1"/>
-          <p:nvPr/>
-        </p:nvSpPr>
-        <p:spPr>
-          <a:xfrm>
-            <a:off x="3835025" y="4343400"/>
-            <a:ext cx="2601600" cy="276900"/>
-          </a:xfrm>
-          <a:prstGeom prst="rect">
-            <a:avLst/>
-          </a:prstGeom>
-          <a:solidFill>
-            <a:schemeClr val="lt1"/>
-          </a:solidFill>
-          <a:ln>
-            <a:noFill/>
-          </a:ln>
-        </p:spPr>
-        <p:txBody>
-          <a:bodyPr anchorCtr="0" anchor="t" bIns="91425" lIns="91425" spcFirstLastPara="1" rIns="91425" wrap="square" tIns="0">
-            <a:spAutoFit/>
-          </a:bodyPr>
-          <a:lstStyle/>
-          <a:p>
-            <a:pPr indent="0" lvl="0" marL="0" rtl="0" algn="l">
-              <a:spcBef>
-                <a:spcPts val="0"/>
-              </a:spcBef>
-              <a:spcAft>
-                <a:spcPts val="0"/>
-              </a:spcAft>
-              <a:buNone/>
-            </a:pPr>
-            <a:r>
-              <a:rPr b="1" lang="es-419" sz="1200">
-                <a:solidFill>
-                  <a:schemeClr val="dk2"/>
-                </a:solidFill>
-              </a:rPr>
-              <a:t>Efecto sobre la actividad media</a:t>
-            </a:r>
-            <a:endParaRPr b="1" sz="1200">
-              <a:solidFill>
-                <a:schemeClr val="dk2"/>
-              </a:solidFill>
-            </a:endParaRPr>
-          </a:p>
-        </p:txBody>
-      </p:sp>
-      <p:sp>
-        <p:nvSpPr>
-          <p:cNvPr id="109" name="Google Shape;109;p20"/>
-          <p:cNvSpPr txBox="1"/>
-          <p:nvPr/>
-        </p:nvSpPr>
-        <p:spPr>
-          <a:xfrm>
-            <a:off x="3465653" y="454825"/>
-            <a:ext cx="1005300" cy="361800"/>
-          </a:xfrm>
-          <a:prstGeom prst="rect">
-            <a:avLst/>
-          </a:prstGeom>
-          <a:solidFill>
-            <a:schemeClr val="lt1"/>
-          </a:solidFill>
-          <a:ln>
-            <a:noFill/>
-          </a:ln>
-        </p:spPr>
-        <p:txBody>
-          <a:bodyPr anchorCtr="0" anchor="t" bIns="91425" lIns="0" spcFirstLastPara="1" rIns="0" wrap="square" tIns="91425">
-            <a:spAutoFit/>
-          </a:bodyPr>
-          <a:lstStyle/>
-          <a:p>
-            <a:pPr indent="0" lvl="0" marL="0" rtl="0" algn="l">
-              <a:spcBef>
-                <a:spcPts val="0"/>
-              </a:spcBef>
-              <a:spcAft>
-                <a:spcPts val="0"/>
-              </a:spcAft>
-              <a:buNone/>
-            </a:pPr>
-            <a:r>
-              <a:rPr b="1" lang="es-419" sz="1150">
-                <a:solidFill>
-                  <a:schemeClr val="dk2"/>
-                </a:solidFill>
-              </a:rPr>
-              <a:t>Alta actividad</a:t>
-            </a:r>
-            <a:endParaRPr b="1" sz="1150">
-              <a:solidFill>
-                <a:schemeClr val="dk2"/>
-              </a:solidFill>
-            </a:endParaRPr>
-          </a:p>
-        </p:txBody>
-      </p:sp>
-      <p:sp>
-        <p:nvSpPr>
-          <p:cNvPr id="110" name="Google Shape;110;p20"/>
-          <p:cNvSpPr txBox="1"/>
-          <p:nvPr/>
-        </p:nvSpPr>
-        <p:spPr>
-          <a:xfrm>
-            <a:off x="3142325" y="248494"/>
-            <a:ext cx="692700" cy="369300"/>
-          </a:xfrm>
-          <a:prstGeom prst="rect">
-            <a:avLst/>
-          </a:prstGeom>
-          <a:noFill/>
-          <a:ln>
-            <a:noFill/>
-          </a:ln>
-        </p:spPr>
-        <p:txBody>
-          <a:bodyPr anchorCtr="0" anchor="t" bIns="91425" lIns="91425" spcFirstLastPara="1" rIns="91425" wrap="square" tIns="91425">
-            <a:spAutoFit/>
-          </a:bodyPr>
-          <a:lstStyle/>
-          <a:p>
-            <a:pPr indent="0" lvl="0" marL="0" rtl="0" algn="l">
-              <a:spcBef>
-                <a:spcPts val="0"/>
-              </a:spcBef>
-              <a:spcAft>
-                <a:spcPts val="0"/>
-              </a:spcAft>
-              <a:buNone/>
-            </a:pPr>
-            <a:r>
-              <a:rPr b="1" lang="es-419" sz="1200">
-                <a:solidFill>
-                  <a:schemeClr val="dk2"/>
-                </a:solidFill>
-              </a:rPr>
-              <a:t>Efecto</a:t>
-            </a:r>
-            <a:endParaRPr b="1" sz="1200">
-              <a:solidFill>
-                <a:schemeClr val="dk2"/>
-              </a:solidFill>
-            </a:endParaRPr>
-          </a:p>
-        </p:txBody>
-      </p:sp>
-      <p:sp>
-        <p:nvSpPr>
-          <p:cNvPr id="111" name="Google Shape;111;p20"/>
-          <p:cNvSpPr txBox="1"/>
-          <p:nvPr/>
-        </p:nvSpPr>
-        <p:spPr>
-          <a:xfrm>
-            <a:off x="4674460" y="452422"/>
-            <a:ext cx="1005300" cy="361800"/>
-          </a:xfrm>
-          <a:prstGeom prst="rect">
-            <a:avLst/>
-          </a:prstGeom>
-          <a:solidFill>
-            <a:schemeClr val="lt1"/>
-          </a:solidFill>
-          <a:ln>
-            <a:noFill/>
-          </a:ln>
-        </p:spPr>
-        <p:txBody>
-          <a:bodyPr anchorCtr="0" anchor="t" bIns="91425" lIns="0" spcFirstLastPara="1" rIns="0" wrap="square" tIns="91425">
-            <a:spAutoFit/>
-          </a:bodyPr>
-          <a:lstStyle/>
-          <a:p>
-            <a:pPr indent="0" lvl="0" marL="0" rtl="0" algn="l">
-              <a:spcBef>
-                <a:spcPts val="0"/>
-              </a:spcBef>
-              <a:spcAft>
-                <a:spcPts val="0"/>
-              </a:spcAft>
-              <a:buNone/>
-            </a:pPr>
-            <a:r>
-              <a:rPr b="1" lang="es-419" sz="1150">
-                <a:solidFill>
-                  <a:schemeClr val="dk2"/>
-                </a:solidFill>
-              </a:rPr>
-              <a:t>Baja actividad</a:t>
-            </a:r>
-            <a:endParaRPr b="1" sz="1150">
-              <a:solidFill>
-                <a:schemeClr val="dk2"/>
-              </a:solidFill>
-            </a:endParaRPr>
-          </a:p>
-        </p:txBody>
-      </p:sp>
-      <p:sp>
-        <p:nvSpPr>
-          <p:cNvPr id="112" name="Google Shape;112;p20"/>
-          <p:cNvSpPr txBox="1"/>
-          <p:nvPr/>
-        </p:nvSpPr>
-        <p:spPr>
-          <a:xfrm>
-            <a:off x="781900" y="233289"/>
-            <a:ext cx="1237200" cy="715800"/>
-          </a:xfrm>
-          <a:prstGeom prst="rect">
-            <a:avLst/>
-          </a:prstGeom>
-          <a:solidFill>
-            <a:schemeClr val="lt1"/>
-          </a:solidFill>
-          <a:ln>
-            <a:noFill/>
-          </a:ln>
-        </p:spPr>
-        <p:txBody>
-          <a:bodyPr anchorCtr="0" anchor="t" bIns="91425" lIns="0" spcFirstLastPara="1" rIns="0" wrap="square" tIns="91425">
-            <a:spAutoFit/>
-          </a:bodyPr>
-          <a:lstStyle/>
-          <a:p>
-            <a:pPr indent="0" lvl="0" marL="0" rtl="0" algn="ctr">
-              <a:spcBef>
-                <a:spcPts val="0"/>
-              </a:spcBef>
-              <a:spcAft>
-                <a:spcPts val="0"/>
-              </a:spcAft>
-              <a:buNone/>
-            </a:pPr>
-            <a:r>
-              <a:rPr b="1" lang="es-419" sz="1150">
-                <a:solidFill>
-                  <a:schemeClr val="dk2"/>
-                </a:solidFill>
-              </a:rPr>
-              <a:t>Características basadas en la secuencia</a:t>
-            </a:r>
-            <a:endParaRPr b="1" sz="1150">
-              <a:solidFill>
-                <a:schemeClr val="dk2"/>
-              </a:solidFill>
-            </a:endParaRPr>
-          </a:p>
-        </p:txBody>
-      </p:sp>
-      <p:sp>
-        <p:nvSpPr>
-          <p:cNvPr id="113" name="Google Shape;113;p20"/>
-          <p:cNvSpPr txBox="1"/>
-          <p:nvPr/>
-        </p:nvSpPr>
-        <p:spPr>
-          <a:xfrm>
-            <a:off x="920600" y="1229375"/>
-            <a:ext cx="1351800" cy="215400"/>
-          </a:xfrm>
-          <a:prstGeom prst="rect">
-            <a:avLst/>
-          </a:prstGeom>
-          <a:solidFill>
-            <a:schemeClr val="lt1"/>
-          </a:solidFill>
-          <a:ln>
-            <a:noFill/>
-          </a:ln>
-        </p:spPr>
-        <p:txBody>
-          <a:bodyPr anchorCtr="0" anchor="t" bIns="0" lIns="91425" spcFirstLastPara="1" rIns="91425" wrap="square" tIns="0">
-            <a:spAutoFit/>
-          </a:bodyPr>
-          <a:lstStyle/>
-          <a:p>
-            <a:pPr indent="0" lvl="0" marL="0" rtl="0" algn="l">
-              <a:spcBef>
-                <a:spcPts val="0"/>
-              </a:spcBef>
-              <a:spcAft>
-                <a:spcPts val="0"/>
-              </a:spcAft>
-              <a:buNone/>
-            </a:pPr>
-            <a:r>
-              <a:rPr lang="es-419">
-                <a:solidFill>
-                  <a:srgbClr val="F37336"/>
-                </a:solidFill>
-              </a:rPr>
-              <a:t>Isla CpG</a:t>
-            </a:r>
-            <a:endParaRPr>
-              <a:solidFill>
-                <a:srgbClr val="F37336"/>
-              </a:solidFill>
-            </a:endParaRPr>
-          </a:p>
-        </p:txBody>
-      </p:sp>
-      <p:sp>
-        <p:nvSpPr>
-          <p:cNvPr id="114" name="Google Shape;114;p20"/>
-          <p:cNvSpPr txBox="1"/>
-          <p:nvPr/>
-        </p:nvSpPr>
-        <p:spPr>
-          <a:xfrm>
-            <a:off x="2344825" y="1810225"/>
-            <a:ext cx="5944500" cy="461700"/>
-          </a:xfrm>
-          <a:prstGeom prst="rect">
-            <a:avLst/>
-          </a:prstGeom>
-          <a:noFill/>
-          <a:ln>
-            <a:noFill/>
-          </a:ln>
-        </p:spPr>
-        <p:txBody>
-          <a:bodyPr anchorCtr="0" anchor="t" bIns="91425" lIns="91425" spcFirstLastPara="1" rIns="91425" wrap="square" tIns="91425">
-            <a:spAutoFit/>
-          </a:bodyPr>
-          <a:lstStyle/>
-          <a:p>
-            <a:pPr indent="0" lvl="0" marL="0" rtl="0" algn="l">
-              <a:spcBef>
-                <a:spcPts val="0"/>
-              </a:spcBef>
-              <a:spcAft>
-                <a:spcPts val="0"/>
-              </a:spcAft>
-              <a:buNone/>
-            </a:pPr>
-            <a:r>
-              <a:t/>
-            </a:r>
-            <a:endParaRPr sz="1800">
-              <a:solidFill>
-                <a:schemeClr val="dk2"/>
-              </a:solidFill>
-            </a:endParaRPr>
-          </a:p>
-        </p:txBody>
-      </p:sp>
-      <p:sp>
-        <p:nvSpPr>
-          <p:cNvPr id="115" name="Google Shape;115;p20"/>
-          <p:cNvSpPr txBox="1"/>
-          <p:nvPr/>
-        </p:nvSpPr>
-        <p:spPr>
-          <a:xfrm>
-            <a:off x="813075" y="991850"/>
-            <a:ext cx="1351800" cy="215400"/>
-          </a:xfrm>
-          <a:prstGeom prst="rect">
-            <a:avLst/>
-          </a:prstGeom>
-          <a:solidFill>
-            <a:schemeClr val="lt1"/>
-          </a:solidFill>
-          <a:ln>
-            <a:noFill/>
-          </a:ln>
-        </p:spPr>
-        <p:txBody>
-          <a:bodyPr anchorCtr="0" anchor="t" bIns="0" lIns="91425" spcFirstLastPara="1" rIns="91425" wrap="square" tIns="0">
-            <a:spAutoFit/>
-          </a:bodyPr>
-          <a:lstStyle/>
-          <a:p>
-            <a:pPr indent="0" lvl="0" marL="0" rtl="0" algn="l">
-              <a:spcBef>
-                <a:spcPts val="0"/>
-              </a:spcBef>
-              <a:spcAft>
-                <a:spcPts val="0"/>
-              </a:spcAft>
-              <a:buNone/>
-            </a:pPr>
-            <a:r>
-              <a:rPr lang="es-419">
-                <a:solidFill>
-                  <a:srgbClr val="F37336"/>
-                </a:solidFill>
-              </a:rPr>
-              <a:t>   CCAAT</a:t>
-            </a:r>
-            <a:endParaRPr>
-              <a:solidFill>
-                <a:srgbClr val="F37336"/>
-              </a:solidFill>
-            </a:endParaRPr>
-          </a:p>
-        </p:txBody>
-      </p:sp>
-      <p:sp>
-        <p:nvSpPr>
-          <p:cNvPr id="116" name="Google Shape;116;p20"/>
-          <p:cNvSpPr txBox="1"/>
-          <p:nvPr/>
-        </p:nvSpPr>
-        <p:spPr>
-          <a:xfrm>
-            <a:off x="884822" y="1503213"/>
-            <a:ext cx="1351800" cy="215400"/>
-          </a:xfrm>
-          <a:prstGeom prst="rect">
-            <a:avLst/>
-          </a:prstGeom>
-          <a:solidFill>
-            <a:schemeClr val="lt1"/>
-          </a:solidFill>
-          <a:ln>
-            <a:noFill/>
-          </a:ln>
-        </p:spPr>
-        <p:txBody>
-          <a:bodyPr anchorCtr="0" anchor="t" bIns="0" lIns="91425" spcFirstLastPara="1" rIns="91425" wrap="square" tIns="0">
-            <a:spAutoFit/>
-          </a:bodyPr>
-          <a:lstStyle/>
-          <a:p>
-            <a:pPr indent="0" lvl="0" marL="0" rtl="0" algn="l">
-              <a:spcBef>
-                <a:spcPts val="0"/>
-              </a:spcBef>
-              <a:spcAft>
-                <a:spcPts val="0"/>
-              </a:spcAft>
-              <a:buNone/>
-            </a:pPr>
-            <a:r>
-              <a:rPr lang="es-419">
-                <a:solidFill>
-                  <a:srgbClr val="F37336"/>
-                </a:solidFill>
-              </a:rPr>
-              <a:t>TATA-box</a:t>
-            </a:r>
-            <a:endParaRPr>
-              <a:solidFill>
-                <a:srgbClr val="F37336"/>
-              </a:solidFill>
-            </a:endParaRPr>
-          </a:p>
-        </p:txBody>
-      </p:sp>
-      <p:sp>
-        <p:nvSpPr>
-          <p:cNvPr id="117" name="Google Shape;117;p20"/>
-          <p:cNvSpPr txBox="1"/>
-          <p:nvPr/>
-        </p:nvSpPr>
-        <p:spPr>
-          <a:xfrm>
-            <a:off x="942002" y="1766743"/>
-            <a:ext cx="1351800" cy="215400"/>
-          </a:xfrm>
-          <a:prstGeom prst="rect">
-            <a:avLst/>
-          </a:prstGeom>
-          <a:solidFill>
-            <a:schemeClr val="lt1"/>
-          </a:solidFill>
-          <a:ln>
-            <a:noFill/>
-          </a:ln>
-        </p:spPr>
-        <p:txBody>
-          <a:bodyPr anchorCtr="0" anchor="t" bIns="0" lIns="91425" spcFirstLastPara="1" rIns="91425" wrap="square" tIns="0">
-            <a:spAutoFit/>
-          </a:bodyPr>
-          <a:lstStyle/>
-          <a:p>
-            <a:pPr indent="0" lvl="0" marL="0" rtl="0" algn="l">
-              <a:spcBef>
-                <a:spcPts val="0"/>
-              </a:spcBef>
-              <a:spcAft>
-                <a:spcPts val="0"/>
-              </a:spcAft>
-              <a:buNone/>
-            </a:pPr>
-            <a:r>
-              <a:rPr lang="es-419">
-                <a:solidFill>
-                  <a:srgbClr val="F37336"/>
-                </a:solidFill>
-              </a:rPr>
-              <a:t>GC-box</a:t>
-            </a:r>
-            <a:endParaRPr>
-              <a:solidFill>
-                <a:srgbClr val="F37336"/>
-              </a:solidFill>
-            </a:endParaRPr>
-          </a:p>
-        </p:txBody>
-      </p:sp>
-      <p:sp>
-        <p:nvSpPr>
-          <p:cNvPr id="118" name="Google Shape;118;p20"/>
-          <p:cNvSpPr txBox="1"/>
-          <p:nvPr/>
-        </p:nvSpPr>
-        <p:spPr>
-          <a:xfrm>
-            <a:off x="373593" y="2030275"/>
-            <a:ext cx="2053800" cy="215400"/>
-          </a:xfrm>
-          <a:prstGeom prst="rect">
-            <a:avLst/>
-          </a:prstGeom>
-          <a:solidFill>
-            <a:schemeClr val="lt1"/>
-          </a:solidFill>
-          <a:ln>
-            <a:noFill/>
-          </a:ln>
-        </p:spPr>
-        <p:txBody>
-          <a:bodyPr anchorCtr="0" anchor="t" bIns="0" lIns="91425" spcFirstLastPara="1" rIns="91425" wrap="square" tIns="0">
-            <a:spAutoFit/>
-          </a:bodyPr>
-          <a:lstStyle/>
-          <a:p>
-            <a:pPr indent="0" lvl="0" marL="0" rtl="0" algn="l">
-              <a:spcBef>
-                <a:spcPts val="0"/>
-              </a:spcBef>
-              <a:spcAft>
-                <a:spcPts val="0"/>
-              </a:spcAft>
-              <a:buNone/>
-            </a:pPr>
-            <a:r>
-              <a:rPr lang="es-419">
-                <a:solidFill>
-                  <a:srgbClr val="F37336"/>
-                </a:solidFill>
-              </a:rPr>
-              <a:t>Alto contenido en G+C</a:t>
-            </a:r>
-            <a:endParaRPr>
-              <a:solidFill>
-                <a:srgbClr val="F37336"/>
-              </a:solidFill>
-            </a:endParaRPr>
-          </a:p>
-        </p:txBody>
-      </p:sp>
-      <p:sp>
-        <p:nvSpPr>
-          <p:cNvPr id="119" name="Google Shape;119;p20"/>
-          <p:cNvSpPr txBox="1"/>
-          <p:nvPr/>
-        </p:nvSpPr>
-        <p:spPr>
-          <a:xfrm>
-            <a:off x="801991" y="2269278"/>
-            <a:ext cx="1351800" cy="215400"/>
-          </a:xfrm>
-          <a:prstGeom prst="rect">
-            <a:avLst/>
-          </a:prstGeom>
-          <a:solidFill>
-            <a:schemeClr val="lt1"/>
-          </a:solidFill>
-          <a:ln>
-            <a:noFill/>
-          </a:ln>
-        </p:spPr>
-        <p:txBody>
-          <a:bodyPr anchorCtr="0" anchor="t" bIns="0" lIns="91425" spcFirstLastPara="1" rIns="91425" wrap="square" tIns="0">
-            <a:spAutoFit/>
-          </a:bodyPr>
-          <a:lstStyle/>
-          <a:p>
-            <a:pPr indent="0" lvl="0" marL="0" rtl="0" algn="l">
-              <a:spcBef>
-                <a:spcPts val="0"/>
-              </a:spcBef>
-              <a:spcAft>
-                <a:spcPts val="0"/>
-              </a:spcAft>
-              <a:buNone/>
-            </a:pPr>
-            <a:r>
-              <a:rPr lang="es-419">
-                <a:solidFill>
-                  <a:srgbClr val="F37336"/>
-                </a:solidFill>
-              </a:rPr>
-              <a:t>CG en TSS</a:t>
-            </a:r>
-            <a:endParaRPr>
-              <a:solidFill>
-                <a:srgbClr val="F37336"/>
-              </a:solidFill>
-            </a:endParaRPr>
-          </a:p>
-        </p:txBody>
-      </p:sp>
-      <p:sp>
-        <p:nvSpPr>
-          <p:cNvPr id="120" name="Google Shape;120;p20"/>
-          <p:cNvSpPr txBox="1"/>
-          <p:nvPr/>
-        </p:nvSpPr>
-        <p:spPr>
-          <a:xfrm>
-            <a:off x="1095665" y="2508259"/>
-            <a:ext cx="1351800" cy="215400"/>
-          </a:xfrm>
-          <a:prstGeom prst="rect">
-            <a:avLst/>
-          </a:prstGeom>
-          <a:solidFill>
-            <a:schemeClr val="lt1"/>
-          </a:solidFill>
-          <a:ln>
-            <a:noFill/>
-          </a:ln>
-        </p:spPr>
-        <p:txBody>
-          <a:bodyPr anchorCtr="0" anchor="t" bIns="0" lIns="91425" spcFirstLastPara="1" rIns="91425" wrap="square" tIns="0">
-            <a:spAutoFit/>
-          </a:bodyPr>
-          <a:lstStyle/>
-          <a:p>
-            <a:pPr indent="0" lvl="0" marL="0" rtl="0" algn="l">
-              <a:spcBef>
-                <a:spcPts val="0"/>
-              </a:spcBef>
-              <a:spcAft>
-                <a:spcPts val="0"/>
-              </a:spcAft>
-              <a:buNone/>
-            </a:pPr>
-            <a:r>
-              <a:rPr lang="es-419">
-                <a:solidFill>
-                  <a:srgbClr val="F37336"/>
-                </a:solidFill>
-              </a:rPr>
-              <a:t>TCT</a:t>
-            </a:r>
-            <a:endParaRPr>
-              <a:solidFill>
-                <a:srgbClr val="F37336"/>
-              </a:solidFill>
-            </a:endParaRPr>
-          </a:p>
-        </p:txBody>
-      </p:sp>
-      <p:sp>
-        <p:nvSpPr>
-          <p:cNvPr id="121" name="Google Shape;121;p20"/>
-          <p:cNvSpPr txBox="1"/>
-          <p:nvPr/>
-        </p:nvSpPr>
-        <p:spPr>
-          <a:xfrm>
-            <a:off x="386175" y="2773823"/>
-            <a:ext cx="2205600" cy="288300"/>
-          </a:xfrm>
-          <a:prstGeom prst="rect">
-            <a:avLst/>
-          </a:prstGeom>
-          <a:solidFill>
-            <a:schemeClr val="lt1"/>
-          </a:solidFill>
-          <a:ln>
-            <a:noFill/>
-          </a:ln>
-        </p:spPr>
-        <p:txBody>
-          <a:bodyPr anchorCtr="0" anchor="t" bIns="72000" lIns="91425" spcFirstLastPara="1" rIns="91425" wrap="square" tIns="0">
-            <a:spAutoFit/>
-          </a:bodyPr>
-          <a:lstStyle/>
-          <a:p>
-            <a:pPr indent="0" lvl="0" marL="0" rtl="0" algn="l">
-              <a:spcBef>
-                <a:spcPts val="0"/>
-              </a:spcBef>
-              <a:spcAft>
-                <a:spcPts val="0"/>
-              </a:spcAft>
-              <a:buNone/>
-            </a:pPr>
-            <a:r>
-              <a:rPr lang="es-419">
-                <a:solidFill>
-                  <a:srgbClr val="24A35F"/>
-                </a:solidFill>
-              </a:rPr>
-              <a:t>Elementos transponibles</a:t>
-            </a:r>
-            <a:endParaRPr>
-              <a:solidFill>
-                <a:srgbClr val="24A35F"/>
-              </a:solidFill>
-            </a:endParaRPr>
-          </a:p>
-        </p:txBody>
-      </p:sp>
-      <p:sp>
-        <p:nvSpPr>
-          <p:cNvPr id="122" name="Google Shape;122;p20"/>
-          <p:cNvSpPr txBox="1"/>
-          <p:nvPr/>
-        </p:nvSpPr>
-        <p:spPr>
-          <a:xfrm>
-            <a:off x="572050" y="3052022"/>
-            <a:ext cx="1656900" cy="215400"/>
-          </a:xfrm>
-          <a:prstGeom prst="rect">
-            <a:avLst/>
-          </a:prstGeom>
-          <a:solidFill>
-            <a:schemeClr val="lt1"/>
-          </a:solidFill>
-          <a:ln>
-            <a:noFill/>
-          </a:ln>
-        </p:spPr>
-        <p:txBody>
-          <a:bodyPr anchorCtr="0" anchor="t" bIns="0" lIns="91425" spcFirstLastPara="1" rIns="91425" wrap="square" tIns="0">
-            <a:spAutoFit/>
-          </a:bodyPr>
-          <a:lstStyle/>
-          <a:p>
-            <a:pPr indent="0" lvl="0" marL="0" rtl="0" algn="l">
-              <a:spcBef>
-                <a:spcPts val="0"/>
-              </a:spcBef>
-              <a:spcAft>
-                <a:spcPts val="0"/>
-              </a:spcAft>
-              <a:buNone/>
-            </a:pPr>
-            <a:r>
-              <a:rPr lang="es-419">
-                <a:solidFill>
-                  <a:srgbClr val="24A35F"/>
-                </a:solidFill>
-              </a:rPr>
-              <a:t>TSS no canónico</a:t>
-            </a:r>
-            <a:endParaRPr>
-              <a:solidFill>
-                <a:srgbClr val="24A35F"/>
-              </a:solidFill>
-            </a:endParaRPr>
-          </a:p>
-        </p:txBody>
-      </p:sp>
-      <p:sp>
-        <p:nvSpPr>
-          <p:cNvPr id="123" name="Google Shape;123;p20"/>
-          <p:cNvSpPr txBox="1"/>
-          <p:nvPr/>
-        </p:nvSpPr>
-        <p:spPr>
-          <a:xfrm>
-            <a:off x="1076130" y="3333063"/>
-            <a:ext cx="660600" cy="215400"/>
-          </a:xfrm>
-          <a:prstGeom prst="rect">
-            <a:avLst/>
-          </a:prstGeom>
-          <a:solidFill>
-            <a:schemeClr val="lt1"/>
-          </a:solidFill>
-          <a:ln>
-            <a:noFill/>
-          </a:ln>
-        </p:spPr>
-        <p:txBody>
-          <a:bodyPr anchorCtr="0" anchor="t" bIns="0" lIns="91425" spcFirstLastPara="1" rIns="91425" wrap="square" tIns="0">
-            <a:spAutoFit/>
-          </a:bodyPr>
-          <a:lstStyle/>
-          <a:p>
-            <a:pPr indent="0" lvl="0" marL="0" rtl="0" algn="l">
-              <a:spcBef>
-                <a:spcPts val="0"/>
-              </a:spcBef>
-              <a:spcAft>
-                <a:spcPts val="0"/>
-              </a:spcAft>
-              <a:buNone/>
-            </a:pPr>
-            <a:r>
-              <a:rPr lang="es-419">
-                <a:solidFill>
-                  <a:srgbClr val="24A35F"/>
-                </a:solidFill>
-              </a:rPr>
-              <a:t>SINE</a:t>
-            </a:r>
-            <a:endParaRPr>
-              <a:solidFill>
-                <a:srgbClr val="24A35F"/>
-              </a:solidFill>
-            </a:endParaRPr>
-          </a:p>
-        </p:txBody>
-      </p:sp>
-      <p:sp>
-        <p:nvSpPr>
-          <p:cNvPr id="124" name="Google Shape;124;p20"/>
-          <p:cNvSpPr txBox="1"/>
-          <p:nvPr/>
-        </p:nvSpPr>
-        <p:spPr>
-          <a:xfrm>
-            <a:off x="1094362" y="3588669"/>
-            <a:ext cx="660600" cy="215400"/>
-          </a:xfrm>
-          <a:prstGeom prst="rect">
-            <a:avLst/>
-          </a:prstGeom>
-          <a:solidFill>
-            <a:schemeClr val="lt1"/>
-          </a:solidFill>
-          <a:ln>
-            <a:noFill/>
-          </a:ln>
-        </p:spPr>
-        <p:txBody>
-          <a:bodyPr anchorCtr="0" anchor="t" bIns="0" lIns="91425" spcFirstLastPara="1" rIns="91425" wrap="square" tIns="0">
-            <a:spAutoFit/>
-          </a:bodyPr>
-          <a:lstStyle/>
-          <a:p>
-            <a:pPr indent="0" lvl="0" marL="0" rtl="0" algn="l">
-              <a:spcBef>
-                <a:spcPts val="0"/>
-              </a:spcBef>
-              <a:spcAft>
-                <a:spcPts val="0"/>
-              </a:spcAft>
-              <a:buNone/>
-            </a:pPr>
-            <a:r>
-              <a:rPr lang="es-419">
-                <a:solidFill>
-                  <a:srgbClr val="24A35F"/>
-                </a:solidFill>
-              </a:rPr>
-              <a:t>LINE</a:t>
-            </a:r>
-            <a:endParaRPr>
-              <a:solidFill>
-                <a:srgbClr val="24A35F"/>
-              </a:solidFill>
-            </a:endParaRPr>
-          </a:p>
-        </p:txBody>
-      </p:sp>
-      <p:sp>
-        <p:nvSpPr>
-          <p:cNvPr id="125" name="Google Shape;125;p20"/>
-          <p:cNvSpPr txBox="1"/>
-          <p:nvPr/>
-        </p:nvSpPr>
-        <p:spPr>
-          <a:xfrm>
-            <a:off x="624425" y="3887950"/>
-            <a:ext cx="1885200" cy="215400"/>
-          </a:xfrm>
-          <a:prstGeom prst="rect">
-            <a:avLst/>
-          </a:prstGeom>
-          <a:solidFill>
-            <a:schemeClr val="lt1"/>
-          </a:solidFill>
-          <a:ln>
-            <a:noFill/>
-          </a:ln>
-        </p:spPr>
-        <p:txBody>
-          <a:bodyPr anchorCtr="0" anchor="t" bIns="0" lIns="91425" spcFirstLastPara="1" rIns="91425" wrap="square" tIns="0">
-            <a:spAutoFit/>
-          </a:bodyPr>
-          <a:lstStyle/>
-          <a:p>
-            <a:pPr indent="0" lvl="0" marL="0" rtl="0" algn="l">
-              <a:spcBef>
-                <a:spcPts val="0"/>
-              </a:spcBef>
-              <a:spcAft>
-                <a:spcPts val="0"/>
-              </a:spcAft>
-              <a:buNone/>
-            </a:pPr>
-            <a:r>
-              <a:rPr lang="es-419">
-                <a:solidFill>
-                  <a:srgbClr val="24A35F"/>
-                </a:solidFill>
-              </a:rPr>
-              <a:t>Transposon de ADN</a:t>
-            </a:r>
-            <a:endParaRPr>
-              <a:solidFill>
-                <a:srgbClr val="24A35F"/>
-              </a:solidFill>
-            </a:endParaRPr>
-          </a:p>
-        </p:txBody>
-      </p:sp>
     </p:spTree>
   </p:cSld>
   <p:clrMapOvr>
@@ -9002,7 +9784,7 @@
   <p:cSld>
     <p:spTree>
       <p:nvGrpSpPr>
-        <p:cNvPr id="129" name="Shape 129"/>
+        <p:cNvPr id="111" name="Shape 111"/>
         <p:cNvGrpSpPr/>
         <p:nvPr/>
       </p:nvGrpSpPr>
@@ -9016,21 +9798,22 @@
       </p:grpSpPr>
       <p:pic>
         <p:nvPicPr>
-          <p:cNvPr id="130" name="Google Shape;130;p21"/>
+          <p:cNvPr id="112" name="Google Shape;112;p21" title="tss_perfil_YR_todos.jpg"/>
           <p:cNvPicPr preferRelativeResize="0"/>
           <p:nvPr/>
         </p:nvPicPr>
-        <p:blipFill rotWithShape="1">
+        <p:blipFill>
           <a:blip r:embed="rId3">
             <a:alphaModFix/>
           </a:blip>
-          <a:srcRect b="0" l="44240" r="0" t="0"/>
-          <a:stretch/>
+          <a:stretch>
+            <a:fillRect/>
+          </a:stretch>
         </p:blipFill>
         <p:spPr>
           <a:xfrm>
-            <a:off x="4009000" y="1417575"/>
-            <a:ext cx="4022124" cy="3606625"/>
+            <a:off x="152400" y="3111501"/>
+            <a:ext cx="5012301" cy="1879599"/>
           </a:xfrm>
           <a:prstGeom prst="rect">
             <a:avLst/>
@@ -9041,367 +9824,9 @@
           </a:ln>
         </p:spPr>
       </p:pic>
-      <p:sp>
-        <p:nvSpPr>
-          <p:cNvPr id="131" name="Google Shape;131;p21"/>
-          <p:cNvSpPr txBox="1"/>
-          <p:nvPr/>
-        </p:nvSpPr>
-        <p:spPr>
-          <a:xfrm>
-            <a:off x="1343725" y="966048"/>
-            <a:ext cx="1713300" cy="715800"/>
-          </a:xfrm>
-          <a:prstGeom prst="rect">
-            <a:avLst/>
-          </a:prstGeom>
-          <a:solidFill>
-            <a:schemeClr val="lt1"/>
-          </a:solidFill>
-          <a:ln>
-            <a:noFill/>
-          </a:ln>
-        </p:spPr>
-        <p:txBody>
-          <a:bodyPr anchorCtr="0" anchor="t" bIns="91425" lIns="0" spcFirstLastPara="1" rIns="0" wrap="square" tIns="91425">
-            <a:spAutoFit/>
-          </a:bodyPr>
-          <a:lstStyle/>
-          <a:p>
-            <a:pPr indent="0" lvl="0" marL="0" rtl="0" algn="ctr">
-              <a:spcBef>
-                <a:spcPts val="0"/>
-              </a:spcBef>
-              <a:spcAft>
-                <a:spcPts val="0"/>
-              </a:spcAft>
-              <a:buNone/>
-            </a:pPr>
-            <a:r>
-              <a:rPr b="1" lang="es-419" sz="1150">
-                <a:solidFill>
-                  <a:schemeClr val="dk2"/>
-                </a:solidFill>
-              </a:rPr>
-              <a:t>Características </a:t>
-            </a:r>
-            <a:endParaRPr b="1" sz="1150">
-              <a:solidFill>
-                <a:schemeClr val="dk2"/>
-              </a:solidFill>
-            </a:endParaRPr>
-          </a:p>
-          <a:p>
-            <a:pPr indent="0" lvl="0" marL="0" rtl="0" algn="ctr">
-              <a:spcBef>
-                <a:spcPts val="0"/>
-              </a:spcBef>
-              <a:spcAft>
-                <a:spcPts val="0"/>
-              </a:spcAft>
-              <a:buNone/>
-            </a:pPr>
-            <a:r>
-              <a:rPr b="1" lang="es-419" sz="1150">
-                <a:solidFill>
-                  <a:schemeClr val="dk2"/>
-                </a:solidFill>
-              </a:rPr>
-              <a:t>basadas en el </a:t>
-            </a:r>
-            <a:endParaRPr b="1" sz="1150">
-              <a:solidFill>
-                <a:schemeClr val="dk2"/>
-              </a:solidFill>
-            </a:endParaRPr>
-          </a:p>
-          <a:p>
-            <a:pPr indent="0" lvl="0" marL="0" rtl="0" algn="ctr">
-              <a:spcBef>
-                <a:spcPts val="0"/>
-              </a:spcBef>
-              <a:spcAft>
-                <a:spcPts val="0"/>
-              </a:spcAft>
-              <a:buNone/>
-            </a:pPr>
-            <a:r>
-              <a:rPr b="1" lang="es-419" sz="1150">
-                <a:solidFill>
-                  <a:schemeClr val="dk2"/>
-                </a:solidFill>
-              </a:rPr>
-              <a:t>contexto endógeno</a:t>
-            </a:r>
-            <a:endParaRPr b="1" sz="1150">
-              <a:solidFill>
-                <a:schemeClr val="dk2"/>
-              </a:solidFill>
-            </a:endParaRPr>
-          </a:p>
-        </p:txBody>
-      </p:sp>
-      <p:sp>
-        <p:nvSpPr>
-          <p:cNvPr id="132" name="Google Shape;132;p21"/>
-          <p:cNvSpPr txBox="1"/>
-          <p:nvPr/>
-        </p:nvSpPr>
-        <p:spPr>
-          <a:xfrm>
-            <a:off x="5390418" y="1417563"/>
-            <a:ext cx="1005300" cy="361800"/>
-          </a:xfrm>
-          <a:prstGeom prst="rect">
-            <a:avLst/>
-          </a:prstGeom>
-          <a:solidFill>
-            <a:schemeClr val="lt1"/>
-          </a:solidFill>
-          <a:ln>
-            <a:noFill/>
-          </a:ln>
-        </p:spPr>
-        <p:txBody>
-          <a:bodyPr anchorCtr="0" anchor="t" bIns="91425" lIns="0" spcFirstLastPara="1" rIns="0" wrap="square" tIns="91425">
-            <a:spAutoFit/>
-          </a:bodyPr>
-          <a:lstStyle/>
-          <a:p>
-            <a:pPr indent="0" lvl="0" marL="0" rtl="0" algn="l">
-              <a:spcBef>
-                <a:spcPts val="0"/>
-              </a:spcBef>
-              <a:spcAft>
-                <a:spcPts val="0"/>
-              </a:spcAft>
-              <a:buNone/>
-            </a:pPr>
-            <a:r>
-              <a:rPr b="1" lang="es-419" sz="1150">
-                <a:solidFill>
-                  <a:schemeClr val="dk2"/>
-                </a:solidFill>
-              </a:rPr>
-              <a:t>Alta actividad</a:t>
-            </a:r>
-            <a:endParaRPr b="1" sz="1150">
-              <a:solidFill>
-                <a:schemeClr val="dk2"/>
-              </a:solidFill>
-            </a:endParaRPr>
-          </a:p>
-        </p:txBody>
-      </p:sp>
-      <p:sp>
-        <p:nvSpPr>
-          <p:cNvPr id="133" name="Google Shape;133;p21"/>
-          <p:cNvSpPr txBox="1"/>
-          <p:nvPr/>
-        </p:nvSpPr>
-        <p:spPr>
-          <a:xfrm>
-            <a:off x="3844128" y="1125758"/>
-            <a:ext cx="692700" cy="369300"/>
-          </a:xfrm>
-          <a:prstGeom prst="rect">
-            <a:avLst/>
-          </a:prstGeom>
-          <a:noFill/>
-          <a:ln>
-            <a:noFill/>
-          </a:ln>
-        </p:spPr>
-        <p:txBody>
-          <a:bodyPr anchorCtr="0" anchor="t" bIns="91425" lIns="91425" spcFirstLastPara="1" rIns="91425" wrap="square" tIns="91425">
-            <a:spAutoFit/>
-          </a:bodyPr>
-          <a:lstStyle/>
-          <a:p>
-            <a:pPr indent="0" lvl="0" marL="0" rtl="0" algn="l">
-              <a:spcBef>
-                <a:spcPts val="0"/>
-              </a:spcBef>
-              <a:spcAft>
-                <a:spcPts val="0"/>
-              </a:spcAft>
-              <a:buNone/>
-            </a:pPr>
-            <a:r>
-              <a:rPr b="1" lang="es-419" sz="1200">
-                <a:solidFill>
-                  <a:schemeClr val="dk2"/>
-                </a:solidFill>
-              </a:rPr>
-              <a:t>Efecto</a:t>
-            </a:r>
-            <a:endParaRPr b="1" sz="1200">
-              <a:solidFill>
-                <a:schemeClr val="dk2"/>
-              </a:solidFill>
-            </a:endParaRPr>
-          </a:p>
-        </p:txBody>
-      </p:sp>
-      <p:sp>
-        <p:nvSpPr>
-          <p:cNvPr id="134" name="Google Shape;134;p21"/>
-          <p:cNvSpPr txBox="1"/>
-          <p:nvPr/>
-        </p:nvSpPr>
-        <p:spPr>
-          <a:xfrm>
-            <a:off x="6400457" y="1417586"/>
-            <a:ext cx="1005300" cy="361800"/>
-          </a:xfrm>
-          <a:prstGeom prst="rect">
-            <a:avLst/>
-          </a:prstGeom>
-          <a:solidFill>
-            <a:schemeClr val="lt1"/>
-          </a:solidFill>
-          <a:ln>
-            <a:noFill/>
-          </a:ln>
-        </p:spPr>
-        <p:txBody>
-          <a:bodyPr anchorCtr="0" anchor="t" bIns="91425" lIns="0" spcFirstLastPara="1" rIns="0" wrap="square" tIns="91425">
-            <a:spAutoFit/>
-          </a:bodyPr>
-          <a:lstStyle/>
-          <a:p>
-            <a:pPr indent="0" lvl="0" marL="0" rtl="0" algn="l">
-              <a:spcBef>
-                <a:spcPts val="0"/>
-              </a:spcBef>
-              <a:spcAft>
-                <a:spcPts val="0"/>
-              </a:spcAft>
-              <a:buNone/>
-            </a:pPr>
-            <a:r>
-              <a:rPr b="1" lang="es-419" sz="1150">
-                <a:solidFill>
-                  <a:schemeClr val="dk2"/>
-                </a:solidFill>
-              </a:rPr>
-              <a:t>Baja actividad</a:t>
-            </a:r>
-            <a:endParaRPr b="1" sz="1150">
-              <a:solidFill>
-                <a:schemeClr val="dk2"/>
-              </a:solidFill>
-            </a:endParaRPr>
-          </a:p>
-        </p:txBody>
-      </p:sp>
-      <p:sp>
-        <p:nvSpPr>
-          <p:cNvPr id="135" name="Google Shape;135;p21"/>
-          <p:cNvSpPr txBox="1"/>
-          <p:nvPr/>
-        </p:nvSpPr>
-        <p:spPr>
-          <a:xfrm>
-            <a:off x="1029806" y="1848455"/>
-            <a:ext cx="2316000" cy="215400"/>
-          </a:xfrm>
-          <a:prstGeom prst="rect">
-            <a:avLst/>
-          </a:prstGeom>
-          <a:solidFill>
-            <a:schemeClr val="lt1"/>
-          </a:solidFill>
-          <a:ln>
-            <a:noFill/>
-          </a:ln>
-        </p:spPr>
-        <p:txBody>
-          <a:bodyPr anchorCtr="0" anchor="t" bIns="0" lIns="91425" spcFirstLastPara="1" rIns="91425" wrap="square" tIns="0">
-            <a:spAutoFit/>
-          </a:bodyPr>
-          <a:lstStyle/>
-          <a:p>
-            <a:pPr indent="0" lvl="0" marL="0" rtl="0" algn="l">
-              <a:spcBef>
-                <a:spcPts val="0"/>
-              </a:spcBef>
-              <a:spcAft>
-                <a:spcPts val="0"/>
-              </a:spcAft>
-              <a:buNone/>
-            </a:pPr>
-            <a:r>
-              <a:rPr lang="es-419">
-                <a:solidFill>
-                  <a:srgbClr val="F37336"/>
-                </a:solidFill>
-              </a:rPr>
-              <a:t>Alta actividad en HEK293</a:t>
-            </a:r>
-            <a:endParaRPr>
-              <a:solidFill>
-                <a:srgbClr val="F37336"/>
-              </a:solidFill>
-            </a:endParaRPr>
-          </a:p>
-        </p:txBody>
-      </p:sp>
-      <p:sp>
-        <p:nvSpPr>
-          <p:cNvPr id="136" name="Google Shape;136;p21"/>
-          <p:cNvSpPr txBox="1"/>
-          <p:nvPr/>
-        </p:nvSpPr>
-        <p:spPr>
-          <a:xfrm>
-            <a:off x="4675379" y="4814203"/>
-            <a:ext cx="2601600" cy="276900"/>
-          </a:xfrm>
-          <a:prstGeom prst="rect">
-            <a:avLst/>
-          </a:prstGeom>
-          <a:solidFill>
-            <a:schemeClr val="lt1"/>
-          </a:solidFill>
-          <a:ln>
-            <a:noFill/>
-          </a:ln>
-        </p:spPr>
-        <p:txBody>
-          <a:bodyPr anchorCtr="0" anchor="t" bIns="91425" lIns="91425" spcFirstLastPara="1" rIns="91425" wrap="square" tIns="0">
-            <a:spAutoFit/>
-          </a:bodyPr>
-          <a:lstStyle/>
-          <a:p>
-            <a:pPr indent="0" lvl="0" marL="0" rtl="0" algn="l">
-              <a:spcBef>
-                <a:spcPts val="0"/>
-              </a:spcBef>
-              <a:spcAft>
-                <a:spcPts val="0"/>
-              </a:spcAft>
-              <a:buNone/>
-            </a:pPr>
-            <a:r>
-              <a:rPr b="1" lang="es-419" sz="1200">
-                <a:solidFill>
-                  <a:schemeClr val="dk2"/>
-                </a:solidFill>
-              </a:rPr>
-              <a:t>Efecto sobre la actividad media</a:t>
-            </a:r>
-            <a:endParaRPr b="1" sz="1200">
-              <a:solidFill>
-                <a:schemeClr val="dk2"/>
-              </a:solidFill>
-            </a:endParaRPr>
-          </a:p>
-        </p:txBody>
-      </p:sp>
       <p:pic>
         <p:nvPicPr>
-          <p:cNvPr id="137" name="Google Shape;137;p21"/>
+          <p:cNvPr id="113" name="Google Shape;113;p21" title="tss_modelo.jpg"/>
           <p:cNvPicPr preferRelativeResize="0"/>
           <p:nvPr/>
         </p:nvPicPr>
@@ -9415,8 +9840,8 @@
         </p:blipFill>
         <p:spPr>
           <a:xfrm>
-            <a:off x="4312857" y="4652550"/>
-            <a:ext cx="3160425" cy="161650"/>
+            <a:off x="646976" y="609872"/>
+            <a:ext cx="3674501" cy="2004110"/>
           </a:xfrm>
           <a:prstGeom prst="rect">
             <a:avLst/>
@@ -9427,526 +9852,6 @@
           </a:ln>
         </p:spPr>
       </p:pic>
-      <p:sp>
-        <p:nvSpPr>
-          <p:cNvPr id="138" name="Google Shape;138;p21"/>
-          <p:cNvSpPr txBox="1"/>
-          <p:nvPr/>
-        </p:nvSpPr>
-        <p:spPr>
-          <a:xfrm>
-            <a:off x="323200" y="2075766"/>
-            <a:ext cx="4213500" cy="215400"/>
-          </a:xfrm>
-          <a:prstGeom prst="rect">
-            <a:avLst/>
-          </a:prstGeom>
-          <a:solidFill>
-            <a:schemeClr val="lt1"/>
-          </a:solidFill>
-          <a:ln>
-            <a:noFill/>
-          </a:ln>
-        </p:spPr>
-        <p:txBody>
-          <a:bodyPr anchorCtr="0" anchor="t" bIns="0" lIns="91425" spcFirstLastPara="1" rIns="91425" wrap="square" tIns="0">
-            <a:spAutoFit/>
-          </a:bodyPr>
-          <a:lstStyle/>
-          <a:p>
-            <a:pPr indent="0" lvl="0" marL="0" rtl="0" algn="l">
-              <a:spcBef>
-                <a:spcPts val="0"/>
-              </a:spcBef>
-              <a:spcAft>
-                <a:spcPts val="0"/>
-              </a:spcAft>
-              <a:buNone/>
-            </a:pPr>
-            <a:r>
-              <a:rPr lang="es-419">
-                <a:solidFill>
-                  <a:srgbClr val="F37336"/>
-                </a:solidFill>
-              </a:rPr>
-              <a:t>Alta accesibilidad a la cromatina (DNasa-seq)</a:t>
-            </a:r>
-            <a:endParaRPr>
-              <a:solidFill>
-                <a:srgbClr val="F37336"/>
-              </a:solidFill>
-            </a:endParaRPr>
-          </a:p>
-        </p:txBody>
-      </p:sp>
-      <p:sp>
-        <p:nvSpPr>
-          <p:cNvPr id="139" name="Google Shape;139;p21"/>
-          <p:cNvSpPr txBox="1"/>
-          <p:nvPr/>
-        </p:nvSpPr>
-        <p:spPr>
-          <a:xfrm>
-            <a:off x="1083060" y="2345890"/>
-            <a:ext cx="2738700" cy="215400"/>
-          </a:xfrm>
-          <a:prstGeom prst="rect">
-            <a:avLst/>
-          </a:prstGeom>
-          <a:solidFill>
-            <a:schemeClr val="lt1"/>
-          </a:solidFill>
-          <a:ln>
-            <a:noFill/>
-          </a:ln>
-        </p:spPr>
-        <p:txBody>
-          <a:bodyPr anchorCtr="0" anchor="t" bIns="0" lIns="91425" spcFirstLastPara="1" rIns="91425" wrap="square" tIns="0">
-            <a:spAutoFit/>
-          </a:bodyPr>
-          <a:lstStyle/>
-          <a:p>
-            <a:pPr indent="0" lvl="0" marL="0" rtl="0" algn="l">
-              <a:spcBef>
-                <a:spcPts val="0"/>
-              </a:spcBef>
-              <a:spcAft>
-                <a:spcPts val="0"/>
-              </a:spcAft>
-              <a:buNone/>
-            </a:pPr>
-            <a:r>
-              <a:rPr lang="es-419">
-                <a:solidFill>
-                  <a:srgbClr val="F37336"/>
-                </a:solidFill>
-              </a:rPr>
-              <a:t>Baja especificidad de tejido</a:t>
-            </a:r>
-            <a:endParaRPr>
-              <a:solidFill>
-                <a:srgbClr val="F37336"/>
-              </a:solidFill>
-            </a:endParaRPr>
-          </a:p>
-        </p:txBody>
-      </p:sp>
-      <p:sp>
-        <p:nvSpPr>
-          <p:cNvPr id="140" name="Google Shape;140;p21"/>
-          <p:cNvSpPr txBox="1"/>
-          <p:nvPr/>
-        </p:nvSpPr>
-        <p:spPr>
-          <a:xfrm>
-            <a:off x="1395994" y="2573206"/>
-            <a:ext cx="2738700" cy="215400"/>
-          </a:xfrm>
-          <a:prstGeom prst="rect">
-            <a:avLst/>
-          </a:prstGeom>
-          <a:solidFill>
-            <a:schemeClr val="lt1"/>
-          </a:solidFill>
-          <a:ln>
-            <a:noFill/>
-          </a:ln>
-        </p:spPr>
-        <p:txBody>
-          <a:bodyPr anchorCtr="0" anchor="t" bIns="0" lIns="91425" spcFirstLastPara="1" rIns="91425" wrap="square" tIns="0">
-            <a:spAutoFit/>
-          </a:bodyPr>
-          <a:lstStyle/>
-          <a:p>
-            <a:pPr indent="0" lvl="0" marL="0" rtl="0" algn="l">
-              <a:spcBef>
-                <a:spcPts val="0"/>
-              </a:spcBef>
-              <a:spcAft>
-                <a:spcPts val="0"/>
-              </a:spcAft>
-              <a:buNone/>
-            </a:pPr>
-            <a:r>
-              <a:rPr lang="es-419">
-                <a:solidFill>
-                  <a:srgbClr val="F37336"/>
-                </a:solidFill>
-              </a:rPr>
-              <a:t>Promotor disperso</a:t>
-            </a:r>
-            <a:endParaRPr>
-              <a:solidFill>
-                <a:srgbClr val="F37336"/>
-              </a:solidFill>
-            </a:endParaRPr>
-          </a:p>
-        </p:txBody>
-      </p:sp>
-      <p:sp>
-        <p:nvSpPr>
-          <p:cNvPr id="141" name="Google Shape;141;p21"/>
-          <p:cNvSpPr txBox="1"/>
-          <p:nvPr/>
-        </p:nvSpPr>
-        <p:spPr>
-          <a:xfrm>
-            <a:off x="730910" y="3079233"/>
-            <a:ext cx="3219600" cy="215400"/>
-          </a:xfrm>
-          <a:prstGeom prst="rect">
-            <a:avLst/>
-          </a:prstGeom>
-          <a:solidFill>
-            <a:schemeClr val="lt1"/>
-          </a:solidFill>
-          <a:ln>
-            <a:noFill/>
-          </a:ln>
-        </p:spPr>
-        <p:txBody>
-          <a:bodyPr anchorCtr="0" anchor="t" bIns="0" lIns="91425" spcFirstLastPara="1" rIns="91425" wrap="square" tIns="0">
-            <a:spAutoFit/>
-          </a:bodyPr>
-          <a:lstStyle/>
-          <a:p>
-            <a:pPr indent="0" lvl="0" marL="0" rtl="0" algn="l">
-              <a:spcBef>
-                <a:spcPts val="0"/>
-              </a:spcBef>
-              <a:spcAft>
-                <a:spcPts val="0"/>
-              </a:spcAft>
-              <a:buNone/>
-            </a:pPr>
-            <a:r>
-              <a:rPr lang="es-419">
-                <a:solidFill>
-                  <a:srgbClr val="24A35F"/>
-                </a:solidFill>
-              </a:rPr>
-              <a:t>Alta conservación distal (-150 a -235)</a:t>
-            </a:r>
-            <a:endParaRPr>
-              <a:solidFill>
-                <a:srgbClr val="24A35F"/>
-              </a:solidFill>
-            </a:endParaRPr>
-          </a:p>
-        </p:txBody>
-      </p:sp>
-      <p:sp>
-        <p:nvSpPr>
-          <p:cNvPr id="142" name="Google Shape;142;p21"/>
-          <p:cNvSpPr txBox="1"/>
-          <p:nvPr/>
-        </p:nvSpPr>
-        <p:spPr>
-          <a:xfrm>
-            <a:off x="1131501" y="3327953"/>
-            <a:ext cx="2738700" cy="215400"/>
-          </a:xfrm>
-          <a:prstGeom prst="rect">
-            <a:avLst/>
-          </a:prstGeom>
-          <a:solidFill>
-            <a:schemeClr val="lt1"/>
-          </a:solidFill>
-          <a:ln>
-            <a:noFill/>
-          </a:ln>
-        </p:spPr>
-        <p:txBody>
-          <a:bodyPr anchorCtr="0" anchor="t" bIns="0" lIns="91425" spcFirstLastPara="1" rIns="91425" wrap="square" tIns="0">
-            <a:spAutoFit/>
-          </a:bodyPr>
-          <a:lstStyle/>
-          <a:p>
-            <a:pPr indent="0" lvl="0" marL="0" rtl="0" algn="l">
-              <a:spcBef>
-                <a:spcPts val="0"/>
-              </a:spcBef>
-              <a:spcAft>
-                <a:spcPts val="0"/>
-              </a:spcAft>
-              <a:buNone/>
-            </a:pPr>
-            <a:r>
-              <a:rPr lang="es-419">
-                <a:solidFill>
-                  <a:srgbClr val="24A35F"/>
-                </a:solidFill>
-              </a:rPr>
-              <a:t>   Enhancers en ∓50kb</a:t>
-            </a:r>
-            <a:endParaRPr>
-              <a:solidFill>
-                <a:srgbClr val="24A35F"/>
-              </a:solidFill>
-            </a:endParaRPr>
-          </a:p>
-        </p:txBody>
-      </p:sp>
-      <p:sp>
-        <p:nvSpPr>
-          <p:cNvPr id="143" name="Google Shape;143;p21"/>
-          <p:cNvSpPr txBox="1"/>
-          <p:nvPr/>
-        </p:nvSpPr>
-        <p:spPr>
-          <a:xfrm>
-            <a:off x="1332479" y="3576678"/>
-            <a:ext cx="1876800" cy="215400"/>
-          </a:xfrm>
-          <a:prstGeom prst="rect">
-            <a:avLst/>
-          </a:prstGeom>
-          <a:solidFill>
-            <a:schemeClr val="lt1"/>
-          </a:solidFill>
-          <a:ln>
-            <a:noFill/>
-          </a:ln>
-        </p:spPr>
-        <p:txBody>
-          <a:bodyPr anchorCtr="0" anchor="t" bIns="0" lIns="91425" spcFirstLastPara="1" rIns="91425" wrap="square" tIns="0">
-            <a:spAutoFit/>
-          </a:bodyPr>
-          <a:lstStyle/>
-          <a:p>
-            <a:pPr indent="0" lvl="0" marL="0" rtl="0" algn="l">
-              <a:spcBef>
-                <a:spcPts val="0"/>
-              </a:spcBef>
-              <a:spcAft>
-                <a:spcPts val="0"/>
-              </a:spcAft>
-              <a:buNone/>
-            </a:pPr>
-            <a:r>
-              <a:rPr lang="es-419">
-                <a:solidFill>
-                  <a:srgbClr val="24A35F"/>
-                </a:solidFill>
-              </a:rPr>
-              <a:t>Promotor focalizado</a:t>
-            </a:r>
-            <a:endParaRPr>
-              <a:solidFill>
-                <a:srgbClr val="24A35F"/>
-              </a:solidFill>
-            </a:endParaRPr>
-          </a:p>
-        </p:txBody>
-      </p:sp>
-      <p:sp>
-        <p:nvSpPr>
-          <p:cNvPr id="144" name="Google Shape;144;p21"/>
-          <p:cNvSpPr txBox="1"/>
-          <p:nvPr/>
-        </p:nvSpPr>
-        <p:spPr>
-          <a:xfrm>
-            <a:off x="877750" y="3814700"/>
-            <a:ext cx="2992500" cy="215400"/>
-          </a:xfrm>
-          <a:prstGeom prst="rect">
-            <a:avLst/>
-          </a:prstGeom>
-          <a:solidFill>
-            <a:schemeClr val="lt1"/>
-          </a:solidFill>
-          <a:ln>
-            <a:noFill/>
-          </a:ln>
-        </p:spPr>
-        <p:txBody>
-          <a:bodyPr anchorCtr="0" anchor="t" bIns="0" lIns="91425" spcFirstLastPara="1" rIns="91425" wrap="square" tIns="0">
-            <a:spAutoFit/>
-          </a:bodyPr>
-          <a:lstStyle/>
-          <a:p>
-            <a:pPr indent="0" lvl="0" marL="0" rtl="0" algn="l">
-              <a:spcBef>
-                <a:spcPts val="0"/>
-              </a:spcBef>
-              <a:spcAft>
-                <a:spcPts val="0"/>
-              </a:spcAft>
-              <a:buNone/>
-            </a:pPr>
-            <a:r>
-              <a:rPr lang="es-419">
-                <a:solidFill>
-                  <a:srgbClr val="24A35F"/>
-                </a:solidFill>
-              </a:rPr>
-              <a:t>Actividad no detectada (FANTOM5)</a:t>
-            </a:r>
-            <a:endParaRPr>
-              <a:solidFill>
-                <a:srgbClr val="24A35F"/>
-              </a:solidFill>
-            </a:endParaRPr>
-          </a:p>
-        </p:txBody>
-      </p:sp>
-      <p:sp>
-        <p:nvSpPr>
-          <p:cNvPr id="145" name="Google Shape;145;p21"/>
-          <p:cNvSpPr txBox="1"/>
-          <p:nvPr/>
-        </p:nvSpPr>
-        <p:spPr>
-          <a:xfrm>
-            <a:off x="1254898" y="4052700"/>
-            <a:ext cx="2314800" cy="215400"/>
-          </a:xfrm>
-          <a:prstGeom prst="rect">
-            <a:avLst/>
-          </a:prstGeom>
-          <a:solidFill>
-            <a:schemeClr val="lt1"/>
-          </a:solidFill>
-          <a:ln>
-            <a:noFill/>
-          </a:ln>
-        </p:spPr>
-        <p:txBody>
-          <a:bodyPr anchorCtr="0" anchor="t" bIns="0" lIns="91425" spcFirstLastPara="1" rIns="91425" wrap="square" tIns="0">
-            <a:spAutoFit/>
-          </a:bodyPr>
-          <a:lstStyle/>
-          <a:p>
-            <a:pPr indent="0" lvl="0" marL="0" rtl="0" algn="l">
-              <a:spcBef>
-                <a:spcPts val="0"/>
-              </a:spcBef>
-              <a:spcAft>
-                <a:spcPts val="0"/>
-              </a:spcAft>
-              <a:buNone/>
-            </a:pPr>
-            <a:r>
-              <a:rPr lang="es-419">
-                <a:solidFill>
-                  <a:srgbClr val="24A35F"/>
-                </a:solidFill>
-              </a:rPr>
-              <a:t>Sin actividad en ratón</a:t>
-            </a:r>
-            <a:endParaRPr>
-              <a:solidFill>
-                <a:srgbClr val="24A35F"/>
-              </a:solidFill>
-            </a:endParaRPr>
-          </a:p>
-        </p:txBody>
-      </p:sp>
-      <p:sp>
-        <p:nvSpPr>
-          <p:cNvPr id="146" name="Google Shape;146;p21"/>
-          <p:cNvSpPr txBox="1"/>
-          <p:nvPr/>
-        </p:nvSpPr>
-        <p:spPr>
-          <a:xfrm>
-            <a:off x="1111750" y="4327128"/>
-            <a:ext cx="2457900" cy="215400"/>
-          </a:xfrm>
-          <a:prstGeom prst="rect">
-            <a:avLst/>
-          </a:prstGeom>
-          <a:solidFill>
-            <a:schemeClr val="lt1"/>
-          </a:solidFill>
-          <a:ln>
-            <a:noFill/>
-          </a:ln>
-        </p:spPr>
-        <p:txBody>
-          <a:bodyPr anchorCtr="0" anchor="t" bIns="0" lIns="91425" spcFirstLastPara="1" rIns="91425" wrap="square" tIns="0">
-            <a:spAutoFit/>
-          </a:bodyPr>
-          <a:lstStyle/>
-          <a:p>
-            <a:pPr indent="0" lvl="0" marL="0" rtl="0" algn="l">
-              <a:spcBef>
-                <a:spcPts val="0"/>
-              </a:spcBef>
-              <a:spcAft>
-                <a:spcPts val="0"/>
-              </a:spcAft>
-              <a:buNone/>
-            </a:pPr>
-            <a:r>
-              <a:rPr lang="es-419">
-                <a:solidFill>
-                  <a:srgbClr val="24A35F"/>
-                </a:solidFill>
-              </a:rPr>
-              <a:t>Alta especificidad de tejido</a:t>
-            </a:r>
-            <a:endParaRPr>
-              <a:solidFill>
-                <a:srgbClr val="24A35F"/>
-              </a:solidFill>
-            </a:endParaRPr>
-          </a:p>
-        </p:txBody>
-      </p:sp>
-      <p:sp>
-        <p:nvSpPr>
-          <p:cNvPr id="147" name="Google Shape;147;p21"/>
-          <p:cNvSpPr txBox="1"/>
-          <p:nvPr/>
-        </p:nvSpPr>
-        <p:spPr>
-          <a:xfrm>
-            <a:off x="1118194" y="2826206"/>
-            <a:ext cx="2738700" cy="215400"/>
-          </a:xfrm>
-          <a:prstGeom prst="rect">
-            <a:avLst/>
-          </a:prstGeom>
-          <a:solidFill>
-            <a:schemeClr val="lt1"/>
-          </a:solidFill>
-          <a:ln>
-            <a:noFill/>
-          </a:ln>
-        </p:spPr>
-        <p:txBody>
-          <a:bodyPr anchorCtr="0" anchor="t" bIns="0" lIns="91425" spcFirstLastPara="1" rIns="91425" wrap="square" tIns="0">
-            <a:spAutoFit/>
-          </a:bodyPr>
-          <a:lstStyle/>
-          <a:p>
-            <a:pPr indent="0" lvl="0" marL="0" rtl="0" algn="l">
-              <a:spcBef>
-                <a:spcPts val="0"/>
-              </a:spcBef>
-              <a:spcAft>
-                <a:spcPts val="0"/>
-              </a:spcAft>
-              <a:buNone/>
-            </a:pPr>
-            <a:r>
-              <a:rPr lang="es-419">
-                <a:solidFill>
-                  <a:srgbClr val="F37336"/>
-                </a:solidFill>
-              </a:rPr>
-              <a:t>Promotor unidireccional</a:t>
-            </a:r>
-            <a:endParaRPr>
-              <a:solidFill>
-                <a:srgbClr val="F37336"/>
-              </a:solidFill>
-            </a:endParaRPr>
-          </a:p>
-        </p:txBody>
-      </p:sp>
     </p:spTree>
   </p:cSld>
   <p:clrMapOvr>

</xml_diff>

<commit_message>
docs: resync figure numbering from Drive decks (2026-10-23)
Changed decks: Fig R2 (content changed; Fig MyM, Fig R1, Fig R3 only export noise).
No slug number changes: every Fig R2 slide 1-15 still matches the slug that holds its number. Slide 15 (tf_nfya_sp_contexto_endogeno / nfy_especificidad) remains flagged revisar, unchanged.

Co-Authored-By: Claude Opus 5.5 <noreply@anthropic.com>
</commit_message>
<xml_diff>
--- a/docs/Fig R2.pptx
+++ b/docs/Fig R2.pptx
@@ -833,7 +833,7 @@
   <p:cSld>
     <p:spTree>
       <p:nvGrpSpPr>
-        <p:cNvPr id="112" name="Shape 112"/>
+        <p:cNvPr id="100" name="Shape 100"/>
         <p:cNvGrpSpPr/>
         <p:nvPr/>
       </p:nvGrpSpPr>
@@ -847,7 +847,7 @@
       </p:grpSpPr>
       <p:sp>
         <p:nvSpPr>
-          <p:cNvPr id="113" name="Google Shape;113;h1c371980c4f29fb2_0_0:notes"/>
+          <p:cNvPr id="101" name="Google Shape;101;h1c371980c4f29fb2_0_0:notes"/>
           <p:cNvSpPr/>
           <p:nvPr>
             <p:ph idx="2" type="sldImg"/>
@@ -882,7 +882,7 @@
       </p:sp>
       <p:sp>
         <p:nvSpPr>
-          <p:cNvPr id="114" name="Google Shape;114;h1c371980c4f29fb2_0_0:notes"/>
+          <p:cNvPr id="102" name="Google Shape;102;h1c371980c4f29fb2_0_0:notes"/>
           <p:cNvSpPr txBox="1"/>
           <p:nvPr>
             <p:ph idx="1" type="body"/>
@@ -932,7 +932,7 @@
   <p:cSld>
     <p:spTree>
       <p:nvGrpSpPr>
-        <p:cNvPr id="119" name="Shape 119"/>
+        <p:cNvPr id="107" name="Shape 107"/>
         <p:cNvGrpSpPr/>
         <p:nvPr/>
       </p:nvGrpSpPr>
@@ -946,7 +946,7 @@
       </p:grpSpPr>
       <p:sp>
         <p:nvSpPr>
-          <p:cNvPr id="120" name="Google Shape;120;g3f58eefa86d_0_9:notes"/>
+          <p:cNvPr id="108" name="Google Shape;108;g3f58eefa86d_0_9:notes"/>
           <p:cNvSpPr/>
           <p:nvPr>
             <p:ph idx="2" type="sldImg"/>
@@ -981,7 +981,7 @@
       </p:sp>
       <p:sp>
         <p:nvSpPr>
-          <p:cNvPr id="121" name="Google Shape;121;g3f58eefa86d_0_9:notes"/>
+          <p:cNvPr id="109" name="Google Shape;109;g3f58eefa86d_0_9:notes"/>
           <p:cNvSpPr txBox="1"/>
           <p:nvPr>
             <p:ph idx="1" type="body"/>
@@ -1031,7 +1031,7 @@
   <p:cSld>
     <p:spTree>
       <p:nvGrpSpPr>
-        <p:cNvPr id="124" name="Shape 124"/>
+        <p:cNvPr id="112" name="Shape 112"/>
         <p:cNvGrpSpPr/>
         <p:nvPr/>
       </p:nvGrpSpPr>
@@ -1045,7 +1045,7 @@
       </p:grpSpPr>
       <p:sp>
         <p:nvSpPr>
-          <p:cNvPr id="125" name="Google Shape;125;h1c371980c4f29fb2_0_10:notes"/>
+          <p:cNvPr id="113" name="Google Shape;113;h1c371980c4f29fb2_0_10:notes"/>
           <p:cNvSpPr/>
           <p:nvPr>
             <p:ph idx="2" type="sldImg"/>
@@ -1080,7 +1080,7 @@
       </p:sp>
       <p:sp>
         <p:nvSpPr>
-          <p:cNvPr id="126" name="Google Shape;126;h1c371980c4f29fb2_0_10:notes"/>
+          <p:cNvPr id="114" name="Google Shape;114;h1c371980c4f29fb2_0_10:notes"/>
           <p:cNvSpPr txBox="1"/>
           <p:nvPr>
             <p:ph idx="1" type="body"/>
@@ -1130,7 +1130,7 @@
   <p:cSld>
     <p:spTree>
       <p:nvGrpSpPr>
-        <p:cNvPr id="131" name="Shape 131"/>
+        <p:cNvPr id="119" name="Shape 119"/>
         <p:cNvGrpSpPr/>
         <p:nvPr/>
       </p:nvGrpSpPr>
@@ -1144,7 +1144,7 @@
       </p:grpSpPr>
       <p:sp>
         <p:nvSpPr>
-          <p:cNvPr id="132" name="Google Shape;132;g3f58eefa86d_0_31:notes"/>
+          <p:cNvPr id="120" name="Google Shape;120;g3f58eefa86d_0_31:notes"/>
           <p:cNvSpPr/>
           <p:nvPr>
             <p:ph idx="2" type="sldImg"/>
@@ -1179,7 +1179,7 @@
       </p:sp>
       <p:sp>
         <p:nvSpPr>
-          <p:cNvPr id="133" name="Google Shape;133;g3f58eefa86d_0_31:notes"/>
+          <p:cNvPr id="121" name="Google Shape;121;g3f58eefa86d_0_31:notes"/>
           <p:cNvSpPr txBox="1"/>
           <p:nvPr>
             <p:ph idx="1" type="body"/>
@@ -1229,7 +1229,7 @@
   <p:cSld>
     <p:spTree>
       <p:nvGrpSpPr>
-        <p:cNvPr id="137" name="Shape 137"/>
+        <p:cNvPr id="125" name="Shape 125"/>
         <p:cNvGrpSpPr/>
         <p:nvPr/>
       </p:nvGrpSpPr>
@@ -1243,7 +1243,7 @@
       </p:grpSpPr>
       <p:sp>
         <p:nvSpPr>
-          <p:cNvPr id="138" name="Google Shape;138;g3f58eefa86d_0_117:notes"/>
+          <p:cNvPr id="126" name="Google Shape;126;g3f58eefa86d_0_117:notes"/>
           <p:cNvSpPr/>
           <p:nvPr>
             <p:ph idx="2" type="sldImg"/>
@@ -1278,7 +1278,7 @@
       </p:sp>
       <p:sp>
         <p:nvSpPr>
-          <p:cNvPr id="139" name="Google Shape;139;g3f58eefa86d_0_117:notes"/>
+          <p:cNvPr id="127" name="Google Shape;127;g3f58eefa86d_0_117:notes"/>
           <p:cNvSpPr txBox="1"/>
           <p:nvPr>
             <p:ph idx="1" type="body"/>
@@ -1328,7 +1328,7 @@
   <p:cSld>
     <p:spTree>
       <p:nvGrpSpPr>
-        <p:cNvPr id="145" name="Shape 145"/>
+        <p:cNvPr id="133" name="Shape 133"/>
         <p:cNvGrpSpPr/>
         <p:nvPr/>
       </p:nvGrpSpPr>
@@ -1342,7 +1342,7 @@
       </p:grpSpPr>
       <p:sp>
         <p:nvSpPr>
-          <p:cNvPr id="146" name="Google Shape;146;g3f58eefa86d_0_108:notes"/>
+          <p:cNvPr id="134" name="Google Shape;134;g3f58eefa86d_0_108:notes"/>
           <p:cNvSpPr/>
           <p:nvPr>
             <p:ph idx="2" type="sldImg"/>
@@ -1377,7 +1377,7 @@
       </p:sp>
       <p:sp>
         <p:nvSpPr>
-          <p:cNvPr id="147" name="Google Shape;147;g3f58eefa86d_0_108:notes"/>
+          <p:cNvPr id="135" name="Google Shape;135;g3f58eefa86d_0_108:notes"/>
           <p:cNvSpPr txBox="1"/>
           <p:nvPr>
             <p:ph idx="1" type="body"/>
@@ -1625,7 +1625,7 @@
   <p:cSld>
     <p:spTree>
       <p:nvGrpSpPr>
-        <p:cNvPr id="68" name="Shape 68"/>
+        <p:cNvPr id="66" name="Shape 66"/>
         <p:cNvGrpSpPr/>
         <p:nvPr/>
       </p:nvGrpSpPr>
@@ -1639,7 +1639,7 @@
       </p:grpSpPr>
       <p:sp>
         <p:nvSpPr>
-          <p:cNvPr id="69" name="Google Shape;69;habefdf5efa44c79_0_23:notes"/>
+          <p:cNvPr id="67" name="Google Shape;67;habefdf5efa44c79_0_23:notes"/>
           <p:cNvSpPr/>
           <p:nvPr>
             <p:ph idx="2" type="sldImg"/>
@@ -1674,7 +1674,7 @@
       </p:sp>
       <p:sp>
         <p:nvSpPr>
-          <p:cNvPr id="70" name="Google Shape;70;habefdf5efa44c79_0_23:notes"/>
+          <p:cNvPr id="68" name="Google Shape;68;habefdf5efa44c79_0_23:notes"/>
           <p:cNvSpPr txBox="1"/>
           <p:nvPr>
             <p:ph idx="1" type="body"/>
@@ -1724,7 +1724,7 @@
   <p:cSld>
     <p:spTree>
       <p:nvGrpSpPr>
-        <p:cNvPr id="77" name="Shape 77"/>
+        <p:cNvPr id="71" name="Shape 71"/>
         <p:cNvGrpSpPr/>
         <p:nvPr/>
       </p:nvGrpSpPr>
@@ -1738,7 +1738,7 @@
       </p:grpSpPr>
       <p:sp>
         <p:nvSpPr>
-          <p:cNvPr id="78" name="Google Shape;78;habefdf5efa44c79_0_42:notes"/>
+          <p:cNvPr id="72" name="Google Shape;72;habefdf5efa44c79_0_42:notes"/>
           <p:cNvSpPr/>
           <p:nvPr>
             <p:ph idx="2" type="sldImg"/>
@@ -1773,7 +1773,7 @@
       </p:sp>
       <p:sp>
         <p:nvSpPr>
-          <p:cNvPr id="79" name="Google Shape;79;habefdf5efa44c79_0_42:notes"/>
+          <p:cNvPr id="73" name="Google Shape;73;habefdf5efa44c79_0_42:notes"/>
           <p:cNvSpPr txBox="1"/>
           <p:nvPr>
             <p:ph idx="1" type="body"/>
@@ -1823,7 +1823,7 @@
   <p:cSld>
     <p:spTree>
       <p:nvGrpSpPr>
-        <p:cNvPr id="83" name="Shape 83"/>
+        <p:cNvPr id="76" name="Shape 76"/>
         <p:cNvGrpSpPr/>
         <p:nvPr/>
       </p:nvGrpSpPr>
@@ -1837,7 +1837,7 @@
       </p:grpSpPr>
       <p:sp>
         <p:nvSpPr>
-          <p:cNvPr id="84" name="Google Shape;84;habefdf5efa44c79_0_5:notes"/>
+          <p:cNvPr id="77" name="Google Shape;77;habefdf5efa44c79_0_5:notes"/>
           <p:cNvSpPr/>
           <p:nvPr>
             <p:ph idx="2" type="sldImg"/>
@@ -1872,7 +1872,7 @@
       </p:sp>
       <p:sp>
         <p:nvSpPr>
-          <p:cNvPr id="85" name="Google Shape;85;habefdf5efa44c79_0_5:notes"/>
+          <p:cNvPr id="78" name="Google Shape;78;habefdf5efa44c79_0_5:notes"/>
           <p:cNvSpPr txBox="1"/>
           <p:nvPr>
             <p:ph idx="1" type="body"/>
@@ -1922,7 +1922,7 @@
   <p:cSld>
     <p:spTree>
       <p:nvGrpSpPr>
-        <p:cNvPr id="94" name="Shape 94"/>
+        <p:cNvPr id="82" name="Shape 82"/>
         <p:cNvGrpSpPr/>
         <p:nvPr/>
       </p:nvGrpSpPr>
@@ -1936,7 +1936,7 @@
       </p:grpSpPr>
       <p:sp>
         <p:nvSpPr>
-          <p:cNvPr id="95" name="Google Shape;95;g3f58eefa86d_0_96:notes"/>
+          <p:cNvPr id="83" name="Google Shape;83;g3f58eefa86d_0_96:notes"/>
           <p:cNvSpPr/>
           <p:nvPr>
             <p:ph idx="2" type="sldImg"/>
@@ -1971,7 +1971,7 @@
       </p:sp>
       <p:sp>
         <p:nvSpPr>
-          <p:cNvPr id="96" name="Google Shape;96;g3f58eefa86d_0_96:notes"/>
+          <p:cNvPr id="84" name="Google Shape;84;g3f58eefa86d_0_96:notes"/>
           <p:cNvSpPr txBox="1"/>
           <p:nvPr>
             <p:ph idx="1" type="body"/>
@@ -2021,7 +2021,7 @@
   <p:cSld>
     <p:spTree>
       <p:nvGrpSpPr>
-        <p:cNvPr id="101" name="Shape 101"/>
+        <p:cNvPr id="89" name="Shape 89"/>
         <p:cNvGrpSpPr/>
         <p:nvPr/>
       </p:nvGrpSpPr>
@@ -2035,7 +2035,7 @@
       </p:grpSpPr>
       <p:sp>
         <p:nvSpPr>
-          <p:cNvPr id="102" name="Google Shape;102;h4ebe40c7f8899e75_0_8:notes"/>
+          <p:cNvPr id="90" name="Google Shape;90;h4ebe40c7f8899e75_0_8:notes"/>
           <p:cNvSpPr/>
           <p:nvPr>
             <p:ph idx="2" type="sldImg"/>
@@ -2070,7 +2070,7 @@
       </p:sp>
       <p:sp>
         <p:nvSpPr>
-          <p:cNvPr id="103" name="Google Shape;103;h4ebe40c7f8899e75_0_8:notes"/>
+          <p:cNvPr id="91" name="Google Shape;91;h4ebe40c7f8899e75_0_8:notes"/>
           <p:cNvSpPr txBox="1"/>
           <p:nvPr>
             <p:ph idx="1" type="body"/>
@@ -2120,7 +2120,7 @@
   <p:cSld>
     <p:spTree>
       <p:nvGrpSpPr>
-        <p:cNvPr id="106" name="Shape 106"/>
+        <p:cNvPr id="94" name="Shape 94"/>
         <p:cNvGrpSpPr/>
         <p:nvPr/>
       </p:nvGrpSpPr>
@@ -2134,7 +2134,7 @@
       </p:grpSpPr>
       <p:sp>
         <p:nvSpPr>
-          <p:cNvPr id="107" name="Google Shape;107;h4ebe40c7f8899e75_0_0:notes"/>
+          <p:cNvPr id="95" name="Google Shape;95;h4ebe40c7f8899e75_0_0:notes"/>
           <p:cNvSpPr/>
           <p:nvPr>
             <p:ph idx="2" type="sldImg"/>
@@ -2169,7 +2169,7 @@
       </p:sp>
       <p:sp>
         <p:nvSpPr>
-          <p:cNvPr id="108" name="Google Shape;108;h4ebe40c7f8899e75_0_0:notes"/>
+          <p:cNvPr id="96" name="Google Shape;96;h4ebe40c7f8899e75_0_0:notes"/>
           <p:cNvSpPr txBox="1"/>
           <p:nvPr>
             <p:ph idx="1" type="body"/>
@@ -6921,7 +6921,7 @@
   <p:cSld>
     <p:spTree>
       <p:nvGrpSpPr>
-        <p:cNvPr id="115" name="Shape 115"/>
+        <p:cNvPr id="103" name="Shape 103"/>
         <p:cNvGrpSpPr/>
         <p:nvPr/>
       </p:nvGrpSpPr>
@@ -6935,7 +6935,7 @@
       </p:grpSpPr>
       <p:pic>
         <p:nvPicPr>
-          <p:cNvPr id="116" name="Google Shape;116;p22" title="kmeros_efecto_vs_cpg.jpg"/>
+          <p:cNvPr id="104" name="Google Shape;104;p22" title="kmeros_efecto_vs_cpg.jpg"/>
           <p:cNvPicPr preferRelativeResize="0"/>
           <p:nvPr/>
         </p:nvPicPr>
@@ -6963,7 +6963,7 @@
       </p:pic>
       <p:pic>
         <p:nvPicPr>
-          <p:cNvPr id="117" name="Google Shape;117;p22" title="ebox_zeb_scatter_cgi.jpg"/>
+          <p:cNvPr id="105" name="Google Shape;105;p22" title="ebox_zeb_scatter_cgi.jpg"/>
           <p:cNvPicPr preferRelativeResize="0"/>
           <p:nvPr/>
         </p:nvPicPr>
@@ -6991,7 +6991,7 @@
       </p:pic>
       <p:pic>
         <p:nvPicPr>
-          <p:cNvPr id="118" name="Google Shape;118;p22" title="kmeros_volcano_motivos.jpg"/>
+          <p:cNvPr id="106" name="Google Shape;106;p22" title="kmeros_volcano_motivos.jpg"/>
           <p:cNvPicPr preferRelativeResize="0"/>
           <p:nvPr/>
         </p:nvPicPr>
@@ -7030,7 +7030,7 @@
   <p:cSld>
     <p:spTree>
       <p:nvGrpSpPr>
-        <p:cNvPr id="122" name="Shape 122"/>
+        <p:cNvPr id="110" name="Shape 110"/>
         <p:cNvGrpSpPr/>
         <p:nvPr/>
       </p:nvGrpSpPr>
@@ -7044,7 +7044,7 @@
       </p:grpSpPr>
       <p:pic>
         <p:nvPicPr>
-          <p:cNvPr id="123" name="Google Shape;123;p23" title="summary_seq.jpg"/>
+          <p:cNvPr id="111" name="Google Shape;111;p23" title="summary_seq.jpg"/>
           <p:cNvPicPr preferRelativeResize="0"/>
           <p:nvPr/>
         </p:nvPicPr>
@@ -7083,7 +7083,7 @@
   <p:cSld>
     <p:spTree>
       <p:nvGrpSpPr>
-        <p:cNvPr id="127" name="Shape 127"/>
+        <p:cNvPr id="115" name="Shape 115"/>
         <p:cNvGrpSpPr/>
         <p:nvPr/>
       </p:nvGrpSpPr>
@@ -7097,7 +7097,7 @@
       </p:grpSpPr>
       <p:sp>
         <p:nvSpPr>
-          <p:cNvPr id="128" name="Google Shape;128;p24"/>
+          <p:cNvPr id="116" name="Google Shape;116;p24"/>
           <p:cNvSpPr txBox="1"/>
           <p:nvPr/>
         </p:nvSpPr>
@@ -7159,7 +7159,7 @@
       </p:sp>
       <p:pic>
         <p:nvPicPr>
-          <p:cNvPr id="129" name="Google Shape;129;p24" title="p1_violines_n_elementos.jpg"/>
+          <p:cNvPr id="117" name="Google Shape;117;p24" title="p1_violines_n_elementos.jpg"/>
           <p:cNvPicPr preferRelativeResize="0"/>
           <p:nvPr/>
         </p:nvPicPr>
@@ -7187,7 +7187,7 @@
       </p:pic>
       <p:pic>
         <p:nvPicPr>
-          <p:cNvPr id="130" name="Google Shape;130;p24" title="p4_grilla_pos_x_neg.jpg"/>
+          <p:cNvPr id="118" name="Google Shape;118;p24" title="p4_grilla_pos_x_neg.jpg"/>
           <p:cNvPicPr preferRelativeResize="0"/>
           <p:nvPr/>
         </p:nvPicPr>
@@ -7226,7 +7226,7 @@
   <p:cSld>
     <p:spTree>
       <p:nvGrpSpPr>
-        <p:cNvPr id="134" name="Shape 134"/>
+        <p:cNvPr id="122" name="Shape 122"/>
         <p:cNvGrpSpPr/>
         <p:nvPr/>
       </p:nvGrpSpPr>
@@ -7240,7 +7240,7 @@
       </p:grpSpPr>
       <p:pic>
         <p:nvPicPr>
-          <p:cNvPr id="135" name="Google Shape;135;p25" title="summary_endo.jpg"/>
+          <p:cNvPr id="123" name="Google Shape;123;p25" title="summary_endo.jpg"/>
           <p:cNvPicPr preferRelativeResize="0"/>
           <p:nvPr/>
         </p:nvPicPr>
@@ -7268,7 +7268,7 @@
       </p:pic>
       <p:pic>
         <p:nvPicPr>
-          <p:cNvPr id="136" name="Google Shape;136;p25" title="secuencia_crudo_vs_ajustado.jpg"/>
+          <p:cNvPr id="124" name="Google Shape;124;p25" title="secuencia_crudo_vs_ajustado.jpg"/>
           <p:cNvPicPr preferRelativeResize="0"/>
           <p:nvPr/>
         </p:nvPicPr>
@@ -7307,7 +7307,7 @@
   <p:cSld>
     <p:spTree>
       <p:nvGrpSpPr>
-        <p:cNvPr id="140" name="Shape 140"/>
+        <p:cNvPr id="128" name="Shape 128"/>
         <p:cNvGrpSpPr/>
         <p:nvPr/>
       </p:nvGrpSpPr>
@@ -7321,7 +7321,7 @@
       </p:grpSpPr>
       <p:pic>
         <p:nvPicPr>
-          <p:cNvPr id="141" name="Google Shape;141;p26" title="remap_act.jpg"/>
+          <p:cNvPr id="129" name="Google Shape;129;p26" title="remap_act.jpg"/>
           <p:cNvPicPr preferRelativeResize="0"/>
           <p:nvPr/>
         </p:nvPicPr>
@@ -7349,7 +7349,7 @@
       </p:pic>
       <p:pic>
         <p:nvPicPr>
-          <p:cNvPr id="142" name="Google Shape;142;p26" title="remap_act_low.jpg"/>
+          <p:cNvPr id="130" name="Google Shape;130;p26" title="remap_act_low.jpg"/>
           <p:cNvPicPr preferRelativeResize="0"/>
           <p:nvPr/>
         </p:nvPicPr>
@@ -7377,7 +7377,7 @@
       </p:pic>
       <p:pic>
         <p:nvPicPr>
-          <p:cNvPr id="143" name="Google Shape;143;p26" title="GSEA_top_pathway_rep1.jpg"/>
+          <p:cNvPr id="131" name="Google Shape;131;p26" title="GSEA_top_pathway_rep1.jpg"/>
           <p:cNvPicPr preferRelativeResize="0"/>
           <p:nvPr/>
         </p:nvPicPr>
@@ -7405,7 +7405,7 @@
       </p:pic>
       <p:sp>
         <p:nvSpPr>
-          <p:cNvPr id="144" name="Google Shape;144;p26"/>
+          <p:cNvPr id="132" name="Google Shape;132;p26"/>
           <p:cNvSpPr txBox="1"/>
           <p:nvPr/>
         </p:nvSpPr>
@@ -7470,7 +7470,7 @@
   <p:cSld>
     <p:spTree>
       <p:nvGrpSpPr>
-        <p:cNvPr id="148" name="Shape 148"/>
+        <p:cNvPr id="136" name="Shape 136"/>
         <p:cNvGrpSpPr/>
         <p:nvPr/>
       </p:nvGrpSpPr>
@@ -7484,7 +7484,7 @@
       </p:grpSpPr>
       <p:pic>
         <p:nvPicPr>
-          <p:cNvPr id="149" name="Google Shape;149;p27" title="nfya_scatter_intersect.jpg"/>
+          <p:cNvPr id="137" name="Google Shape;137;p27" title="nfya_scatter_intersect.jpg"/>
           <p:cNvPicPr preferRelativeResize="0"/>
           <p:nvPr/>
         </p:nvPicPr>
@@ -7512,7 +7512,7 @@
       </p:pic>
       <p:pic>
         <p:nvPicPr>
-          <p:cNvPr id="150" name="Google Shape;150;p27" title="tf_efecto_vs_cobertura.jpg"/>
+          <p:cNvPr id="138" name="Google Shape;138;p27" title="tf_efecto_vs_cobertura.jpg"/>
           <p:cNvPicPr preferRelativeResize="0"/>
           <p:nvPr/>
         </p:nvPicPr>
@@ -7540,7 +7540,7 @@
       </p:pic>
       <p:pic>
         <p:nvPicPr>
-          <p:cNvPr id="151" name="Google Shape;151;p27" title="tf_especificidad_ccaat.jpg"/>
+          <p:cNvPr id="139" name="Google Shape;139;p27" title="tf_especificidad_ccaat.jpg"/>
           <p:cNvPicPr preferRelativeResize="0"/>
           <p:nvPr/>
         </p:nvPicPr>
@@ -7568,7 +7568,7 @@
       </p:pic>
       <p:sp>
         <p:nvSpPr>
-          <p:cNvPr id="152" name="Google Shape;152;p27"/>
+          <p:cNvPr id="140" name="Google Shape;140;p27"/>
           <p:cNvSpPr txBox="1"/>
           <p:nvPr/>
         </p:nvSpPr>
@@ -7757,7 +7757,7 @@
       </p:grpSpPr>
       <p:pic>
         <p:nvPicPr>
-          <p:cNvPr id="65" name="Google Shape;65;p15" title="TATA_scatter.jpg"/>
+          <p:cNvPr id="65" name="Google Shape;65;p15" title="tata_actividad.jpg"/>
           <p:cNvPicPr preferRelativeResize="0"/>
           <p:nvPr/>
         </p:nvPicPr>
@@ -7771,63 +7771,8 @@
         </p:blipFill>
         <p:spPr>
           <a:xfrm>
-            <a:off x="2535552" y="23153"/>
-            <a:ext cx="2124355" cy="1593266"/>
-          </a:xfrm>
-          <a:prstGeom prst="rect">
-            <a:avLst/>
-          </a:prstGeom>
-          <a:noFill/>
-          <a:ln>
-            <a:noFill/>
-          </a:ln>
-        </p:spPr>
-      </p:pic>
-      <p:pic>
-        <p:nvPicPr>
-          <p:cNvPr id="66" name="Google Shape;66;p15" title="TATA_violin_rep1.jpg"/>
-          <p:cNvPicPr preferRelativeResize="0"/>
-          <p:nvPr/>
-        </p:nvPicPr>
-        <p:blipFill>
-          <a:blip r:embed="rId4">
-            <a:alphaModFix/>
-          </a:blip>
-          <a:stretch>
-            <a:fillRect/>
-          </a:stretch>
-        </p:blipFill>
-        <p:spPr>
-          <a:xfrm>
-            <a:off x="2607266" y="1656833"/>
-            <a:ext cx="1219886" cy="914915"/>
-          </a:xfrm>
-          <a:prstGeom prst="rect">
-            <a:avLst/>
-          </a:prstGeom>
-          <a:noFill/>
-          <a:ln>
-            <a:noFill/>
-          </a:ln>
-        </p:spPr>
-      </p:pic>
-      <p:pic>
-        <p:nvPicPr>
-          <p:cNvPr id="67" name="Google Shape;67;p15" title="TATA_violin_rep2.jpg"/>
-          <p:cNvPicPr preferRelativeResize="0"/>
-          <p:nvPr/>
-        </p:nvPicPr>
-        <p:blipFill rotWithShape="1">
-          <a:blip r:embed="rId5">
-            <a:alphaModFix/>
-          </a:blip>
-          <a:srcRect b="0" l="12080" r="0" t="0"/>
-          <a:stretch/>
-        </p:blipFill>
-        <p:spPr>
-          <a:xfrm>
-            <a:off x="3755445" y="1655221"/>
-            <a:ext cx="1072584" cy="914918"/>
+            <a:off x="152400" y="152400"/>
+            <a:ext cx="5805302" cy="4838696"/>
           </a:xfrm>
           <a:prstGeom prst="rect">
             <a:avLst/>
@@ -7851,7 +7796,7 @@
   <p:cSld>
     <p:spTree>
       <p:nvGrpSpPr>
-        <p:cNvPr id="71" name="Shape 71"/>
+        <p:cNvPr id="69" name="Shape 69"/>
         <p:cNvGrpSpPr/>
         <p:nvPr/>
       </p:nvGrpSpPr>
@@ -7865,7 +7810,7 @@
       </p:grpSpPr>
       <p:pic>
         <p:nvPicPr>
-          <p:cNvPr id="72" name="Google Shape;72;p16" title="tata_posicion_perfil.jpg"/>
+          <p:cNvPr id="70" name="Google Shape;70;p16" title="tata_posicion.jpg"/>
           <p:cNvPicPr preferRelativeResize="0"/>
           <p:nvPr/>
         </p:nvPicPr>
@@ -7880,7 +7825,7 @@
         <p:spPr>
           <a:xfrm>
             <a:off x="152400" y="152400"/>
-            <a:ext cx="3255173" cy="2325351"/>
+            <a:ext cx="5147873" cy="4838699"/>
           </a:xfrm>
           <a:prstGeom prst="rect">
             <a:avLst/>
@@ -7891,182 +7836,6 @@
           </a:ln>
         </p:spPr>
       </p:pic>
-      <p:sp>
-        <p:nvSpPr>
-          <p:cNvPr id="73" name="Google Shape;73;p16"/>
-          <p:cNvSpPr txBox="1"/>
-          <p:nvPr/>
-        </p:nvSpPr>
-        <p:spPr>
-          <a:xfrm>
-            <a:off x="4434550" y="129925"/>
-            <a:ext cx="2894400" cy="2370300"/>
-          </a:xfrm>
-          <a:prstGeom prst="rect">
-            <a:avLst/>
-          </a:prstGeom>
-          <a:noFill/>
-          <a:ln>
-            <a:noFill/>
-          </a:ln>
-        </p:spPr>
-        <p:txBody>
-          <a:bodyPr anchorCtr="0" anchor="t" bIns="91425" lIns="91425" spcFirstLastPara="1" rIns="91425" wrap="square" tIns="91425">
-            <a:spAutoFit/>
-          </a:bodyPr>
-          <a:lstStyle/>
-          <a:p>
-            <a:pPr indent="0" lvl="0" marL="0" rtl="0" algn="l">
-              <a:spcBef>
-                <a:spcPts val="0"/>
-              </a:spcBef>
-              <a:spcAft>
-                <a:spcPts val="0"/>
-              </a:spcAft>
-              <a:buNone/>
-            </a:pPr>
-            <a:r>
-              <a:rPr b="1" lang="es-419" sz="1000">
-                <a:solidFill>
-                  <a:schemeClr val="dk2"/>
-                </a:solidFill>
-              </a:rPr>
-              <a:t>La TATA-box se asocia con mayor actividad solo en su posición canónica.</a:t>
-            </a:r>
-            <a:r>
-              <a:rPr b="1" lang="es-419" sz="1100">
-                <a:solidFill>
-                  <a:schemeClr val="dk1"/>
-                </a:solidFill>
-              </a:rPr>
-              <a:t> </a:t>
-            </a:r>
-            <a:r>
-              <a:rPr lang="es-419" sz="1100">
-                <a:solidFill>
-                  <a:schemeClr val="dk1"/>
-                </a:solidFill>
-              </a:rPr>
-              <a:t>Diferencia de actividad media (Hodges-Lehmann, IC 95%) entre los promotores con una TATA-box en cada ventana de 10 pb y los promotores sin TATA-box. La TATA-box se buscó con la matriz de Bucher y el corte de EPD, en la misma hebra (verde oscuro) y en la opuesta (verde claro). Puntos rellenos: BH &lt; 0,05. Abajo, el porcentaje de promotores con TATA-box en cada ventana. Franja gris: ventana canónica (−31 a −26). </a:t>
-            </a:r>
-            <a:endParaRPr sz="1000">
-              <a:solidFill>
-                <a:schemeClr val="dk2"/>
-              </a:solidFill>
-            </a:endParaRPr>
-          </a:p>
-        </p:txBody>
-      </p:sp>
-      <p:pic>
-        <p:nvPicPr>
-          <p:cNvPr id="74" name="Google Shape;74;p16" title="tata_posicion_modelo_AT.jpg"/>
-          <p:cNvPicPr preferRelativeResize="0"/>
-          <p:nvPr/>
-        </p:nvPicPr>
-        <p:blipFill>
-          <a:blip r:embed="rId4">
-            <a:alphaModFix/>
-          </a:blip>
-          <a:stretch>
-            <a:fillRect/>
-          </a:stretch>
-        </p:blipFill>
-        <p:spPr>
-          <a:xfrm>
-            <a:off x="52375" y="2571750"/>
-            <a:ext cx="3399398" cy="2718851"/>
-          </a:xfrm>
-          <a:prstGeom prst="rect">
-            <a:avLst/>
-          </a:prstGeom>
-          <a:noFill/>
-          <a:ln>
-            <a:noFill/>
-          </a:ln>
-        </p:spPr>
-      </p:pic>
-      <p:pic>
-        <p:nvPicPr>
-          <p:cNvPr id="75" name="Google Shape;75;p16" title="tata_posicion_permutadas.jpg"/>
-          <p:cNvPicPr preferRelativeResize="0"/>
-          <p:nvPr/>
-        </p:nvPicPr>
-        <p:blipFill>
-          <a:blip r:embed="rId5">
-            <a:alphaModFix/>
-          </a:blip>
-          <a:stretch>
-            <a:fillRect/>
-          </a:stretch>
-        </p:blipFill>
-        <p:spPr>
-          <a:xfrm>
-            <a:off x="3603349" y="2571750"/>
-            <a:ext cx="3399398" cy="2718863"/>
-          </a:xfrm>
-          <a:prstGeom prst="rect">
-            <a:avLst/>
-          </a:prstGeom>
-          <a:noFill/>
-          <a:ln>
-            <a:noFill/>
-          </a:ln>
-        </p:spPr>
-      </p:pic>
-      <p:sp>
-        <p:nvSpPr>
-          <p:cNvPr id="76" name="Google Shape;76;p16"/>
-          <p:cNvSpPr txBox="1"/>
-          <p:nvPr/>
-        </p:nvSpPr>
-        <p:spPr>
-          <a:xfrm>
-            <a:off x="6927650" y="3035825"/>
-            <a:ext cx="3000000" cy="1877700"/>
-          </a:xfrm>
-          <a:prstGeom prst="rect">
-            <a:avLst/>
-          </a:prstGeom>
-          <a:noFill/>
-          <a:ln>
-            <a:noFill/>
-          </a:ln>
-        </p:spPr>
-        <p:txBody>
-          <a:bodyPr anchorCtr="0" anchor="t" bIns="91425" lIns="91425" spcFirstLastPara="1" rIns="91425" wrap="square" tIns="91425">
-            <a:spAutoFit/>
-          </a:bodyPr>
-          <a:lstStyle/>
-          <a:p>
-            <a:pPr indent="0" lvl="0" marL="0" rtl="0" algn="l">
-              <a:spcBef>
-                <a:spcPts val="0"/>
-              </a:spcBef>
-              <a:spcAft>
-                <a:spcPts val="0"/>
-              </a:spcAft>
-              <a:buNone/>
-            </a:pPr>
-            <a:r>
-              <a:rPr b="1" lang="es-419" sz="1100">
-                <a:solidFill>
-                  <a:schemeClr val="dk1"/>
-                </a:solidFill>
-              </a:rPr>
-              <a:t>El efecto de la TATA-box canónica no se explica por la composición de bases.</a:t>
-            </a:r>
-            <a:r>
-              <a:rPr lang="es-419" sz="1100">
-                <a:solidFill>
-                  <a:schemeClr val="dk1"/>
-                </a:solidFill>
-              </a:rPr>
-              <a:t> (A) Coeficientes de un modelo lineal del percentil de actividad para cada clase de promotor respecto de los promotores sin TATA-box, sin ajustar y ajustando por el contenido de A/T. (B) Mismo perfil de la Figura R2.3 en la misma hebra, para la matriz real (color) y para 10 matrices con las columnas permutadas (gris).</a:t>
-            </a:r>
-            <a:endParaRPr/>
-          </a:p>
-        </p:txBody>
-      </p:sp>
     </p:spTree>
   </p:cSld>
   <p:clrMapOvr>
@@ -8080,7 +7849,7 @@
   <p:cSld>
     <p:spTree>
       <p:nvGrpSpPr>
-        <p:cNvPr id="80" name="Shape 80"/>
+        <p:cNvPr id="74" name="Shape 74"/>
         <p:cNvGrpSpPr/>
         <p:nvPr/>
       </p:nvGrpSpPr>
@@ -8094,7 +7863,7 @@
       </p:grpSpPr>
       <p:pic>
         <p:nvPicPr>
-          <p:cNvPr id="81" name="Google Shape;81;p17" title="panel_puntaje_bins.jpg"/>
+          <p:cNvPr id="75" name="Google Shape;75;p17" title="tata_puntaje_bins.jpg"/>
           <p:cNvPicPr preferRelativeResize="0"/>
           <p:nvPr/>
         </p:nvPicPr>
@@ -8108,8 +7877,8 @@
         </p:blipFill>
         <p:spPr>
           <a:xfrm>
-            <a:off x="1838526" y="-12"/>
-            <a:ext cx="5988751" cy="2807225"/>
+            <a:off x="1595275" y="1285875"/>
+            <a:ext cx="5209027" cy="2441724"/>
           </a:xfrm>
           <a:prstGeom prst="rect">
             <a:avLst/>
@@ -8120,60 +7889,6 @@
           </a:ln>
         </p:spPr>
       </p:pic>
-      <p:sp>
-        <p:nvSpPr>
-          <p:cNvPr id="82" name="Google Shape;82;p17"/>
-          <p:cNvSpPr txBox="1"/>
-          <p:nvPr/>
-        </p:nvSpPr>
-        <p:spPr>
-          <a:xfrm>
-            <a:off x="3623150" y="2807200"/>
-            <a:ext cx="3000000" cy="2385900"/>
-          </a:xfrm>
-          <a:prstGeom prst="rect">
-            <a:avLst/>
-          </a:prstGeom>
-          <a:noFill/>
-          <a:ln>
-            <a:noFill/>
-          </a:ln>
-        </p:spPr>
-        <p:txBody>
-          <a:bodyPr anchorCtr="0" anchor="t" bIns="91425" lIns="91425" spcFirstLastPara="1" rIns="91425" wrap="square" tIns="91425">
-            <a:spAutoFit/>
-          </a:bodyPr>
-          <a:lstStyle/>
-          <a:p>
-            <a:pPr indent="0" lvl="0" marL="0" rtl="0" algn="l">
-              <a:spcBef>
-                <a:spcPts val="0"/>
-              </a:spcBef>
-              <a:spcAft>
-                <a:spcPts val="0"/>
-              </a:spcAft>
-              <a:buNone/>
-            </a:pPr>
-            <a:r>
-              <a:rPr b="1" lang="es-419" sz="1100">
-                <a:solidFill>
-                  <a:schemeClr val="dk1"/>
-                </a:solidFill>
-              </a:rPr>
-              <a:t>La actividad aumenta en forma gradual con el puntaje de la TATA-box canónica.</a:t>
-            </a:r>
-            <a:r>
-              <a:rPr lang="es-419" sz="1100">
-                <a:solidFill>
-                  <a:schemeClr val="dk1"/>
-                </a:solidFill>
-              </a:rPr>
-              <a:t> Percentil de actividad medio (IC 95%) según el puntaje de la TATA-box en la ventana canónica de la Figura R2.3 (verde) o en una ventana control lejos del TSS (gris), en intervalos fijos de puntaje y en intervalos de 1 unidad. Diferencia de actividad (Hodges-Lehmann, IC 95%) de los promotores con TATA-box canónica para cortes crecientes, respecto de una referencia fija sin TATA-box. Línea vertical: corte de EPD (−8,17). </a:t>
-            </a:r>
-            <a:endParaRPr/>
-          </a:p>
-        </p:txBody>
-      </p:sp>
     </p:spTree>
   </p:cSld>
   <p:clrMapOvr>
@@ -8187,7 +7902,7 @@
   <p:cSld>
     <p:spTree>
       <p:nvGrpSpPr>
-        <p:cNvPr id="86" name="Shape 86"/>
+        <p:cNvPr id="79" name="Shape 79"/>
         <p:cNvGrpSpPr/>
         <p:nvPr/>
       </p:nvGrpSpPr>
@@ -8199,177 +7914,9 @@
           <a:chExt cx="0" cy="0"/>
         </a:xfrm>
       </p:grpSpPr>
-      <p:pic>
-        <p:nvPicPr>
-          <p:cNvPr id="87" name="Google Shape;87;p18" title="ccaat_scatter.jpg"/>
-          <p:cNvPicPr preferRelativeResize="0"/>
-          <p:nvPr/>
-        </p:nvPicPr>
-        <p:blipFill>
-          <a:blip r:embed="rId3">
-            <a:alphaModFix/>
-          </a:blip>
-          <a:stretch>
-            <a:fillRect/>
-          </a:stretch>
-        </p:blipFill>
-        <p:spPr>
-          <a:xfrm>
-            <a:off x="407676" y="213872"/>
-            <a:ext cx="2832507" cy="1593274"/>
-          </a:xfrm>
-          <a:prstGeom prst="rect">
-            <a:avLst/>
-          </a:prstGeom>
-          <a:noFill/>
-          <a:ln>
-            <a:noFill/>
-          </a:ln>
-        </p:spPr>
-      </p:pic>
-      <p:pic>
-        <p:nvPicPr>
-          <p:cNvPr id="88" name="Google Shape;88;p18" title="ccaat_violin_rep1.jpg"/>
-          <p:cNvPicPr preferRelativeResize="0"/>
-          <p:nvPr/>
-        </p:nvPicPr>
-        <p:blipFill>
-          <a:blip r:embed="rId4">
-            <a:alphaModFix/>
-          </a:blip>
-          <a:stretch>
-            <a:fillRect/>
-          </a:stretch>
-        </p:blipFill>
-        <p:spPr>
-          <a:xfrm>
-            <a:off x="520414" y="1870697"/>
-            <a:ext cx="1375375" cy="1031524"/>
-          </a:xfrm>
-          <a:prstGeom prst="rect">
-            <a:avLst/>
-          </a:prstGeom>
-          <a:noFill/>
-          <a:ln>
-            <a:noFill/>
-          </a:ln>
-        </p:spPr>
-      </p:pic>
-      <p:pic>
-        <p:nvPicPr>
-          <p:cNvPr id="89" name="Google Shape;89;p18" title="ccaat_violin_rep2.jpg"/>
-          <p:cNvPicPr preferRelativeResize="0"/>
-          <p:nvPr/>
-        </p:nvPicPr>
-        <p:blipFill>
-          <a:blip r:embed="rId5">
-            <a:alphaModFix/>
-          </a:blip>
-          <a:stretch>
-            <a:fillRect/>
-          </a:stretch>
-        </p:blipFill>
-        <p:spPr>
-          <a:xfrm>
-            <a:off x="1895788" y="1821299"/>
-            <a:ext cx="1507098" cy="1130323"/>
-          </a:xfrm>
-          <a:prstGeom prst="rect">
-            <a:avLst/>
-          </a:prstGeom>
-          <a:noFill/>
-          <a:ln>
-            <a:noFill/>
-          </a:ln>
-        </p:spPr>
-      </p:pic>
-      <p:pic>
-        <p:nvPicPr>
-          <p:cNvPr id="90" name="Google Shape;90;p18" title="gcbox_scatter.jpg"/>
-          <p:cNvPicPr preferRelativeResize="0"/>
-          <p:nvPr/>
-        </p:nvPicPr>
-        <p:blipFill>
-          <a:blip r:embed="rId6">
-            <a:alphaModFix/>
-          </a:blip>
-          <a:stretch>
-            <a:fillRect/>
-          </a:stretch>
-        </p:blipFill>
-        <p:spPr>
-          <a:xfrm>
-            <a:off x="3555280" y="152400"/>
-            <a:ext cx="3017902" cy="1697570"/>
-          </a:xfrm>
-          <a:prstGeom prst="rect">
-            <a:avLst/>
-          </a:prstGeom>
-          <a:noFill/>
-          <a:ln>
-            <a:noFill/>
-          </a:ln>
-        </p:spPr>
-      </p:pic>
-      <p:pic>
-        <p:nvPicPr>
-          <p:cNvPr id="91" name="Google Shape;91;p18" title="gcbox_violin_rep1.jpg"/>
-          <p:cNvPicPr preferRelativeResize="0"/>
-          <p:nvPr/>
-        </p:nvPicPr>
-        <p:blipFill>
-          <a:blip r:embed="rId7">
-            <a:alphaModFix/>
-          </a:blip>
-          <a:stretch>
-            <a:fillRect/>
-          </a:stretch>
-        </p:blipFill>
-        <p:spPr>
-          <a:xfrm>
-            <a:off x="3876990" y="1849968"/>
-            <a:ext cx="1396782" cy="1047587"/>
-          </a:xfrm>
-          <a:prstGeom prst="rect">
-            <a:avLst/>
-          </a:prstGeom>
-          <a:noFill/>
-          <a:ln>
-            <a:noFill/>
-          </a:ln>
-        </p:spPr>
-      </p:pic>
-      <p:pic>
-        <p:nvPicPr>
-          <p:cNvPr id="92" name="Google Shape;92;p18" title="gcbox_violin_rep2.jpg"/>
-          <p:cNvPicPr preferRelativeResize="0"/>
-          <p:nvPr/>
-        </p:nvPicPr>
-        <p:blipFill>
-          <a:blip r:embed="rId8">
-            <a:alphaModFix/>
-          </a:blip>
-          <a:stretch>
-            <a:fillRect/>
-          </a:stretch>
-        </p:blipFill>
-        <p:spPr>
-          <a:xfrm>
-            <a:off x="5261006" y="1904038"/>
-            <a:ext cx="1396782" cy="1047587"/>
-          </a:xfrm>
-          <a:prstGeom prst="rect">
-            <a:avLst/>
-          </a:prstGeom>
-          <a:noFill/>
-          <a:ln>
-            <a:noFill/>
-          </a:ln>
-        </p:spPr>
-      </p:pic>
       <p:sp>
         <p:nvSpPr>
-          <p:cNvPr id="93" name="Google Shape;93;p18"/>
+          <p:cNvPr id="80" name="Google Shape;80;p18"/>
           <p:cNvSpPr txBox="1"/>
           <p:nvPr/>
         </p:nvSpPr>
@@ -8517,6 +8064,34 @@
           </a:p>
         </p:txBody>
       </p:sp>
+      <p:pic>
+        <p:nvPicPr>
+          <p:cNvPr id="81" name="Google Shape;81;p18" title="ccaat_gcbox_actividad.jpg"/>
+          <p:cNvPicPr preferRelativeResize="0"/>
+          <p:nvPr/>
+        </p:nvPicPr>
+        <p:blipFill>
+          <a:blip r:embed="rId3">
+            <a:alphaModFix/>
+          </a:blip>
+          <a:stretch>
+            <a:fillRect/>
+          </a:stretch>
+        </p:blipFill>
+        <p:spPr>
+          <a:xfrm>
+            <a:off x="152400" y="152400"/>
+            <a:ext cx="1760297" cy="2933350"/>
+          </a:xfrm>
+          <a:prstGeom prst="rect">
+            <a:avLst/>
+          </a:prstGeom>
+          <a:noFill/>
+          <a:ln>
+            <a:noFill/>
+          </a:ln>
+        </p:spPr>
+      </p:pic>
     </p:spTree>
   </p:cSld>
   <p:clrMapOvr>
@@ -8530,7 +8105,7 @@
   <p:cSld>
     <p:spTree>
       <p:nvGrpSpPr>
-        <p:cNvPr id="97" name="Shape 97"/>
+        <p:cNvPr id="85" name="Shape 85"/>
         <p:cNvGrpSpPr/>
         <p:nvPr/>
       </p:nvGrpSpPr>
@@ -8544,7 +8119,7 @@
       </p:grpSpPr>
       <p:pic>
         <p:nvPicPr>
-          <p:cNvPr id="98" name="Google Shape;98;p19" title="ccaat_gcbox_prevalencia_cgi.jpg"/>
+          <p:cNvPr id="86" name="Google Shape;86;p19" title="ccaat_gcbox_prevalencia_cgi.jpg"/>
           <p:cNvPicPr preferRelativeResize="0"/>
           <p:nvPr/>
         </p:nvPicPr>
@@ -8572,7 +8147,7 @@
       </p:pic>
       <p:pic>
         <p:nvPicPr>
-          <p:cNvPr id="99" name="Google Shape;99;p19" title="ccaat_gcbox_efecto_cgi.jpg"/>
+          <p:cNvPr id="87" name="Google Shape;87;p19" title="ccaat_gcbox_efecto_cgi.jpg"/>
           <p:cNvPicPr preferRelativeResize="0"/>
           <p:nvPr/>
         </p:nvPicPr>
@@ -8600,7 +8175,7 @@
       </p:pic>
       <p:sp>
         <p:nvSpPr>
-          <p:cNvPr id="100" name="Google Shape;100;p19"/>
+          <p:cNvPr id="88" name="Google Shape;88;p19"/>
           <p:cNvSpPr txBox="1"/>
           <p:nvPr/>
         </p:nvSpPr>
@@ -8750,7 +8325,7 @@
   <p:cSld>
     <p:spTree>
       <p:nvGrpSpPr>
-        <p:cNvPr id="104" name="Shape 104"/>
+        <p:cNvPr id="92" name="Shape 92"/>
         <p:cNvGrpSpPr/>
         <p:nvPr/>
       </p:nvGrpSpPr>
@@ -8764,7 +8339,7 @@
       </p:grpSpPr>
       <p:pic>
         <p:nvPicPr>
-          <p:cNvPr id="105" name="Google Shape;105;p20" title="tss_perfil_efectos_promotor_hl.jpg"/>
+          <p:cNvPr id="93" name="Google Shape;93;p20" title="tss_perfil_efectos_promotor_hl.jpg"/>
           <p:cNvPicPr preferRelativeResize="0"/>
           <p:nvPr/>
         </p:nvPicPr>
@@ -8803,7 +8378,7 @@
   <p:cSld>
     <p:spTree>
       <p:nvGrpSpPr>
-        <p:cNvPr id="109" name="Shape 109"/>
+        <p:cNvPr id="97" name="Shape 97"/>
         <p:cNvGrpSpPr/>
         <p:nvPr/>
       </p:nvGrpSpPr>
@@ -8817,7 +8392,7 @@
       </p:grpSpPr>
       <p:pic>
         <p:nvPicPr>
-          <p:cNvPr id="110" name="Google Shape;110;p21" title="tss_perfil_YR_todos.jpg"/>
+          <p:cNvPr id="98" name="Google Shape;98;p21" title="tss_perfil_YR_todos.jpg"/>
           <p:cNvPicPr preferRelativeResize="0"/>
           <p:nvPr/>
         </p:nvPicPr>
@@ -8845,7 +8420,7 @@
       </p:pic>
       <p:pic>
         <p:nvPicPr>
-          <p:cNvPr id="111" name="Google Shape;111;p21" title="tss_modelo.jpg"/>
+          <p:cNvPr id="99" name="Google Shape;99;p21" title="tss_modelo.jpg"/>
           <p:cNvPicPr preferRelativeResize="0"/>
           <p:nvPr/>
         </p:nvPicPr>

</xml_diff>

<commit_message>
docs: resync figure numbering from Drive decks (2026-10-26)
Changed decks: Fig R2 (slide 14: first image replaced, now matches nfy_especificidad/nfya_scatter_intersect.jpg). Fig MyM, Fig R1, Fig R3: export noise only.

No slug number changes. tf_nfya_sp_contexto_endogeno / nfy_especificidad still flagged revisar (mapping_figuras.csv notes updated in the working tree, not committed here because the file has unrelated uncommitted edits).

Co-Authored-By: Claude Opus 5.5 <noreply@anthropic.com>
</commit_message>
<xml_diff>
--- a/docs/Fig R2.pptx
+++ b/docs/Fig R2.pptx
@@ -2,27 +2,26 @@
 <file path=ppt/presentation.xml><?xml version="1.0" encoding="utf-8"?>
 <p:presentation xmlns:a="http://schemas.openxmlformats.org/drawingml/2006/main" xmlns:r="http://schemas.openxmlformats.org/officeDocument/2006/relationships" xmlns:mc="http://schemas.openxmlformats.org/markup-compatibility/2006" xmlns:mv="urn:schemas-microsoft-com:mac:vml" xmlns:p="http://schemas.openxmlformats.org/presentationml/2006/main" xmlns:c="http://schemas.openxmlformats.org/drawingml/2006/chart" xmlns:dgm="http://schemas.openxmlformats.org/drawingml/2006/diagram" xmlns:o="urn:schemas-microsoft-com:office:office" xmlns:v="urn:schemas-microsoft-com:vml" xmlns:pvml="urn:schemas-microsoft-com:office:powerpoint" xmlns:com="http://schemas.openxmlformats.org/drawingml/2006/compatibility" xmlns:p14="http://schemas.microsoft.com/office/powerpoint/2010/main" xmlns:p15="http://schemas.microsoft.com/office/powerpoint/2012/main" xmlns:ahyp="http://schemas.microsoft.com/office/drawing/2018/hyperlinkcolor" autoCompressPictures="0" strictFirstAndLastChars="0" saveSubsetFonts="1">
   <p:sldMasterIdLst>
-    <p:sldMasterId id="2147483659" r:id="rId5"/>
+    <p:sldMasterId id="2147483659" r:id="rId4"/>
   </p:sldMasterIdLst>
   <p:notesMasterIdLst>
-    <p:notesMasterId r:id="rId6"/>
+    <p:notesMasterId r:id="rId5"/>
   </p:notesMasterIdLst>
   <p:sldIdLst>
-    <p:sldId id="256" r:id="rId7"/>
-    <p:sldId id="257" r:id="rId8"/>
-    <p:sldId id="258" r:id="rId9"/>
-    <p:sldId id="259" r:id="rId10"/>
-    <p:sldId id="260" r:id="rId11"/>
-    <p:sldId id="261" r:id="rId12"/>
-    <p:sldId id="262" r:id="rId13"/>
-    <p:sldId id="263" r:id="rId14"/>
-    <p:sldId id="264" r:id="rId15"/>
-    <p:sldId id="265" r:id="rId16"/>
-    <p:sldId id="266" r:id="rId17"/>
-    <p:sldId id="267" r:id="rId18"/>
-    <p:sldId id="268" r:id="rId19"/>
-    <p:sldId id="269" r:id="rId20"/>
-    <p:sldId id="270" r:id="rId21"/>
+    <p:sldId id="256" r:id="rId6"/>
+    <p:sldId id="257" r:id="rId7"/>
+    <p:sldId id="258" r:id="rId8"/>
+    <p:sldId id="259" r:id="rId9"/>
+    <p:sldId id="260" r:id="rId10"/>
+    <p:sldId id="261" r:id="rId11"/>
+    <p:sldId id="262" r:id="rId12"/>
+    <p:sldId id="263" r:id="rId13"/>
+    <p:sldId id="264" r:id="rId14"/>
+    <p:sldId id="265" r:id="rId15"/>
+    <p:sldId id="266" r:id="rId16"/>
+    <p:sldId id="267" r:id="rId17"/>
+    <p:sldId id="268" r:id="rId18"/>
+    <p:sldId id="269" r:id="rId19"/>
   </p:sldIdLst>
   <p:sldSz cy="5143500" cx="9144000"/>
   <p:notesSz cx="6858000" cy="9144000"/>
@@ -272,35 +271,6 @@
     </p:ext>
   </p:extLst>
 </p:presentation>
-</file>
-
-<file path=ppt/commentAuthors.xml><?xml version="1.0" encoding="utf-8"?>
-<p:cmAuthorLst xmlns:a="http://schemas.openxmlformats.org/drawingml/2006/main" xmlns:r="http://schemas.openxmlformats.org/officeDocument/2006/relationships" xmlns:mc="http://schemas.openxmlformats.org/markup-compatibility/2006" xmlns:mv="urn:schemas-microsoft-com:mac:vml" xmlns:p="http://schemas.openxmlformats.org/presentationml/2006/main" xmlns:c="http://schemas.openxmlformats.org/drawingml/2006/chart" xmlns:dgm="http://schemas.openxmlformats.org/drawingml/2006/diagram" xmlns:o="urn:schemas-microsoft-com:office:office" xmlns:v="urn:schemas-microsoft-com:vml" xmlns:pvml="urn:schemas-microsoft-com:office:powerpoint" xmlns:com="http://schemas.openxmlformats.org/drawingml/2006/compatibility" xmlns:p14="http://schemas.microsoft.com/office/powerpoint/2010/main" xmlns:p15="http://schemas.microsoft.com/office/powerpoint/2012/main" xmlns:ahyp="http://schemas.microsoft.com/office/drawing/2018/hyperlinkcolor">
-  <p:cmAuthor clrIdx="0" id="0" initials="" lastIdx="2" name="Martin Iungman"/>
-  <p:cmAuthor clrIdx="1" id="1" initials="" lastIdx="1" name="Ignacio Schor"/>
-</p:cmAuthorLst>
-</file>
-
-<file path=ppt/comments/comment1.xml><?xml version="1.0" encoding="utf-8"?>
-<p:cmLst xmlns:a="http://schemas.openxmlformats.org/drawingml/2006/main" xmlns:r="http://schemas.openxmlformats.org/officeDocument/2006/relationships" xmlns:mc="http://schemas.openxmlformats.org/markup-compatibility/2006" xmlns:mv="urn:schemas-microsoft-com:mac:vml" xmlns:p="http://schemas.openxmlformats.org/presentationml/2006/main" xmlns:c="http://schemas.openxmlformats.org/drawingml/2006/chart" xmlns:dgm="http://schemas.openxmlformats.org/drawingml/2006/diagram" xmlns:o="urn:schemas-microsoft-com:office:office" xmlns:v="urn:schemas-microsoft-com:vml" xmlns:pvml="urn:schemas-microsoft-com:office:powerpoint" xmlns:com="http://schemas.openxmlformats.org/drawingml/2006/compatibility" xmlns:p14="http://schemas.microsoft.com/office/powerpoint/2010/main" xmlns:p15="http://schemas.microsoft.com/office/powerpoint/2012/main" xmlns:ahyp="http://schemas.microsoft.com/office/drawing/2018/hyperlinkcolor">
-  <p:cm authorId="0" idx="1" dt="2026-10-15T18:20:48.941">
-    <p:pos x="96" y="1590"/>
-    <p:text>tengo un tema aca y en otros con este mismo esquema de plot.  parece que el efecto es bajo, cuando en realidad esta cayendo a la mitad. al mantener la escala fija, cuando hay poca prevalencia del feture, pasa esto. pero cambiar la escala y que no llegue a 1 me resulta raro.</p:text>
-  </p:cm>
-</p:cmLst>
-</file>
-
-<file path=ppt/comments/comment2.xml><?xml version="1.0" encoding="utf-8"?>
-<p:cmLst xmlns:a="http://schemas.openxmlformats.org/drawingml/2006/main" xmlns:r="http://schemas.openxmlformats.org/officeDocument/2006/relationships" xmlns:mc="http://schemas.openxmlformats.org/markup-compatibility/2006" xmlns:mv="urn:schemas-microsoft-com:mac:vml" xmlns:p="http://schemas.openxmlformats.org/presentationml/2006/main" xmlns:c="http://schemas.openxmlformats.org/drawingml/2006/chart" xmlns:dgm="http://schemas.openxmlformats.org/drawingml/2006/diagram" xmlns:o="urn:schemas-microsoft-com:office:office" xmlns:v="urn:schemas-microsoft-com:vml" xmlns:pvml="urn:schemas-microsoft-com:office:powerpoint" xmlns:com="http://schemas.openxmlformats.org/drawingml/2006/compatibility" xmlns:p14="http://schemas.microsoft.com/office/powerpoint/2010/main" xmlns:p15="http://schemas.microsoft.com/office/powerpoint/2012/main" xmlns:ahyp="http://schemas.microsoft.com/office/drawing/2018/hyperlinkcolor">
-  <p:cm authorId="0" idx="2" dt="2026-10-21T02:52:53.624">
-    <p:pos x="2064" y="1412"/>
-    <p:text>tal vez hacer una escala de colores para cada replica es mas correcto</p:text>
-  </p:cm>
-  <p:cm authorId="1" idx="1" dt="2026-10-21T02:52:53.624">
-    <p:pos x="2064" y="1412"/>
-    <p:text>si, definitivamente</p:text>
-  </p:cm>
-</p:cmLst>
 </file>
 
 <file path=ppt/notesMasters/notesMaster1.xml><?xml version="1.0" encoding="utf-8"?>
@@ -833,7 +803,7 @@
   <p:cSld>
     <p:spTree>
       <p:nvGrpSpPr>
-        <p:cNvPr id="100" name="Shape 100"/>
+        <p:cNvPr id="97" name="Shape 97"/>
         <p:cNvGrpSpPr/>
         <p:nvPr/>
       </p:nvGrpSpPr>
@@ -847,7 +817,7 @@
       </p:grpSpPr>
       <p:sp>
         <p:nvSpPr>
-          <p:cNvPr id="101" name="Google Shape;101;h1c371980c4f29fb2_0_0:notes"/>
+          <p:cNvPr id="98" name="Google Shape;98;g3f58eefa86d_0_9:notes"/>
           <p:cNvSpPr/>
           <p:nvPr>
             <p:ph idx="2" type="sldImg"/>
@@ -882,7 +852,7 @@
       </p:sp>
       <p:sp>
         <p:nvSpPr>
-          <p:cNvPr id="102" name="Google Shape;102;h1c371980c4f29fb2_0_0:notes"/>
+          <p:cNvPr id="99" name="Google Shape;99;g3f58eefa86d_0_9:notes"/>
           <p:cNvSpPr txBox="1"/>
           <p:nvPr>
             <p:ph idx="1" type="body"/>
@@ -932,7 +902,7 @@
   <p:cSld>
     <p:spTree>
       <p:nvGrpSpPr>
-        <p:cNvPr id="107" name="Shape 107"/>
+        <p:cNvPr id="102" name="Shape 102"/>
         <p:cNvGrpSpPr/>
         <p:nvPr/>
       </p:nvGrpSpPr>
@@ -946,7 +916,7 @@
       </p:grpSpPr>
       <p:sp>
         <p:nvSpPr>
-          <p:cNvPr id="108" name="Google Shape;108;g3f58eefa86d_0_9:notes"/>
+          <p:cNvPr id="103" name="Google Shape;103;h1c371980c4f29fb2_0_10:notes"/>
           <p:cNvSpPr/>
           <p:nvPr>
             <p:ph idx="2" type="sldImg"/>
@@ -981,7 +951,7 @@
       </p:sp>
       <p:sp>
         <p:nvSpPr>
-          <p:cNvPr id="109" name="Google Shape;109;g3f58eefa86d_0_9:notes"/>
+          <p:cNvPr id="104" name="Google Shape;104;h1c371980c4f29fb2_0_10:notes"/>
           <p:cNvSpPr txBox="1"/>
           <p:nvPr>
             <p:ph idx="1" type="body"/>
@@ -1031,7 +1001,7 @@
   <p:cSld>
     <p:spTree>
       <p:nvGrpSpPr>
-        <p:cNvPr id="112" name="Shape 112"/>
+        <p:cNvPr id="107" name="Shape 107"/>
         <p:cNvGrpSpPr/>
         <p:nvPr/>
       </p:nvGrpSpPr>
@@ -1045,7 +1015,7 @@
       </p:grpSpPr>
       <p:sp>
         <p:nvSpPr>
-          <p:cNvPr id="113" name="Google Shape;113;h1c371980c4f29fb2_0_10:notes"/>
+          <p:cNvPr id="108" name="Google Shape;108;g3f58eefa86d_0_31:notes"/>
           <p:cNvSpPr/>
           <p:nvPr>
             <p:ph idx="2" type="sldImg"/>
@@ -1080,7 +1050,7 @@
       </p:sp>
       <p:sp>
         <p:nvSpPr>
-          <p:cNvPr id="114" name="Google Shape;114;h1c371980c4f29fb2_0_10:notes"/>
+          <p:cNvPr id="109" name="Google Shape;109;g3f58eefa86d_0_31:notes"/>
           <p:cNvSpPr txBox="1"/>
           <p:nvPr>
             <p:ph idx="1" type="body"/>
@@ -1130,7 +1100,7 @@
   <p:cSld>
     <p:spTree>
       <p:nvGrpSpPr>
-        <p:cNvPr id="119" name="Shape 119"/>
+        <p:cNvPr id="112" name="Shape 112"/>
         <p:cNvGrpSpPr/>
         <p:nvPr/>
       </p:nvGrpSpPr>
@@ -1144,7 +1114,7 @@
       </p:grpSpPr>
       <p:sp>
         <p:nvSpPr>
-          <p:cNvPr id="120" name="Google Shape;120;g3f58eefa86d_0_31:notes"/>
+          <p:cNvPr id="113" name="Google Shape;113;g3f58eefa86d_0_117:notes"/>
           <p:cNvSpPr/>
           <p:nvPr>
             <p:ph idx="2" type="sldImg"/>
@@ -1179,7 +1149,7 @@
       </p:sp>
       <p:sp>
         <p:nvSpPr>
-          <p:cNvPr id="121" name="Google Shape;121;g3f58eefa86d_0_31:notes"/>
+          <p:cNvPr id="114" name="Google Shape;114;g3f58eefa86d_0_117:notes"/>
           <p:cNvSpPr txBox="1"/>
           <p:nvPr>
             <p:ph idx="1" type="body"/>
@@ -1229,7 +1199,7 @@
   <p:cSld>
     <p:spTree>
       <p:nvGrpSpPr>
-        <p:cNvPr id="125" name="Shape 125"/>
+        <p:cNvPr id="120" name="Shape 120"/>
         <p:cNvGrpSpPr/>
         <p:nvPr/>
       </p:nvGrpSpPr>
@@ -1243,7 +1213,7 @@
       </p:grpSpPr>
       <p:sp>
         <p:nvSpPr>
-          <p:cNvPr id="126" name="Google Shape;126;g3f58eefa86d_0_117:notes"/>
+          <p:cNvPr id="121" name="Google Shape;121;g3f58eefa86d_0_108:notes"/>
           <p:cNvSpPr/>
           <p:nvPr>
             <p:ph idx="2" type="sldImg"/>
@@ -1278,106 +1248,7 @@
       </p:sp>
       <p:sp>
         <p:nvSpPr>
-          <p:cNvPr id="127" name="Google Shape;127;g3f58eefa86d_0_117:notes"/>
-          <p:cNvSpPr txBox="1"/>
-          <p:nvPr>
-            <p:ph idx="1" type="body"/>
-          </p:nvPr>
-        </p:nvSpPr>
-        <p:spPr>
-          <a:xfrm>
-            <a:off x="685800" y="4343400"/>
-            <a:ext cx="5486400" cy="4114800"/>
-          </a:xfrm>
-          <a:prstGeom prst="rect">
-            <a:avLst/>
-          </a:prstGeom>
-        </p:spPr>
-        <p:txBody>
-          <a:bodyPr anchorCtr="0" anchor="t" bIns="91425" lIns="91425" spcFirstLastPara="1" rIns="91425" wrap="square" tIns="91425">
-            <a:noAutofit/>
-          </a:bodyPr>
-          <a:lstStyle/>
-          <a:p>
-            <a:pPr indent="0" lvl="0" marL="0" rtl="0" algn="l">
-              <a:spcBef>
-                <a:spcPts val="0"/>
-              </a:spcBef>
-              <a:spcAft>
-                <a:spcPts val="0"/>
-              </a:spcAft>
-              <a:buNone/>
-            </a:pPr>
-            <a:r>
-              <a:t/>
-            </a:r>
-            <a:endParaRPr/>
-          </a:p>
-        </p:txBody>
-      </p:sp>
-    </p:spTree>
-  </p:cSld>
-  <p:clrMapOvr>
-    <a:masterClrMapping/>
-  </p:clrMapOvr>
-</p:notes>
-</file>
-
-<file path=ppt/notesSlides/notesSlide15.xml><?xml version="1.0" encoding="utf-8"?>
-<p:notes xmlns:a="http://schemas.openxmlformats.org/drawingml/2006/main" xmlns:r="http://schemas.openxmlformats.org/officeDocument/2006/relationships" xmlns:mc="http://schemas.openxmlformats.org/markup-compatibility/2006" xmlns:mv="urn:schemas-microsoft-com:mac:vml" xmlns:p="http://schemas.openxmlformats.org/presentationml/2006/main" xmlns:c="http://schemas.openxmlformats.org/drawingml/2006/chart" xmlns:dgm="http://schemas.openxmlformats.org/drawingml/2006/diagram" xmlns:o="urn:schemas-microsoft-com:office:office" xmlns:v="urn:schemas-microsoft-com:vml" xmlns:pvml="urn:schemas-microsoft-com:office:powerpoint" xmlns:com="http://schemas.openxmlformats.org/drawingml/2006/compatibility" xmlns:p14="http://schemas.microsoft.com/office/powerpoint/2010/main" xmlns:p15="http://schemas.microsoft.com/office/powerpoint/2012/main" xmlns:ahyp="http://schemas.microsoft.com/office/drawing/2018/hyperlinkcolor" showMasterPhAnim="0" showMasterSp="0">
-  <p:cSld>
-    <p:spTree>
-      <p:nvGrpSpPr>
-        <p:cNvPr id="133" name="Shape 133"/>
-        <p:cNvGrpSpPr/>
-        <p:nvPr/>
-      </p:nvGrpSpPr>
-      <p:grpSpPr>
-        <a:xfrm>
-          <a:off x="0" y="0"/>
-          <a:ext cx="0" cy="0"/>
-          <a:chOff x="0" y="0"/>
-          <a:chExt cx="0" cy="0"/>
-        </a:xfrm>
-      </p:grpSpPr>
-      <p:sp>
-        <p:nvSpPr>
-          <p:cNvPr id="134" name="Google Shape;134;g3f58eefa86d_0_108:notes"/>
-          <p:cNvSpPr/>
-          <p:nvPr>
-            <p:ph idx="2" type="sldImg"/>
-          </p:nvPr>
-        </p:nvSpPr>
-        <p:spPr>
-          <a:xfrm>
-            <a:off x="381300" y="685800"/>
-            <a:ext cx="6096000" cy="3429000"/>
-          </a:xfrm>
-          <a:custGeom>
-            <a:rect b="b" l="l" r="r" t="t"/>
-            <a:pathLst>
-              <a:path extrusionOk="0" h="120000" w="120000">
-                <a:moveTo>
-                  <a:pt x="0" y="0"/>
-                </a:moveTo>
-                <a:lnTo>
-                  <a:pt x="120000" y="0"/>
-                </a:lnTo>
-                <a:lnTo>
-                  <a:pt x="120000" y="120000"/>
-                </a:lnTo>
-                <a:lnTo>
-                  <a:pt x="0" y="120000"/>
-                </a:lnTo>
-                <a:close/>
-              </a:path>
-            </a:pathLst>
-          </a:custGeom>
-        </p:spPr>
-      </p:sp>
-      <p:sp>
-        <p:nvSpPr>
-          <p:cNvPr id="135" name="Google Shape;135;g3f58eefa86d_0_108:notes"/>
+          <p:cNvPr id="122" name="Google Shape;122;g3f58eefa86d_0_108:notes"/>
           <p:cNvSpPr txBox="1"/>
           <p:nvPr>
             <p:ph idx="1" type="body"/>
@@ -1922,7 +1793,7 @@
   <p:cSld>
     <p:spTree>
       <p:nvGrpSpPr>
-        <p:cNvPr id="82" name="Shape 82"/>
+        <p:cNvPr id="81" name="Shape 81"/>
         <p:cNvGrpSpPr/>
         <p:nvPr/>
       </p:nvGrpSpPr>
@@ -1936,7 +1807,7 @@
       </p:grpSpPr>
       <p:sp>
         <p:nvSpPr>
-          <p:cNvPr id="83" name="Google Shape;83;g3f58eefa86d_0_96:notes"/>
+          <p:cNvPr id="82" name="Google Shape;82;h4ebe40c7f8899e75_0_8:notes"/>
           <p:cNvSpPr/>
           <p:nvPr>
             <p:ph idx="2" type="sldImg"/>
@@ -1971,7 +1842,7 @@
       </p:sp>
       <p:sp>
         <p:nvSpPr>
-          <p:cNvPr id="84" name="Google Shape;84;g3f58eefa86d_0_96:notes"/>
+          <p:cNvPr id="83" name="Google Shape;83;h4ebe40c7f8899e75_0_8:notes"/>
           <p:cNvSpPr txBox="1"/>
           <p:nvPr>
             <p:ph idx="1" type="body"/>
@@ -2021,7 +1892,7 @@
   <p:cSld>
     <p:spTree>
       <p:nvGrpSpPr>
-        <p:cNvPr id="89" name="Shape 89"/>
+        <p:cNvPr id="86" name="Shape 86"/>
         <p:cNvGrpSpPr/>
         <p:nvPr/>
       </p:nvGrpSpPr>
@@ -2035,7 +1906,7 @@
       </p:grpSpPr>
       <p:sp>
         <p:nvSpPr>
-          <p:cNvPr id="90" name="Google Shape;90;h4ebe40c7f8899e75_0_8:notes"/>
+          <p:cNvPr id="87" name="Google Shape;87;h4ebe40c7f8899e75_0_0:notes"/>
           <p:cNvSpPr/>
           <p:nvPr>
             <p:ph idx="2" type="sldImg"/>
@@ -2070,7 +1941,7 @@
       </p:sp>
       <p:sp>
         <p:nvSpPr>
-          <p:cNvPr id="91" name="Google Shape;91;h4ebe40c7f8899e75_0_8:notes"/>
+          <p:cNvPr id="88" name="Google Shape;88;h4ebe40c7f8899e75_0_0:notes"/>
           <p:cNvSpPr txBox="1"/>
           <p:nvPr>
             <p:ph idx="1" type="body"/>
@@ -2120,7 +1991,7 @@
   <p:cSld>
     <p:spTree>
       <p:nvGrpSpPr>
-        <p:cNvPr id="94" name="Shape 94"/>
+        <p:cNvPr id="92" name="Shape 92"/>
         <p:cNvGrpSpPr/>
         <p:nvPr/>
       </p:nvGrpSpPr>
@@ -2134,7 +2005,7 @@
       </p:grpSpPr>
       <p:sp>
         <p:nvSpPr>
-          <p:cNvPr id="95" name="Google Shape;95;h4ebe40c7f8899e75_0_0:notes"/>
+          <p:cNvPr id="93" name="Google Shape;93;h1c371980c4f29fb2_0_0:notes"/>
           <p:cNvSpPr/>
           <p:nvPr>
             <p:ph idx="2" type="sldImg"/>
@@ -2169,7 +2040,7 @@
       </p:sp>
       <p:sp>
         <p:nvSpPr>
-          <p:cNvPr id="96" name="Google Shape;96;h4ebe40c7f8899e75_0_0:notes"/>
+          <p:cNvPr id="94" name="Google Shape;94;h1c371980c4f29fb2_0_0:notes"/>
           <p:cNvSpPr txBox="1"/>
           <p:nvPr>
             <p:ph idx="1" type="body"/>
@@ -6921,7 +6792,7 @@
   <p:cSld>
     <p:spTree>
       <p:nvGrpSpPr>
-        <p:cNvPr id="103" name="Shape 103"/>
+        <p:cNvPr id="100" name="Shape 100"/>
         <p:cNvGrpSpPr/>
         <p:nvPr/>
       </p:nvGrpSpPr>
@@ -6935,12 +6806,12 @@
       </p:grpSpPr>
       <p:pic>
         <p:nvPicPr>
-          <p:cNvPr id="104" name="Google Shape;104;p22" title="kmeros_efecto_vs_cpg.jpg"/>
+          <p:cNvPr id="101" name="Google Shape;101;p22" title="summary_seq.jpg"/>
           <p:cNvPicPr preferRelativeResize="0"/>
           <p:nvPr/>
         </p:nvPicPr>
         <p:blipFill>
-          <a:blip r:embed="rId4">
+          <a:blip r:embed="rId3">
             <a:alphaModFix/>
           </a:blip>
           <a:stretch>
@@ -6949,64 +6820,8 @@
         </p:blipFill>
         <p:spPr>
           <a:xfrm>
-            <a:off x="0" y="-1"/>
-            <a:ext cx="5610598" cy="2372450"/>
-          </a:xfrm>
-          <a:prstGeom prst="rect">
-            <a:avLst/>
-          </a:prstGeom>
-          <a:noFill/>
-          <a:ln>
-            <a:noFill/>
-          </a:ln>
-        </p:spPr>
-      </p:pic>
-      <p:pic>
-        <p:nvPicPr>
-          <p:cNvPr id="105" name="Google Shape;105;p22" title="ebox_zeb_scatter_cgi.jpg"/>
-          <p:cNvPicPr preferRelativeResize="0"/>
-          <p:nvPr/>
-        </p:nvPicPr>
-        <p:blipFill>
-          <a:blip r:embed="rId5">
-            <a:alphaModFix/>
-          </a:blip>
-          <a:stretch>
-            <a:fillRect/>
-          </a:stretch>
-        </p:blipFill>
-        <p:spPr>
-          <a:xfrm>
-            <a:off x="152400" y="2524849"/>
-            <a:ext cx="4384445" cy="2466251"/>
-          </a:xfrm>
-          <a:prstGeom prst="rect">
-            <a:avLst/>
-          </a:prstGeom>
-          <a:noFill/>
-          <a:ln>
-            <a:noFill/>
-          </a:ln>
-        </p:spPr>
-      </p:pic>
-      <p:pic>
-        <p:nvPicPr>
-          <p:cNvPr id="106" name="Google Shape;106;p22" title="kmeros_volcano_motivos.jpg"/>
-          <p:cNvPicPr preferRelativeResize="0"/>
-          <p:nvPr/>
-        </p:nvPicPr>
-        <p:blipFill>
-          <a:blip r:embed="rId6">
-            <a:alphaModFix/>
-          </a:blip>
-          <a:stretch>
-            <a:fillRect/>
-          </a:stretch>
-        </p:blipFill>
-        <p:spPr>
-          <a:xfrm>
-            <a:off x="5762998" y="152400"/>
-            <a:ext cx="3228600" cy="2536532"/>
+            <a:off x="152400" y="152400"/>
+            <a:ext cx="8839204" cy="4419602"/>
           </a:xfrm>
           <a:prstGeom prst="rect">
             <a:avLst/>
@@ -7026,6 +6841,59 @@
 </file>
 
 <file path=ppt/slides/slide11.xml><?xml version="1.0" encoding="utf-8"?>
+<p:sld xmlns:a="http://schemas.openxmlformats.org/drawingml/2006/main" xmlns:r="http://schemas.openxmlformats.org/officeDocument/2006/relationships" xmlns:mc="http://schemas.openxmlformats.org/markup-compatibility/2006" xmlns:mv="urn:schemas-microsoft-com:mac:vml" xmlns:p="http://schemas.openxmlformats.org/presentationml/2006/main" xmlns:c="http://schemas.openxmlformats.org/drawingml/2006/chart" xmlns:dgm="http://schemas.openxmlformats.org/drawingml/2006/diagram" xmlns:o="urn:schemas-microsoft-com:office:office" xmlns:v="urn:schemas-microsoft-com:vml" xmlns:pvml="urn:schemas-microsoft-com:office:powerpoint" xmlns:com="http://schemas.openxmlformats.org/drawingml/2006/compatibility" xmlns:p14="http://schemas.microsoft.com/office/powerpoint/2010/main" xmlns:p15="http://schemas.microsoft.com/office/powerpoint/2012/main" xmlns:ahyp="http://schemas.microsoft.com/office/drawing/2018/hyperlinkcolor">
+  <p:cSld>
+    <p:spTree>
+      <p:nvGrpSpPr>
+        <p:cNvPr id="105" name="Shape 105"/>
+        <p:cNvGrpSpPr/>
+        <p:nvPr/>
+      </p:nvGrpSpPr>
+      <p:grpSpPr>
+        <a:xfrm>
+          <a:off x="0" y="0"/>
+          <a:ext cx="0" cy="0"/>
+          <a:chOff x="0" y="0"/>
+          <a:chExt cx="0" cy="0"/>
+        </a:xfrm>
+      </p:grpSpPr>
+      <p:pic>
+        <p:nvPicPr>
+          <p:cNvPr id="106" name="Google Shape;106;p23" title="aditividad_elementos_promotor.jpg"/>
+          <p:cNvPicPr preferRelativeResize="0"/>
+          <p:nvPr/>
+        </p:nvPicPr>
+        <p:blipFill>
+          <a:blip r:embed="rId3">
+            <a:alphaModFix/>
+          </a:blip>
+          <a:stretch>
+            <a:fillRect/>
+          </a:stretch>
+        </p:blipFill>
+        <p:spPr>
+          <a:xfrm>
+            <a:off x="3152400" y="152400"/>
+            <a:ext cx="5582909" cy="4838703"/>
+          </a:xfrm>
+          <a:prstGeom prst="rect">
+            <a:avLst/>
+          </a:prstGeom>
+          <a:noFill/>
+          <a:ln>
+            <a:noFill/>
+          </a:ln>
+        </p:spPr>
+      </p:pic>
+    </p:spTree>
+  </p:cSld>
+  <p:clrMapOvr>
+    <a:masterClrMapping/>
+  </p:clrMapOvr>
+</p:sld>
+</file>
+
+<file path=ppt/slides/slide12.xml><?xml version="1.0" encoding="utf-8"?>
 <p:sld xmlns:a="http://schemas.openxmlformats.org/drawingml/2006/main" xmlns:r="http://schemas.openxmlformats.org/officeDocument/2006/relationships" xmlns:mc="http://schemas.openxmlformats.org/markup-compatibility/2006" xmlns:mv="urn:schemas-microsoft-com:mac:vml" xmlns:p="http://schemas.openxmlformats.org/presentationml/2006/main" xmlns:c="http://schemas.openxmlformats.org/drawingml/2006/chart" xmlns:dgm="http://schemas.openxmlformats.org/drawingml/2006/diagram" xmlns:o="urn:schemas-microsoft-com:office:office" xmlns:v="urn:schemas-microsoft-com:vml" xmlns:pvml="urn:schemas-microsoft-com:office:powerpoint" xmlns:com="http://schemas.openxmlformats.org/drawingml/2006/compatibility" xmlns:p14="http://schemas.microsoft.com/office/powerpoint/2010/main" xmlns:p15="http://schemas.microsoft.com/office/powerpoint/2012/main" xmlns:ahyp="http://schemas.microsoft.com/office/drawing/2018/hyperlinkcolor">
   <p:cSld>
     <p:spTree>
@@ -7044,7 +6912,7 @@
       </p:grpSpPr>
       <p:pic>
         <p:nvPicPr>
-          <p:cNvPr id="111" name="Google Shape;111;p23" title="summary_seq.jpg"/>
+          <p:cNvPr id="111" name="Google Shape;111;p24" title="summary_features_endogeno.jpg"/>
           <p:cNvPicPr preferRelativeResize="0"/>
           <p:nvPr/>
         </p:nvPicPr>
@@ -7059,7 +6927,7 @@
         <p:spPr>
           <a:xfrm>
             <a:off x="152400" y="152400"/>
-            <a:ext cx="8839204" cy="4419602"/>
+            <a:ext cx="4214963" cy="4838702"/>
           </a:xfrm>
           <a:prstGeom prst="rect">
             <a:avLst/>
@@ -7078,7 +6946,7 @@
 </p:sld>
 </file>
 
-<file path=ppt/slides/slide12.xml><?xml version="1.0" encoding="utf-8"?>
+<file path=ppt/slides/slide13.xml><?xml version="1.0" encoding="utf-8"?>
 <p:sld xmlns:a="http://schemas.openxmlformats.org/drawingml/2006/main" xmlns:r="http://schemas.openxmlformats.org/officeDocument/2006/relationships" xmlns:mc="http://schemas.openxmlformats.org/markup-compatibility/2006" xmlns:mv="urn:schemas-microsoft-com:mac:vml" xmlns:p="http://schemas.openxmlformats.org/presentationml/2006/main" xmlns:c="http://schemas.openxmlformats.org/drawingml/2006/chart" xmlns:dgm="http://schemas.openxmlformats.org/drawingml/2006/diagram" xmlns:o="urn:schemas-microsoft-com:office:office" xmlns:v="urn:schemas-microsoft-com:vml" xmlns:pvml="urn:schemas-microsoft-com:office:powerpoint" xmlns:com="http://schemas.openxmlformats.org/drawingml/2006/compatibility" xmlns:p14="http://schemas.microsoft.com/office/powerpoint/2010/main" xmlns:p15="http://schemas.microsoft.com/office/powerpoint/2012/main" xmlns:ahyp="http://schemas.microsoft.com/office/drawing/2018/hyperlinkcolor">
   <p:cSld>
     <p:spTree>
@@ -7095,16 +6963,24 @@
           <a:chExt cx="0" cy="0"/>
         </a:xfrm>
       </p:grpSpPr>
-      <p:sp>
-        <p:nvSpPr>
-          <p:cNvPr id="116" name="Google Shape;116;p24"/>
-          <p:cNvSpPr txBox="1"/>
+      <p:pic>
+        <p:nvPicPr>
+          <p:cNvPr id="116" name="Google Shape;116;p25" title="remap_act.jpg"/>
+          <p:cNvPicPr preferRelativeResize="0"/>
           <p:nvPr/>
-        </p:nvSpPr>
-        <p:spPr>
-          <a:xfrm>
-            <a:off x="0" y="0"/>
-            <a:ext cx="3000000" cy="2647500"/>
+        </p:nvPicPr>
+        <p:blipFill>
+          <a:blip r:embed="rId3">
+            <a:alphaModFix/>
+          </a:blip>
+          <a:stretch>
+            <a:fillRect/>
+          </a:stretch>
+        </p:blipFill>
+        <p:spPr>
+          <a:xfrm>
+            <a:off x="184850" y="205750"/>
+            <a:ext cx="3154673" cy="2366001"/>
           </a:xfrm>
           <a:prstGeom prst="rect">
             <a:avLst/>
@@ -7114,52 +6990,10 @@
             <a:noFill/>
           </a:ln>
         </p:spPr>
-        <p:txBody>
-          <a:bodyPr anchorCtr="0" anchor="t" bIns="91425" lIns="91425" spcFirstLastPara="1" rIns="91425" wrap="square" tIns="91425">
-            <a:spAutoFit/>
-          </a:bodyPr>
-          <a:lstStyle/>
-          <a:p>
-            <a:pPr indent="0" lvl="0" marL="0" rtl="0" algn="l">
-              <a:spcBef>
-                <a:spcPts val="0"/>
-              </a:spcBef>
-              <a:spcAft>
-                <a:spcPts val="0"/>
-              </a:spcAft>
-              <a:buNone/>
-            </a:pPr>
-            <a:r>
-              <a:rPr b="1" lang="es-419" sz="1000">
-                <a:solidFill>
-                  <a:schemeClr val="dk1"/>
-                </a:solidFill>
-              </a:rPr>
-              <a:t>F</a:t>
-            </a:r>
-            <a:r>
-              <a:rPr b="1" lang="es-419" sz="1000">
-                <a:solidFill>
-                  <a:schemeClr val="dk1"/>
-                </a:solidFill>
-              </a:rPr>
-              <a:t>igura R2.12. Los elementos del promotor basal combinan sus efectos de forma aproximadamente aditiva.</a:t>
-            </a:r>
-            <a:r>
-              <a:rPr lang="es-419" sz="1000">
-                <a:solidFill>
-                  <a:schemeClr val="dk1"/>
-                </a:solidFill>
-              </a:rPr>
-              <a:t> (A) Distribución de la actividad media de los promotores según el número de elementos asociados a mayor actividad que contienen (isla CpG, TATA-box, CCAAT-box, sitio de YY1 y CRE), para cada réplica. Sobre cada violín se indica el número de promotores. (B) Mediana de la actividad media según el número de elementos positivos (columnas) y de características asociadas a menor actividad (TSS no canónico, E-box CAGGTR y tramo poli(dA:dT) proximal; filas), para cada réplica. En cada celda se indican la mediana y el número de promotores; se omiten las celdas con menos de 50 promotores. </a:t>
-            </a:r>
-            <a:endParaRPr sz="1000"/>
-          </a:p>
-        </p:txBody>
-      </p:sp>
+      </p:pic>
       <p:pic>
         <p:nvPicPr>
-          <p:cNvPr id="117" name="Google Shape;117;p24" title="p1_violines_n_elementos.jpg"/>
+          <p:cNvPr id="117" name="Google Shape;117;p25" title="remap_act_low.jpg"/>
           <p:cNvPicPr preferRelativeResize="0"/>
           <p:nvPr/>
         </p:nvPicPr>
@@ -7173,8 +7007,8 @@
         </p:blipFill>
         <p:spPr>
           <a:xfrm>
-            <a:off x="3559375" y="0"/>
-            <a:ext cx="4419599" cy="2209800"/>
+            <a:off x="5159224" y="-52348"/>
+            <a:ext cx="2235203" cy="1986362"/>
           </a:xfrm>
           <a:prstGeom prst="rect">
             <a:avLst/>
@@ -7187,7 +7021,7 @@
       </p:pic>
       <p:pic>
         <p:nvPicPr>
-          <p:cNvPr id="118" name="Google Shape;118;p24" title="p4_grilla_pos_x_neg.jpg"/>
+          <p:cNvPr id="118" name="Google Shape;118;p25" title="GSEA_top_pathway_rep1.jpg"/>
           <p:cNvPicPr preferRelativeResize="0"/>
           <p:nvPr/>
         </p:nvPicPr>
@@ -7201,8 +7035,8 @@
         </p:blipFill>
         <p:spPr>
           <a:xfrm>
-            <a:off x="3278100" y="2241950"/>
-            <a:ext cx="5347702" cy="2467575"/>
+            <a:off x="4744150" y="2046525"/>
+            <a:ext cx="3154673" cy="2366001"/>
           </a:xfrm>
           <a:prstGeom prst="rect">
             <a:avLst/>
@@ -7213,199 +7047,9 @@
           </a:ln>
         </p:spPr>
       </p:pic>
-    </p:spTree>
-  </p:cSld>
-  <p:clrMapOvr>
-    <a:masterClrMapping/>
-  </p:clrMapOvr>
-</p:sld>
-</file>
-
-<file path=ppt/slides/slide13.xml><?xml version="1.0" encoding="utf-8"?>
-<p:sld xmlns:a="http://schemas.openxmlformats.org/drawingml/2006/main" xmlns:r="http://schemas.openxmlformats.org/officeDocument/2006/relationships" xmlns:mc="http://schemas.openxmlformats.org/markup-compatibility/2006" xmlns:mv="urn:schemas-microsoft-com:mac:vml" xmlns:p="http://schemas.openxmlformats.org/presentationml/2006/main" xmlns:c="http://schemas.openxmlformats.org/drawingml/2006/chart" xmlns:dgm="http://schemas.openxmlformats.org/drawingml/2006/diagram" xmlns:o="urn:schemas-microsoft-com:office:office" xmlns:v="urn:schemas-microsoft-com:vml" xmlns:pvml="urn:schemas-microsoft-com:office:powerpoint" xmlns:com="http://schemas.openxmlformats.org/drawingml/2006/compatibility" xmlns:p14="http://schemas.microsoft.com/office/powerpoint/2010/main" xmlns:p15="http://schemas.microsoft.com/office/powerpoint/2012/main" xmlns:ahyp="http://schemas.microsoft.com/office/drawing/2018/hyperlinkcolor">
-  <p:cSld>
-    <p:spTree>
-      <p:nvGrpSpPr>
-        <p:cNvPr id="122" name="Shape 122"/>
-        <p:cNvGrpSpPr/>
-        <p:nvPr/>
-      </p:nvGrpSpPr>
-      <p:grpSpPr>
-        <a:xfrm>
-          <a:off x="0" y="0"/>
-          <a:ext cx="0" cy="0"/>
-          <a:chOff x="0" y="0"/>
-          <a:chExt cx="0" cy="0"/>
-        </a:xfrm>
-      </p:grpSpPr>
-      <p:pic>
-        <p:nvPicPr>
-          <p:cNvPr id="123" name="Google Shape;123;p25" title="summary_endo.jpg"/>
-          <p:cNvPicPr preferRelativeResize="0"/>
-          <p:nvPr/>
-        </p:nvPicPr>
-        <p:blipFill>
-          <a:blip r:embed="rId3">
-            <a:alphaModFix/>
-          </a:blip>
-          <a:stretch>
-            <a:fillRect/>
-          </a:stretch>
-        </p:blipFill>
-        <p:spPr>
-          <a:xfrm>
-            <a:off x="152400" y="152400"/>
-            <a:ext cx="5227448" cy="2613724"/>
-          </a:xfrm>
-          <a:prstGeom prst="rect">
-            <a:avLst/>
-          </a:prstGeom>
-          <a:noFill/>
-          <a:ln>
-            <a:noFill/>
-          </a:ln>
-        </p:spPr>
-      </p:pic>
-      <p:pic>
-        <p:nvPicPr>
-          <p:cNvPr id="124" name="Google Shape;124;p25" title="secuencia_crudo_vs_ajustado.jpg"/>
-          <p:cNvPicPr preferRelativeResize="0"/>
-          <p:nvPr/>
-        </p:nvPicPr>
-        <p:blipFill>
-          <a:blip r:embed="rId4">
-            <a:alphaModFix/>
-          </a:blip>
-          <a:stretch>
-            <a:fillRect/>
-          </a:stretch>
-        </p:blipFill>
-        <p:spPr>
-          <a:xfrm>
-            <a:off x="5532248" y="152400"/>
-            <a:ext cx="3459354" cy="2395197"/>
-          </a:xfrm>
-          <a:prstGeom prst="rect">
-            <a:avLst/>
-          </a:prstGeom>
-          <a:noFill/>
-          <a:ln>
-            <a:noFill/>
-          </a:ln>
-        </p:spPr>
-      </p:pic>
-    </p:spTree>
-  </p:cSld>
-  <p:clrMapOvr>
-    <a:masterClrMapping/>
-  </p:clrMapOvr>
-</p:sld>
-</file>
-
-<file path=ppt/slides/slide14.xml><?xml version="1.0" encoding="utf-8"?>
-<p:sld xmlns:a="http://schemas.openxmlformats.org/drawingml/2006/main" xmlns:r="http://schemas.openxmlformats.org/officeDocument/2006/relationships" xmlns:mc="http://schemas.openxmlformats.org/markup-compatibility/2006" xmlns:mv="urn:schemas-microsoft-com:mac:vml" xmlns:p="http://schemas.openxmlformats.org/presentationml/2006/main" xmlns:c="http://schemas.openxmlformats.org/drawingml/2006/chart" xmlns:dgm="http://schemas.openxmlformats.org/drawingml/2006/diagram" xmlns:o="urn:schemas-microsoft-com:office:office" xmlns:v="urn:schemas-microsoft-com:vml" xmlns:pvml="urn:schemas-microsoft-com:office:powerpoint" xmlns:com="http://schemas.openxmlformats.org/drawingml/2006/compatibility" xmlns:p14="http://schemas.microsoft.com/office/powerpoint/2010/main" xmlns:p15="http://schemas.microsoft.com/office/powerpoint/2012/main" xmlns:ahyp="http://schemas.microsoft.com/office/drawing/2018/hyperlinkcolor">
-  <p:cSld>
-    <p:spTree>
-      <p:nvGrpSpPr>
-        <p:cNvPr id="128" name="Shape 128"/>
-        <p:cNvGrpSpPr/>
-        <p:nvPr/>
-      </p:nvGrpSpPr>
-      <p:grpSpPr>
-        <a:xfrm>
-          <a:off x="0" y="0"/>
-          <a:ext cx="0" cy="0"/>
-          <a:chOff x="0" y="0"/>
-          <a:chExt cx="0" cy="0"/>
-        </a:xfrm>
-      </p:grpSpPr>
-      <p:pic>
-        <p:nvPicPr>
-          <p:cNvPr id="129" name="Google Shape;129;p26" title="remap_act.jpg"/>
-          <p:cNvPicPr preferRelativeResize="0"/>
-          <p:nvPr/>
-        </p:nvPicPr>
-        <p:blipFill>
-          <a:blip r:embed="rId3">
-            <a:alphaModFix/>
-          </a:blip>
-          <a:stretch>
-            <a:fillRect/>
-          </a:stretch>
-        </p:blipFill>
-        <p:spPr>
-          <a:xfrm>
-            <a:off x="184850" y="205750"/>
-            <a:ext cx="3154673" cy="2366001"/>
-          </a:xfrm>
-          <a:prstGeom prst="rect">
-            <a:avLst/>
-          </a:prstGeom>
-          <a:noFill/>
-          <a:ln>
-            <a:noFill/>
-          </a:ln>
-        </p:spPr>
-      </p:pic>
-      <p:pic>
-        <p:nvPicPr>
-          <p:cNvPr id="130" name="Google Shape;130;p26" title="remap_act_low.jpg"/>
-          <p:cNvPicPr preferRelativeResize="0"/>
-          <p:nvPr/>
-        </p:nvPicPr>
-        <p:blipFill>
-          <a:blip r:embed="rId4">
-            <a:alphaModFix/>
-          </a:blip>
-          <a:stretch>
-            <a:fillRect/>
-          </a:stretch>
-        </p:blipFill>
-        <p:spPr>
-          <a:xfrm>
-            <a:off x="5159224" y="-52348"/>
-            <a:ext cx="2235203" cy="1986362"/>
-          </a:xfrm>
-          <a:prstGeom prst="rect">
-            <a:avLst/>
-          </a:prstGeom>
-          <a:noFill/>
-          <a:ln>
-            <a:noFill/>
-          </a:ln>
-        </p:spPr>
-      </p:pic>
-      <p:pic>
-        <p:nvPicPr>
-          <p:cNvPr id="131" name="Google Shape;131;p26" title="GSEA_top_pathway_rep1.jpg"/>
-          <p:cNvPicPr preferRelativeResize="0"/>
-          <p:nvPr/>
-        </p:nvPicPr>
-        <p:blipFill>
-          <a:blip r:embed="rId5">
-            <a:alphaModFix/>
-          </a:blip>
-          <a:stretch>
-            <a:fillRect/>
-          </a:stretch>
-        </p:blipFill>
-        <p:spPr>
-          <a:xfrm>
-            <a:off x="4744150" y="2046525"/>
-            <a:ext cx="3154673" cy="2366001"/>
-          </a:xfrm>
-          <a:prstGeom prst="rect">
-            <a:avLst/>
-          </a:prstGeom>
-          <a:noFill/>
-          <a:ln>
-            <a:noFill/>
-          </a:ln>
-        </p:spPr>
-      </p:pic>
       <p:sp>
         <p:nvSpPr>
-          <p:cNvPr id="132" name="Google Shape;132;p26"/>
+          <p:cNvPr id="119" name="Google Shape;119;p25"/>
           <p:cNvSpPr txBox="1"/>
           <p:nvPr/>
         </p:nvSpPr>
@@ -7465,12 +7109,12 @@
 </p:sld>
 </file>
 
-<file path=ppt/slides/slide15.xml><?xml version="1.0" encoding="utf-8"?>
+<file path=ppt/slides/slide14.xml><?xml version="1.0" encoding="utf-8"?>
 <p:sld xmlns:a="http://schemas.openxmlformats.org/drawingml/2006/main" xmlns:r="http://schemas.openxmlformats.org/officeDocument/2006/relationships" xmlns:mc="http://schemas.openxmlformats.org/markup-compatibility/2006" xmlns:mv="urn:schemas-microsoft-com:mac:vml" xmlns:p="http://schemas.openxmlformats.org/presentationml/2006/main" xmlns:c="http://schemas.openxmlformats.org/drawingml/2006/chart" xmlns:dgm="http://schemas.openxmlformats.org/drawingml/2006/diagram" xmlns:o="urn:schemas-microsoft-com:office:office" xmlns:v="urn:schemas-microsoft-com:vml" xmlns:pvml="urn:schemas-microsoft-com:office:powerpoint" xmlns:com="http://schemas.openxmlformats.org/drawingml/2006/compatibility" xmlns:p14="http://schemas.microsoft.com/office/powerpoint/2010/main" xmlns:p15="http://schemas.microsoft.com/office/powerpoint/2012/main" xmlns:ahyp="http://schemas.microsoft.com/office/drawing/2018/hyperlinkcolor">
   <p:cSld>
     <p:spTree>
       <p:nvGrpSpPr>
-        <p:cNvPr id="136" name="Shape 136"/>
+        <p:cNvPr id="123" name="Shape 123"/>
         <p:cNvGrpSpPr/>
         <p:nvPr/>
       </p:nvGrpSpPr>
@@ -7484,7 +7128,7 @@
       </p:grpSpPr>
       <p:pic>
         <p:nvPicPr>
-          <p:cNvPr id="137" name="Google Shape;137;p27" title="nfya_scatter_intersect.jpg"/>
+          <p:cNvPr id="124" name="Google Shape;124;p26" title="nfya_scatter_intersect.jpg"/>
           <p:cNvPicPr preferRelativeResize="0"/>
           <p:nvPr/>
         </p:nvPicPr>
@@ -7512,7 +7156,7 @@
       </p:pic>
       <p:pic>
         <p:nvPicPr>
-          <p:cNvPr id="138" name="Google Shape;138;p27" title="tf_efecto_vs_cobertura.jpg"/>
+          <p:cNvPr id="125" name="Google Shape;125;p26" title="tf_efecto_vs_cobertura.jpg"/>
           <p:cNvPicPr preferRelativeResize="0"/>
           <p:nvPr/>
         </p:nvPicPr>
@@ -7540,7 +7184,7 @@
       </p:pic>
       <p:pic>
         <p:nvPicPr>
-          <p:cNvPr id="139" name="Google Shape;139;p27" title="tf_especificidad_ccaat.jpg"/>
+          <p:cNvPr id="126" name="Google Shape;126;p26" title="tf_especificidad_ccaat.jpg"/>
           <p:cNvPicPr preferRelativeResize="0"/>
           <p:nvPr/>
         </p:nvPicPr>
@@ -7568,7 +7212,7 @@
       </p:pic>
       <p:sp>
         <p:nvSpPr>
-          <p:cNvPr id="140" name="Google Shape;140;p27"/>
+          <p:cNvPr id="127" name="Google Shape;127;p26"/>
           <p:cNvSpPr txBox="1"/>
           <p:nvPr/>
         </p:nvSpPr>
@@ -7914,159 +7558,9 @@
           <a:chExt cx="0" cy="0"/>
         </a:xfrm>
       </p:grpSpPr>
-      <p:sp>
-        <p:nvSpPr>
-          <p:cNvPr id="80" name="Google Shape;80;p18"/>
-          <p:cNvSpPr txBox="1"/>
-          <p:nvPr/>
-        </p:nvSpPr>
-        <p:spPr>
-          <a:xfrm>
-            <a:off x="0" y="3238150"/>
-            <a:ext cx="7238400" cy="2039400"/>
-          </a:xfrm>
-          <a:prstGeom prst="rect">
-            <a:avLst/>
-          </a:prstGeom>
-          <a:noFill/>
-          <a:ln>
-            <a:noFill/>
-          </a:ln>
-        </p:spPr>
-        <p:txBody>
-          <a:bodyPr anchorCtr="0" anchor="t" bIns="91425" lIns="91425" spcFirstLastPara="1" rIns="91425" wrap="square" tIns="91425">
-            <a:spAutoFit/>
-          </a:bodyPr>
-          <a:lstStyle/>
-          <a:p>
-            <a:pPr indent="0" lvl="0" marL="0" rtl="0" algn="l">
-              <a:lnSpc>
-                <a:spcPct val="115000"/>
-              </a:lnSpc>
-              <a:spcBef>
-                <a:spcPts val="1200"/>
-              </a:spcBef>
-              <a:spcAft>
-                <a:spcPts val="0"/>
-              </a:spcAft>
-              <a:buNone/>
-            </a:pPr>
-            <a:r>
-              <a:rPr b="1" lang="es-419" sz="1000">
-                <a:solidFill>
-                  <a:schemeClr val="dk1"/>
-                </a:solidFill>
-              </a:rPr>
-              <a:t>Asociación de la CCAAT-box y la GC-box con la actividad transcripcional.</a:t>
-            </a:r>
-            <a:endParaRPr b="1" sz="1000">
-              <a:solidFill>
-                <a:schemeClr val="dk1"/>
-              </a:solidFill>
-            </a:endParaRPr>
-          </a:p>
-          <a:p>
-            <a:pPr indent="0" lvl="0" marL="0" rtl="0" algn="l">
-              <a:lnSpc>
-                <a:spcPct val="115000"/>
-              </a:lnSpc>
-              <a:spcBef>
-                <a:spcPts val="1200"/>
-              </a:spcBef>
-              <a:spcAft>
-                <a:spcPts val="0"/>
-              </a:spcAft>
-              <a:buNone/>
-            </a:pPr>
-            <a:r>
-              <a:rPr b="1" lang="es-419" sz="1000">
-                <a:solidFill>
-                  <a:schemeClr val="dk1"/>
-                </a:solidFill>
-              </a:rPr>
-              <a:t>(A)</a:t>
-            </a:r>
-            <a:r>
-              <a:rPr lang="es-419" sz="1000">
-                <a:solidFill>
-                  <a:schemeClr val="dk1"/>
-                </a:solidFill>
-              </a:rPr>
-              <a:t> CCAAT-box. Izquierda: proporción de promotores con CCAAT-box en grupos de 100 promotores ordenados por actividad media, para cada réplica, con una curva suavizada. Derecha: distribución de la actividad media de los promotores sin el motivo (Ausencia) y con él (Presencia), para las réplicas 1 y 2.</a:t>
-            </a:r>
-            <a:endParaRPr sz="1000">
-              <a:solidFill>
-                <a:schemeClr val="dk1"/>
-              </a:solidFill>
-            </a:endParaRPr>
-          </a:p>
-          <a:p>
-            <a:pPr indent="0" lvl="0" marL="0" rtl="0" algn="l">
-              <a:lnSpc>
-                <a:spcPct val="115000"/>
-              </a:lnSpc>
-              <a:spcBef>
-                <a:spcPts val="1200"/>
-              </a:spcBef>
-              <a:spcAft>
-                <a:spcPts val="0"/>
-              </a:spcAft>
-              <a:buNone/>
-            </a:pPr>
-            <a:r>
-              <a:rPr b="1" lang="es-419" sz="1000">
-                <a:solidFill>
-                  <a:schemeClr val="dk1"/>
-                </a:solidFill>
-              </a:rPr>
-              <a:t>(B)</a:t>
-            </a:r>
-            <a:r>
-              <a:rPr lang="es-419" sz="1000">
-                <a:solidFill>
-                  <a:schemeClr val="dk1"/>
-                </a:solidFill>
-              </a:rPr>
-              <a:t> Lo mismo para la GC-box.</a:t>
-            </a:r>
-            <a:endParaRPr sz="1000">
-              <a:solidFill>
-                <a:schemeClr val="dk1"/>
-              </a:solidFill>
-            </a:endParaRPr>
-          </a:p>
-          <a:p>
-            <a:pPr indent="0" lvl="0" marL="0" rtl="0" algn="l">
-              <a:lnSpc>
-                <a:spcPct val="115000"/>
-              </a:lnSpc>
-              <a:spcBef>
-                <a:spcPts val="1200"/>
-              </a:spcBef>
-              <a:spcAft>
-                <a:spcPts val="1200"/>
-              </a:spcAft>
-              <a:buNone/>
-            </a:pPr>
-            <a:r>
-              <a:rPr lang="es-419" sz="1000">
-                <a:solidFill>
-                  <a:schemeClr val="dk1"/>
-                </a:solidFill>
-              </a:rPr>
-              <a:t>En todos los casos, la presencia del motivo corresponde a la anotación de EPD. Las diferencias entre grupos se evaluaron con el test de Wilcoxon (p &lt; 2,2×10⁻¹⁶ en ambos motivos y réplicas); el tamaño del efecto (estimador de Hodges-Lehmann) se informa en el texto.</a:t>
-            </a:r>
-            <a:endParaRPr sz="1000">
-              <a:solidFill>
-                <a:schemeClr val="dk1"/>
-              </a:solidFill>
-            </a:endParaRPr>
-          </a:p>
-        </p:txBody>
-      </p:sp>
       <p:pic>
         <p:nvPicPr>
-          <p:cNvPr id="81" name="Google Shape;81;p18" title="ccaat_gcbox_actividad.jpg"/>
+          <p:cNvPr id="80" name="Google Shape;80;p18" title="ccaat_gcbox_actividad.jpg"/>
           <p:cNvPicPr preferRelativeResize="0"/>
           <p:nvPr/>
         </p:nvPicPr>
@@ -8081,7 +7575,7 @@
         <p:spPr>
           <a:xfrm>
             <a:off x="152400" y="152400"/>
-            <a:ext cx="1760297" cy="2933350"/>
+            <a:ext cx="6853156" cy="4838703"/>
           </a:xfrm>
           <a:prstGeom prst="rect">
             <a:avLst/>
@@ -8105,7 +7599,7 @@
   <p:cSld>
     <p:spTree>
       <p:nvGrpSpPr>
-        <p:cNvPr id="85" name="Shape 85"/>
+        <p:cNvPr id="84" name="Shape 84"/>
         <p:cNvGrpSpPr/>
         <p:nvPr/>
       </p:nvGrpSpPr>
@@ -8119,7 +7613,7 @@
       </p:grpSpPr>
       <p:pic>
         <p:nvPicPr>
-          <p:cNvPr id="86" name="Google Shape;86;p19" title="ccaat_gcbox_prevalencia_cgi.jpg"/>
+          <p:cNvPr id="85" name="Google Shape;85;p19" title="tss_perfil_efectos_promotor_hl.jpg"/>
           <p:cNvPicPr preferRelativeResize="0"/>
           <p:nvPr/>
         </p:nvPicPr>
@@ -8133,8 +7627,8 @@
         </p:blipFill>
         <p:spPr>
           <a:xfrm>
-            <a:off x="0" y="526575"/>
-            <a:ext cx="3988301" cy="2243425"/>
+            <a:off x="152400" y="152400"/>
+            <a:ext cx="8469796" cy="4838702"/>
           </a:xfrm>
           <a:prstGeom prst="rect">
             <a:avLst/>
@@ -8145,173 +7639,6 @@
           </a:ln>
         </p:spPr>
       </p:pic>
-      <p:pic>
-        <p:nvPicPr>
-          <p:cNvPr id="87" name="Google Shape;87;p19" title="ccaat_gcbox_efecto_cgi.jpg"/>
-          <p:cNvPicPr preferRelativeResize="0"/>
-          <p:nvPr/>
-        </p:nvPicPr>
-        <p:blipFill>
-          <a:blip r:embed="rId4">
-            <a:alphaModFix/>
-          </a:blip>
-          <a:stretch>
-            <a:fillRect/>
-          </a:stretch>
-        </p:blipFill>
-        <p:spPr>
-          <a:xfrm>
-            <a:off x="4096770" y="170720"/>
-            <a:ext cx="4837873" cy="2763824"/>
-          </a:xfrm>
-          <a:prstGeom prst="rect">
-            <a:avLst/>
-          </a:prstGeom>
-          <a:noFill/>
-          <a:ln>
-            <a:noFill/>
-          </a:ln>
-        </p:spPr>
-      </p:pic>
-      <p:sp>
-        <p:nvSpPr>
-          <p:cNvPr id="88" name="Google Shape;88;p19"/>
-          <p:cNvSpPr txBox="1"/>
-          <p:nvPr/>
-        </p:nvSpPr>
-        <p:spPr>
-          <a:xfrm>
-            <a:off x="750300" y="3080150"/>
-            <a:ext cx="6705300" cy="1885500"/>
-          </a:xfrm>
-          <a:prstGeom prst="rect">
-            <a:avLst/>
-          </a:prstGeom>
-          <a:noFill/>
-          <a:ln>
-            <a:noFill/>
-          </a:ln>
-        </p:spPr>
-        <p:txBody>
-          <a:bodyPr anchorCtr="0" anchor="t" bIns="91425" lIns="91425" spcFirstLastPara="1" rIns="91425" wrap="square" tIns="91425">
-            <a:spAutoFit/>
-          </a:bodyPr>
-          <a:lstStyle/>
-          <a:p>
-            <a:pPr indent="0" lvl="0" marL="0" rtl="0" algn="l">
-              <a:lnSpc>
-                <a:spcPct val="115000"/>
-              </a:lnSpc>
-              <a:spcBef>
-                <a:spcPts val="1200"/>
-              </a:spcBef>
-              <a:spcAft>
-                <a:spcPts val="0"/>
-              </a:spcAft>
-              <a:buNone/>
-            </a:pPr>
-            <a:r>
-              <a:rPr b="1" lang="es-419" sz="1000">
-                <a:solidFill>
-                  <a:schemeClr val="dk1"/>
-                </a:solidFill>
-              </a:rPr>
-              <a:t>Relación de la CCAAT-box y la GC-box con las islas CpG.</a:t>
-            </a:r>
-            <a:endParaRPr b="1" sz="1000">
-              <a:solidFill>
-                <a:schemeClr val="dk1"/>
-              </a:solidFill>
-            </a:endParaRPr>
-          </a:p>
-          <a:p>
-            <a:pPr indent="0" lvl="0" marL="0" rtl="0" algn="l">
-              <a:lnSpc>
-                <a:spcPct val="115000"/>
-              </a:lnSpc>
-              <a:spcBef>
-                <a:spcPts val="1200"/>
-              </a:spcBef>
-              <a:spcAft>
-                <a:spcPts val="0"/>
-              </a:spcAft>
-              <a:buNone/>
-            </a:pPr>
-            <a:r>
-              <a:rPr b="1" lang="es-419" sz="1000">
-                <a:solidFill>
-                  <a:schemeClr val="dk1"/>
-                </a:solidFill>
-              </a:rPr>
-              <a:t>(A)</a:t>
-            </a:r>
-            <a:r>
-              <a:rPr lang="es-419" sz="1000">
-                <a:solidFill>
-                  <a:schemeClr val="dk1"/>
-                </a:solidFill>
-              </a:rPr>
-              <a:t> Porcentaje de promotores de la </a:t>
-            </a:r>
-            <a:r>
-              <a:rPr i="1" lang="es-419" sz="1000">
-                <a:solidFill>
-                  <a:schemeClr val="dk1"/>
-                </a:solidFill>
-              </a:rPr>
-              <a:t>library</a:t>
-            </a:r>
-            <a:r>
-              <a:rPr lang="es-419" sz="1000">
-                <a:solidFill>
-                  <a:schemeClr val="dk1"/>
-                </a:solidFill>
-              </a:rPr>
-              <a:t> con CCAAT-box y con GC-box, entre los que tienen isla CpG (n = 13.886) y los que no (n = 6.965). La isla CpG se definió por la composición del fragmento (G+C ≥ 50% y razón CpG observado/esperado &gt; 0,6).</a:t>
-            </a:r>
-            <a:endParaRPr sz="1000">
-              <a:solidFill>
-                <a:schemeClr val="dk1"/>
-              </a:solidFill>
-            </a:endParaRPr>
-          </a:p>
-          <a:p>
-            <a:pPr indent="0" lvl="0" marL="0" rtl="0" algn="l">
-              <a:lnSpc>
-                <a:spcPct val="115000"/>
-              </a:lnSpc>
-              <a:spcBef>
-                <a:spcPts val="1200"/>
-              </a:spcBef>
-              <a:spcAft>
-                <a:spcPts val="1200"/>
-              </a:spcAft>
-              <a:buNone/>
-            </a:pPr>
-            <a:r>
-              <a:rPr b="1" lang="es-419" sz="1000">
-                <a:solidFill>
-                  <a:schemeClr val="dk1"/>
-                </a:solidFill>
-              </a:rPr>
-              <a:t>(B)</a:t>
-            </a:r>
-            <a:r>
-              <a:rPr lang="es-419" sz="1000">
-                <a:solidFill>
-                  <a:schemeClr val="dk1"/>
-                </a:solidFill>
-              </a:rPr>
-              <a:t> Diferencia de actividad media entre promotores con y sin cada motivo (estimador de Hodges-Lehmann con IC 95%), calculada sobre todos los promotores y por separado en los promotores con y sin isla CpG, para cada réplica. Junto a cada punto se indica el número de promotores con el motivo. La línea punteada marca la ausencia de efecto.</a:t>
-            </a:r>
-            <a:endParaRPr sz="1000">
-              <a:solidFill>
-                <a:schemeClr val="dk1"/>
-              </a:solidFill>
-            </a:endParaRPr>
-          </a:p>
-        </p:txBody>
-      </p:sp>
     </p:spTree>
   </p:cSld>
   <p:clrMapOvr>
@@ -8325,7 +7652,7 @@
   <p:cSld>
     <p:spTree>
       <p:nvGrpSpPr>
-        <p:cNvPr id="92" name="Shape 92"/>
+        <p:cNvPr id="89" name="Shape 89"/>
         <p:cNvGrpSpPr/>
         <p:nvPr/>
       </p:nvGrpSpPr>
@@ -8339,7 +7666,7 @@
       </p:grpSpPr>
       <p:pic>
         <p:nvPicPr>
-          <p:cNvPr id="93" name="Google Shape;93;p20" title="tss_perfil_efectos_promotor_hl.jpg"/>
+          <p:cNvPr id="90" name="Google Shape;90;p20" title="tss_perfil_YR_todos.jpg"/>
           <p:cNvPicPr preferRelativeResize="0"/>
           <p:nvPr/>
         </p:nvPicPr>
@@ -8353,8 +7680,36 @@
         </p:blipFill>
         <p:spPr>
           <a:xfrm>
-            <a:off x="152400" y="152400"/>
-            <a:ext cx="8469796" cy="4838702"/>
+            <a:off x="152400" y="3111501"/>
+            <a:ext cx="5012301" cy="1879599"/>
+          </a:xfrm>
+          <a:prstGeom prst="rect">
+            <a:avLst/>
+          </a:prstGeom>
+          <a:noFill/>
+          <a:ln>
+            <a:noFill/>
+          </a:ln>
+        </p:spPr>
+      </p:pic>
+      <p:pic>
+        <p:nvPicPr>
+          <p:cNvPr id="91" name="Google Shape;91;p20" title="tss_modelo.jpg"/>
+          <p:cNvPicPr preferRelativeResize="0"/>
+          <p:nvPr/>
+        </p:nvPicPr>
+        <p:blipFill>
+          <a:blip r:embed="rId4">
+            <a:alphaModFix/>
+          </a:blip>
+          <a:stretch>
+            <a:fillRect/>
+          </a:stretch>
+        </p:blipFill>
+        <p:spPr>
+          <a:xfrm>
+            <a:off x="646976" y="609872"/>
+            <a:ext cx="3674501" cy="2004110"/>
           </a:xfrm>
           <a:prstGeom prst="rect">
             <a:avLst/>
@@ -8378,7 +7733,7 @@
   <p:cSld>
     <p:spTree>
       <p:nvGrpSpPr>
-        <p:cNvPr id="97" name="Shape 97"/>
+        <p:cNvPr id="95" name="Shape 95"/>
         <p:cNvGrpSpPr/>
         <p:nvPr/>
       </p:nvGrpSpPr>
@@ -8392,7 +7747,7 @@
       </p:grpSpPr>
       <p:pic>
         <p:nvPicPr>
-          <p:cNvPr id="98" name="Google Shape;98;p21" title="tss_perfil_YR_todos.jpg"/>
+          <p:cNvPr id="96" name="Google Shape;96;p21" title="motivos_de_novo.jpg"/>
           <p:cNvPicPr preferRelativeResize="0"/>
           <p:nvPr/>
         </p:nvPicPr>
@@ -8406,36 +7761,8 @@
         </p:blipFill>
         <p:spPr>
           <a:xfrm>
-            <a:off x="152400" y="3111501"/>
-            <a:ext cx="5012301" cy="1879599"/>
-          </a:xfrm>
-          <a:prstGeom prst="rect">
-            <a:avLst/>
-          </a:prstGeom>
-          <a:noFill/>
-          <a:ln>
-            <a:noFill/>
-          </a:ln>
-        </p:spPr>
-      </p:pic>
-      <p:pic>
-        <p:nvPicPr>
-          <p:cNvPr id="99" name="Google Shape;99;p21" title="tss_modelo.jpg"/>
-          <p:cNvPicPr preferRelativeResize="0"/>
-          <p:nvPr/>
-        </p:nvPicPr>
-        <p:blipFill>
-          <a:blip r:embed="rId4">
-            <a:alphaModFix/>
-          </a:blip>
-          <a:stretch>
-            <a:fillRect/>
-          </a:stretch>
-        </p:blipFill>
-        <p:spPr>
-          <a:xfrm>
-            <a:off x="646976" y="609872"/>
-            <a:ext cx="3674501" cy="2004110"/>
+            <a:off x="152400" y="0"/>
+            <a:ext cx="3258343" cy="4991099"/>
           </a:xfrm>
           <a:prstGeom prst="rect">
             <a:avLst/>

</xml_diff>

<commit_message>
docs: resync figure numbering from Drive decks (2026-10-27)
Changed decks: Fig R2 (Fig MyM, Fig R1, Fig R3: export noise only).
No slug number changes: all 14 Fig R2 slides still match their slugs
(cgi_actividad .. nfy_especificidad).
cgi_actividad: slide now uses the composite cgi_actividad.jpg (matches),
so the scatter-image mismatch was dropped from the Revisar note.

Co-Authored-By: Claude Opus 5.5 <noreply@anthropic.com>
</commit_message>
<xml_diff>
--- a/docs/Fig R2.pptx
+++ b/docs/Fig R2.pptx
@@ -1199,7 +1199,7 @@
   <p:cSld>
     <p:spTree>
       <p:nvGrpSpPr>
-        <p:cNvPr id="120" name="Shape 120"/>
+        <p:cNvPr id="117" name="Shape 117"/>
         <p:cNvGrpSpPr/>
         <p:nvPr/>
       </p:nvGrpSpPr>
@@ -1213,7 +1213,7 @@
       </p:grpSpPr>
       <p:sp>
         <p:nvSpPr>
-          <p:cNvPr id="121" name="Google Shape;121;g3f58eefa86d_0_108:notes"/>
+          <p:cNvPr id="118" name="Google Shape;118;g3f58eefa86d_0_108:notes"/>
           <p:cNvSpPr/>
           <p:nvPr>
             <p:ph idx="2" type="sldImg"/>
@@ -1248,7 +1248,7 @@
       </p:sp>
       <p:sp>
         <p:nvSpPr>
-          <p:cNvPr id="122" name="Google Shape;122;g3f58eefa86d_0_108:notes"/>
+          <p:cNvPr id="119" name="Google Shape;119;g3f58eefa86d_0_108:notes"/>
           <p:cNvSpPr txBox="1"/>
           <p:nvPr>
             <p:ph idx="1" type="body"/>
@@ -6965,7 +6965,7 @@
       </p:grpSpPr>
       <p:pic>
         <p:nvPicPr>
-          <p:cNvPr id="116" name="Google Shape;116;p25" title="remap_act.jpg"/>
+          <p:cNvPr id="116" name="Google Shape;116;p25" title="remap_tf_activity_gsea.jpg"/>
           <p:cNvPicPr preferRelativeResize="0"/>
           <p:nvPr/>
         </p:nvPicPr>
@@ -6979,8 +6979,8 @@
         </p:blipFill>
         <p:spPr>
           <a:xfrm>
-            <a:off x="184850" y="205750"/>
-            <a:ext cx="3154673" cy="2366001"/>
+            <a:off x="152400" y="152400"/>
+            <a:ext cx="5678889" cy="4838702"/>
           </a:xfrm>
           <a:prstGeom prst="rect">
             <a:avLst/>
@@ -6991,116 +6991,6 @@
           </a:ln>
         </p:spPr>
       </p:pic>
-      <p:pic>
-        <p:nvPicPr>
-          <p:cNvPr id="117" name="Google Shape;117;p25" title="remap_act_low.jpg"/>
-          <p:cNvPicPr preferRelativeResize="0"/>
-          <p:nvPr/>
-        </p:nvPicPr>
-        <p:blipFill>
-          <a:blip r:embed="rId4">
-            <a:alphaModFix/>
-          </a:blip>
-          <a:stretch>
-            <a:fillRect/>
-          </a:stretch>
-        </p:blipFill>
-        <p:spPr>
-          <a:xfrm>
-            <a:off x="5159224" y="-52348"/>
-            <a:ext cx="2235203" cy="1986362"/>
-          </a:xfrm>
-          <a:prstGeom prst="rect">
-            <a:avLst/>
-          </a:prstGeom>
-          <a:noFill/>
-          <a:ln>
-            <a:noFill/>
-          </a:ln>
-        </p:spPr>
-      </p:pic>
-      <p:pic>
-        <p:nvPicPr>
-          <p:cNvPr id="118" name="Google Shape;118;p25" title="GSEA_top_pathway_rep1.jpg"/>
-          <p:cNvPicPr preferRelativeResize="0"/>
-          <p:nvPr/>
-        </p:nvPicPr>
-        <p:blipFill>
-          <a:blip r:embed="rId5">
-            <a:alphaModFix/>
-          </a:blip>
-          <a:stretch>
-            <a:fillRect/>
-          </a:stretch>
-        </p:blipFill>
-        <p:spPr>
-          <a:xfrm>
-            <a:off x="4744150" y="2046525"/>
-            <a:ext cx="3154673" cy="2366001"/>
-          </a:xfrm>
-          <a:prstGeom prst="rect">
-            <a:avLst/>
-          </a:prstGeom>
-          <a:noFill/>
-          <a:ln>
-            <a:noFill/>
-          </a:ln>
-        </p:spPr>
-      </p:pic>
-      <p:sp>
-        <p:nvSpPr>
-          <p:cNvPr id="119" name="Google Shape;119;p25"/>
-          <p:cNvSpPr txBox="1"/>
-          <p:nvPr/>
-        </p:nvSpPr>
-        <p:spPr>
-          <a:xfrm>
-            <a:off x="0" y="2809825"/>
-            <a:ext cx="4366500" cy="1985700"/>
-          </a:xfrm>
-          <a:prstGeom prst="rect">
-            <a:avLst/>
-          </a:prstGeom>
-          <a:noFill/>
-          <a:ln>
-            <a:noFill/>
-          </a:ln>
-        </p:spPr>
-        <p:txBody>
-          <a:bodyPr anchorCtr="0" anchor="t" bIns="91425" lIns="91425" spcFirstLastPara="1" rIns="91425" wrap="square" tIns="91425">
-            <a:spAutoFit/>
-          </a:bodyPr>
-          <a:lstStyle/>
-          <a:p>
-            <a:pPr indent="0" lvl="0" marL="0" rtl="0" algn="l">
-              <a:spcBef>
-                <a:spcPts val="0"/>
-              </a:spcBef>
-              <a:spcAft>
-                <a:spcPts val="0"/>
-              </a:spcAft>
-              <a:buNone/>
-            </a:pPr>
-            <a:r>
-              <a:rPr b="1" lang="es-419" sz="900">
-                <a:solidFill>
-                  <a:schemeClr val="dk1"/>
-                </a:solidFill>
-              </a:rPr>
-              <a:t>Figura R2.14. La ocupación de factores de transcripción en el contexto endógeno se asocia con la actividad en el reportero.</a:t>
-            </a:r>
-            <a:r>
-              <a:rPr lang="es-419" sz="900">
-                <a:solidFill>
-                  <a:schemeClr val="dk1"/>
-                </a:solidFill>
-              </a:rPr>
-              <a:t> (A) Efecto de la unión de cada uno de los 986 factores de ReMap sobre la actividad media en el reportero (estimador de Hodges-Lehmann), para las réplicas 1 (color sólido) y 2 (color claro). En naranja se muestran los factores asociados con mayor actividad y en verde, los asociados con menor actividad. (B) Detalle de los factores asociados con menor actividad [criterio], con el estimador de Hodges-Lehmann y su intervalo de confianza del 95% para cada réplica. (C) Análisis de enriquecimiento de conjuntos (GSEA) del término de Gene Ontology «actividad de factor general de iniciación de la transcripción de la RNA polimerasa II» (GO:0016251), con los factores ordenados según su efecto sobre la actividad en la réplica 1. Arriba se muestra el puntaje de enriquecimiento acumulado; abajo, el efecto de cada factor, con los miembros del término marcados en rojo oscuro. </a:t>
-            </a:r>
-            <a:endParaRPr sz="900"/>
-          </a:p>
-        </p:txBody>
-      </p:sp>
     </p:spTree>
   </p:cSld>
   <p:clrMapOvr>
@@ -7114,7 +7004,7 @@
   <p:cSld>
     <p:spTree>
       <p:nvGrpSpPr>
-        <p:cNvPr id="123" name="Shape 123"/>
+        <p:cNvPr id="120" name="Shape 120"/>
         <p:cNvGrpSpPr/>
         <p:nvPr/>
       </p:nvGrpSpPr>
@@ -7128,7 +7018,7 @@
       </p:grpSpPr>
       <p:pic>
         <p:nvPicPr>
-          <p:cNvPr id="124" name="Google Shape;124;p26" title="nfya_scatter_intersect.jpg"/>
+          <p:cNvPr id="121" name="Google Shape;121;p26" title="nfy_especificidad.jpg"/>
           <p:cNvPicPr preferRelativeResize="0"/>
           <p:nvPr/>
         </p:nvPicPr>
@@ -7142,8 +7032,8 @@
         </p:blipFill>
         <p:spPr>
           <a:xfrm>
-            <a:off x="0" y="0"/>
-            <a:ext cx="3225800" cy="2419350"/>
+            <a:off x="152400" y="152400"/>
+            <a:ext cx="7445274" cy="4838701"/>
           </a:xfrm>
           <a:prstGeom prst="rect">
             <a:avLst/>
@@ -7154,116 +7044,6 @@
           </a:ln>
         </p:spPr>
       </p:pic>
-      <p:pic>
-        <p:nvPicPr>
-          <p:cNvPr id="125" name="Google Shape;125;p26" title="tf_efecto_vs_cobertura.jpg"/>
-          <p:cNvPicPr preferRelativeResize="0"/>
-          <p:nvPr/>
-        </p:nvPicPr>
-        <p:blipFill>
-          <a:blip r:embed="rId4">
-            <a:alphaModFix/>
-          </a:blip>
-          <a:stretch>
-            <a:fillRect/>
-          </a:stretch>
-        </p:blipFill>
-        <p:spPr>
-          <a:xfrm>
-            <a:off x="3485400" y="0"/>
-            <a:ext cx="5613404" cy="3039680"/>
-          </a:xfrm>
-          <a:prstGeom prst="rect">
-            <a:avLst/>
-          </a:prstGeom>
-          <a:noFill/>
-          <a:ln>
-            <a:noFill/>
-          </a:ln>
-        </p:spPr>
-      </p:pic>
-      <p:pic>
-        <p:nvPicPr>
-          <p:cNvPr id="126" name="Google Shape;126;p26" title="tf_especificidad_ccaat.jpg"/>
-          <p:cNvPicPr preferRelativeResize="0"/>
-          <p:nvPr/>
-        </p:nvPicPr>
-        <p:blipFill>
-          <a:blip r:embed="rId5">
-            <a:alphaModFix/>
-          </a:blip>
-          <a:stretch>
-            <a:fillRect/>
-          </a:stretch>
-        </p:blipFill>
-        <p:spPr>
-          <a:xfrm>
-            <a:off x="52350" y="2497122"/>
-            <a:ext cx="3730524" cy="2542873"/>
-          </a:xfrm>
-          <a:prstGeom prst="rect">
-            <a:avLst/>
-          </a:prstGeom>
-          <a:noFill/>
-          <a:ln>
-            <a:noFill/>
-          </a:ln>
-        </p:spPr>
-      </p:pic>
-      <p:sp>
-        <p:nvSpPr>
-          <p:cNvPr id="127" name="Google Shape;127;p26"/>
-          <p:cNvSpPr txBox="1"/>
-          <p:nvPr/>
-        </p:nvSpPr>
-        <p:spPr>
-          <a:xfrm>
-            <a:off x="4055400" y="3304900"/>
-            <a:ext cx="5088600" cy="1569900"/>
-          </a:xfrm>
-          <a:prstGeom prst="rect">
-            <a:avLst/>
-          </a:prstGeom>
-          <a:noFill/>
-          <a:ln>
-            <a:noFill/>
-          </a:ln>
-        </p:spPr>
-        <p:txBody>
-          <a:bodyPr anchorCtr="0" anchor="t" bIns="91425" lIns="91425" spcFirstLastPara="1" rIns="91425" wrap="square" tIns="91425">
-            <a:spAutoFit/>
-          </a:bodyPr>
-          <a:lstStyle/>
-          <a:p>
-            <a:pPr indent="0" lvl="0" marL="0" rtl="0" algn="l">
-              <a:spcBef>
-                <a:spcPts val="0"/>
-              </a:spcBef>
-              <a:spcAft>
-                <a:spcPts val="0"/>
-              </a:spcAft>
-              <a:buNone/>
-            </a:pPr>
-            <a:r>
-              <a:rPr b="1" lang="es-419" sz="900">
-                <a:solidFill>
-                  <a:schemeClr val="dk1"/>
-                </a:solidFill>
-              </a:rPr>
-              <a:t>Figura R2.15. La unión de NF-YA se asocia con la actividad de forma específica y dependiente de la CCAAT-box.</a:t>
-            </a:r>
-            <a:r>
-              <a:rPr lang="es-419" sz="900">
-                <a:solidFill>
-                  <a:schemeClr val="dk1"/>
-                </a:solidFill>
-              </a:rPr>
-              <a:t> (A) Proporción de promotores unidos por NF-YA (picos en HeLa-S3, Hep-G2 y K-562) en grupos de 100 promotores ordenados por su actividad media en el reportero, para cada réplica. (B) Efecto de la unión de cada factor de ReMap sobre la actividad (estimador de Hodges-Lehmann) en función del número de promotores que une, para cada réplica. El punto naranja indica NF-YA, y la franja sombreada, los factores con un número de promotores unidos dentro de ±25% del de NF-YA. (C) Distribución de la diferencia entre el efecto de la unión de cada factor en los promotores con CCAAT-box y en los que no la tienen, para todos los factores (gris) y para los de cobertura similar a NF-YA (naranja). La línea vertical indica el valor de NF-YA. </a:t>
-            </a:r>
-            <a:endParaRPr sz="900"/>
-          </a:p>
-        </p:txBody>
-      </p:sp>
     </p:spTree>
   </p:cSld>
   <p:clrMapOvr>

</xml_diff>